<commit_message>
Refine final report metrics and transformer sections
</commit_message>
<xml_diff>
--- a/presentation/analiza_sentimenta_recenzija.pptx
+++ b/presentation/analiza_sentimenta_recenzija.pptx
@@ -2,24 +2,24 @@
 <file path=ppt/presentation.xml><?xml version="1.0" encoding="utf-8"?>
 <p:presentation xmlns:p="http://schemas.openxmlformats.org/presentationml/2006/main">
   <p:sldMasterIdLst>
-    <p:sldMasterId xmlns:r="http://schemas.openxmlformats.org/officeDocument/2006/relationships" id="2147483648" r:id="R02db2f8d083c4125"/>
+    <p:sldMasterId xmlns:r="http://schemas.openxmlformats.org/officeDocument/2006/relationships" id="2147483648" r:id="Reeb38266d4954036"/>
   </p:sldMasterIdLst>
   <p:notesMasterIdLst>
-    <p:notesMasterId xmlns:r="http://schemas.openxmlformats.org/officeDocument/2006/relationships" r:id="Rb6375ceda7af40d2"/>
+    <p:notesMasterId xmlns:r="http://schemas.openxmlformats.org/officeDocument/2006/relationships" r:id="Rad94ac0cca034dd4"/>
   </p:notesMasterIdLst>
   <p:sldIdLst>
-    <p:sldId xmlns:r="http://schemas.openxmlformats.org/officeDocument/2006/relationships" id="256" r:id="Re8f484bd90b04a14"/>
-    <p:sldId xmlns:r="http://schemas.openxmlformats.org/officeDocument/2006/relationships" id="257" r:id="R7887a47f88f04987"/>
-    <p:sldId xmlns:r="http://schemas.openxmlformats.org/officeDocument/2006/relationships" id="258" r:id="R8dcaadc201a54671"/>
-    <p:sldId xmlns:r="http://schemas.openxmlformats.org/officeDocument/2006/relationships" id="259" r:id="R797d6b4a7ad04924"/>
-    <p:sldId xmlns:r="http://schemas.openxmlformats.org/officeDocument/2006/relationships" id="260" r:id="R58b75066c7ff405a"/>
-    <p:sldId xmlns:r="http://schemas.openxmlformats.org/officeDocument/2006/relationships" id="261" r:id="R009cb80dd0524112"/>
-    <p:sldId xmlns:r="http://schemas.openxmlformats.org/officeDocument/2006/relationships" id="262" r:id="R82f6542dbfef4c92"/>
-    <p:sldId xmlns:r="http://schemas.openxmlformats.org/officeDocument/2006/relationships" id="263" r:id="R3ea3310cb7c54d48"/>
-    <p:sldId xmlns:r="http://schemas.openxmlformats.org/officeDocument/2006/relationships" id="264" r:id="Rf2f518100f284b82"/>
-    <p:sldId xmlns:r="http://schemas.openxmlformats.org/officeDocument/2006/relationships" id="265" r:id="R2e7b84a0d45447f6"/>
-    <p:sldId xmlns:r="http://schemas.openxmlformats.org/officeDocument/2006/relationships" id="266" r:id="R2f374b878068449a"/>
-    <p:sldId xmlns:r="http://schemas.openxmlformats.org/officeDocument/2006/relationships" id="267" r:id="R3da9148271a644ba"/>
+    <p:sldId xmlns:r="http://schemas.openxmlformats.org/officeDocument/2006/relationships" id="256" r:id="R86da204419e14b15"/>
+    <p:sldId xmlns:r="http://schemas.openxmlformats.org/officeDocument/2006/relationships" id="257" r:id="Rb680987929d7456c"/>
+    <p:sldId xmlns:r="http://schemas.openxmlformats.org/officeDocument/2006/relationships" id="258" r:id="R03d30a45c8114c1f"/>
+    <p:sldId xmlns:r="http://schemas.openxmlformats.org/officeDocument/2006/relationships" id="259" r:id="R0ccb4e035e3740b9"/>
+    <p:sldId xmlns:r="http://schemas.openxmlformats.org/officeDocument/2006/relationships" id="260" r:id="R6185d6bd3d2f4571"/>
+    <p:sldId xmlns:r="http://schemas.openxmlformats.org/officeDocument/2006/relationships" id="261" r:id="Rc20913d43d30461f"/>
+    <p:sldId xmlns:r="http://schemas.openxmlformats.org/officeDocument/2006/relationships" id="262" r:id="R8dfe103e99ea4519"/>
+    <p:sldId xmlns:r="http://schemas.openxmlformats.org/officeDocument/2006/relationships" id="263" r:id="R642fef8db1a642b1"/>
+    <p:sldId xmlns:r="http://schemas.openxmlformats.org/officeDocument/2006/relationships" id="264" r:id="R6b5390efd5c44976"/>
+    <p:sldId xmlns:r="http://schemas.openxmlformats.org/officeDocument/2006/relationships" id="265" r:id="R992a3ec36ba84895"/>
+    <p:sldId xmlns:r="http://schemas.openxmlformats.org/officeDocument/2006/relationships" id="266" r:id="R947bb07e0cbc4362"/>
+    <p:sldId xmlns:r="http://schemas.openxmlformats.org/officeDocument/2006/relationships" id="267" r:id="R6d707e2886724476"/>
   </p:sldIdLst>
   <p:sldSz cx="12192000" cy="6858000"/>
   <p:notesSz cx="6858000" cy="9144000"/>
@@ -1292,7 +1292,7 @@
   </p:cSld>
   <p:clrMap bg1="lt1" tx1="dk1" bg2="lt2" tx2="dk2" accent1="accent1" accent2="accent2" accent3="accent3" accent4="accent4" accent5="accent5" accent6="accent6" hlink="hlink" folHlink="folHlink"/>
   <p:sldLayoutIdLst>
-    <p:sldLayoutId xmlns:r="http://schemas.openxmlformats.org/officeDocument/2006/relationships" id="2147483649" r:id="R949775561f05424d"/>
+    <p:sldLayoutId xmlns:r="http://schemas.openxmlformats.org/officeDocument/2006/relationships" id="2147483649" r:id="Rc81ec75663704953"/>
   </p:sldLayoutIdLst>
   <p:txStyles>
     <p:titleStyle>
@@ -1790,7 +1790,7 @@
           <p:cNvPr id="1" name="">
             <a:extLst xmlns:a="http://schemas.openxmlformats.org/drawingml/2006/main">
               <a:ext uri="{FF2B5EF4-FFF2-40B4-BE49-F238E27FC236}">
-                <a16:creationId xmlns:a16="http://schemas.microsoft.com/office/drawing/2014/main" id="{4C301DEA-01FD-428F-A11D-12E8364FE587}"/>
+                <a16:creationId xmlns:a16="http://schemas.microsoft.com/office/drawing/2014/main" id="{7599E284-FCA3-4FBE-9E09-992A51ED0BA4}"/>
               </a:ext>
             </a:extLst>
           </p:cNvPr>
@@ -1825,7 +1825,7 @@
           <p:cNvPr id="2" name="">
             <a:extLst xmlns:a="http://schemas.openxmlformats.org/drawingml/2006/main">
               <a:ext uri="{FF2B5EF4-FFF2-40B4-BE49-F238E27FC236}">
-                <a16:creationId xmlns:a16="http://schemas.microsoft.com/office/drawing/2014/main" id="{04C5C446-5AF1-48AD-8AC7-4BFC893B14BA}"/>
+                <a16:creationId xmlns:a16="http://schemas.microsoft.com/office/drawing/2014/main" id="{36ECA108-0CF2-44BB-9B7D-9708A5DDECCF}"/>
               </a:ext>
             </a:extLst>
           </p:cNvPr>
@@ -1871,7 +1871,7 @@
           <p:cNvPr id="3" name="">
             <a:extLst xmlns:a="http://schemas.openxmlformats.org/drawingml/2006/main">
               <a:ext uri="{FF2B5EF4-FFF2-40B4-BE49-F238E27FC236}">
-                <a16:creationId xmlns:a16="http://schemas.microsoft.com/office/drawing/2014/main" id="{E47C871A-A72C-49A9-8CA2-97F0637A3A64}"/>
+                <a16:creationId xmlns:a16="http://schemas.microsoft.com/office/drawing/2014/main" id="{E150C589-9718-40C4-B982-CE0F1CE45564}"/>
               </a:ext>
             </a:extLst>
           </p:cNvPr>
@@ -1935,7 +1935,7 @@
           <p:cNvPr id="4" name="">
             <a:extLst xmlns:a="http://schemas.openxmlformats.org/drawingml/2006/main">
               <a:ext uri="{FF2B5EF4-FFF2-40B4-BE49-F238E27FC236}">
-                <a16:creationId xmlns:a16="http://schemas.microsoft.com/office/drawing/2014/main" id="{1A043826-560E-4031-BA38-0EC00126EB97}"/>
+                <a16:creationId xmlns:a16="http://schemas.microsoft.com/office/drawing/2014/main" id="{C08E4C76-433F-4BD3-97AC-C52C68FAD2A7}"/>
               </a:ext>
             </a:extLst>
           </p:cNvPr>
@@ -1999,7 +1999,7 @@
           <p:cNvPr id="5" name="">
             <a:extLst xmlns:a="http://schemas.openxmlformats.org/drawingml/2006/main">
               <a:ext uri="{FF2B5EF4-FFF2-40B4-BE49-F238E27FC236}">
-                <a16:creationId xmlns:a16="http://schemas.microsoft.com/office/drawing/2014/main" id="{056E2607-31B3-4AE9-86EA-86F1D0191C46}"/>
+                <a16:creationId xmlns:a16="http://schemas.microsoft.com/office/drawing/2014/main" id="{8D878209-734B-4DBD-9920-3EE4F09CD0FD}"/>
               </a:ext>
             </a:extLst>
           </p:cNvPr>
@@ -2032,7 +2032,7 @@
           <p:cNvPr id="6" name="">
             <a:extLst xmlns:a="http://schemas.openxmlformats.org/drawingml/2006/main">
               <a:ext uri="{FF2B5EF4-FFF2-40B4-BE49-F238E27FC236}">
-                <a16:creationId xmlns:a16="http://schemas.microsoft.com/office/drawing/2014/main" id="{2050CD16-4D25-40FC-A31D-25E1527A1ADE}"/>
+                <a16:creationId xmlns:a16="http://schemas.microsoft.com/office/drawing/2014/main" id="{E3017FE0-3F39-411B-ACD7-C97E4853D992}"/>
               </a:ext>
             </a:extLst>
           </p:cNvPr>
@@ -2067,7 +2067,7 @@
           <p:cNvPr id="7" name="">
             <a:extLst xmlns:a="http://schemas.openxmlformats.org/drawingml/2006/main">
               <a:ext uri="{FF2B5EF4-FFF2-40B4-BE49-F238E27FC236}">
-                <a16:creationId xmlns:a16="http://schemas.microsoft.com/office/drawing/2014/main" id="{66B5878D-3A2A-44C0-B5F1-977A01ACC3C0}"/>
+                <a16:creationId xmlns:a16="http://schemas.microsoft.com/office/drawing/2014/main" id="{6AFA7CB4-8F91-4C62-B46A-1AFA8939A618}"/>
               </a:ext>
             </a:extLst>
           </p:cNvPr>
@@ -2131,7 +2131,7 @@
           <p:cNvPr id="8" name="">
             <a:extLst xmlns:a="http://schemas.openxmlformats.org/drawingml/2006/main">
               <a:ext uri="{FF2B5EF4-FFF2-40B4-BE49-F238E27FC236}">
-                <a16:creationId xmlns:a16="http://schemas.microsoft.com/office/drawing/2014/main" id="{5009C6BD-636D-41B7-BF5E-8D12240571DA}"/>
+                <a16:creationId xmlns:a16="http://schemas.microsoft.com/office/drawing/2014/main" id="{59A6C12D-C05B-44DF-96C9-FD597701C52B}"/>
               </a:ext>
             </a:extLst>
           </p:cNvPr>
@@ -2195,7 +2195,7 @@
           <p:cNvPr id="9" name="">
             <a:extLst xmlns:a="http://schemas.openxmlformats.org/drawingml/2006/main">
               <a:ext uri="{FF2B5EF4-FFF2-40B4-BE49-F238E27FC236}">
-                <a16:creationId xmlns:a16="http://schemas.microsoft.com/office/drawing/2014/main" id="{CABDF4E4-A296-4275-973A-B8ADA5FDA9BC}"/>
+                <a16:creationId xmlns:a16="http://schemas.microsoft.com/office/drawing/2014/main" id="{BDDAD27A-3645-408A-B452-DB384D1C3623}"/>
               </a:ext>
             </a:extLst>
           </p:cNvPr>
@@ -2228,7 +2228,7 @@
           <p:cNvPr id="10" name="">
             <a:extLst xmlns:a="http://schemas.openxmlformats.org/drawingml/2006/main">
               <a:ext uri="{FF2B5EF4-FFF2-40B4-BE49-F238E27FC236}">
-                <a16:creationId xmlns:a16="http://schemas.microsoft.com/office/drawing/2014/main" id="{33D5D4AD-2F78-4AC8-B51E-7FA80C9A2509}"/>
+                <a16:creationId xmlns:a16="http://schemas.microsoft.com/office/drawing/2014/main" id="{9803F310-711D-4298-8D61-595804EB58A6}"/>
               </a:ext>
             </a:extLst>
           </p:cNvPr>
@@ -2263,7 +2263,7 @@
           <p:cNvPr id="11" name="">
             <a:extLst xmlns:a="http://schemas.openxmlformats.org/drawingml/2006/main">
               <a:ext uri="{FF2B5EF4-FFF2-40B4-BE49-F238E27FC236}">
-                <a16:creationId xmlns:a16="http://schemas.microsoft.com/office/drawing/2014/main" id="{5FE4AE02-F9AB-4849-B603-6CB64CB136E6}"/>
+                <a16:creationId xmlns:a16="http://schemas.microsoft.com/office/drawing/2014/main" id="{707A5583-7A24-4F0B-8B42-598274578A4A}"/>
               </a:ext>
             </a:extLst>
           </p:cNvPr>
@@ -2327,7 +2327,7 @@
           <p:cNvPr id="12" name="">
             <a:extLst xmlns:a="http://schemas.openxmlformats.org/drawingml/2006/main">
               <a:ext uri="{FF2B5EF4-FFF2-40B4-BE49-F238E27FC236}">
-                <a16:creationId xmlns:a16="http://schemas.microsoft.com/office/drawing/2014/main" id="{F01A15E2-4DD4-45FD-B014-AB750CEAE0AC}"/>
+                <a16:creationId xmlns:a16="http://schemas.microsoft.com/office/drawing/2014/main" id="{8EE8EE19-CD5A-42B8-9542-00F7FFD2AB7B}"/>
               </a:ext>
             </a:extLst>
           </p:cNvPr>
@@ -2391,7 +2391,7 @@
           <p:cNvPr id="13" name="">
             <a:extLst xmlns:a="http://schemas.openxmlformats.org/drawingml/2006/main">
               <a:ext uri="{FF2B5EF4-FFF2-40B4-BE49-F238E27FC236}">
-                <a16:creationId xmlns:a16="http://schemas.microsoft.com/office/drawing/2014/main" id="{C0F24684-4189-4BB6-B814-2BCA54F278F5}"/>
+                <a16:creationId xmlns:a16="http://schemas.microsoft.com/office/drawing/2014/main" id="{9DC9221A-6F9A-42BC-80FA-3D15CB0E16AE}"/>
               </a:ext>
             </a:extLst>
           </p:cNvPr>
@@ -2424,7 +2424,7 @@
           <p:cNvPr id="14" name="">
             <a:extLst xmlns:a="http://schemas.openxmlformats.org/drawingml/2006/main">
               <a:ext uri="{FF2B5EF4-FFF2-40B4-BE49-F238E27FC236}">
-                <a16:creationId xmlns:a16="http://schemas.microsoft.com/office/drawing/2014/main" id="{6578D103-485E-4EF2-8076-0C2FFD81806D}"/>
+                <a16:creationId xmlns:a16="http://schemas.microsoft.com/office/drawing/2014/main" id="{E6677FC5-D838-47D3-B813-ED3529006CD2}"/>
               </a:ext>
             </a:extLst>
           </p:cNvPr>
@@ -2459,7 +2459,7 @@
           <p:cNvPr id="15" name="">
             <a:extLst xmlns:a="http://schemas.openxmlformats.org/drawingml/2006/main">
               <a:ext uri="{FF2B5EF4-FFF2-40B4-BE49-F238E27FC236}">
-                <a16:creationId xmlns:a16="http://schemas.microsoft.com/office/drawing/2014/main" id="{A54A92CA-B3FD-4FEE-85FE-F24260302A58}"/>
+                <a16:creationId xmlns:a16="http://schemas.microsoft.com/office/drawing/2014/main" id="{11C6EAEA-46B7-4AC0-B5CA-8ED7F19EF8D6}"/>
               </a:ext>
             </a:extLst>
           </p:cNvPr>
@@ -2523,7 +2523,7 @@
           <p:cNvPr id="16" name="">
             <a:extLst xmlns:a="http://schemas.openxmlformats.org/drawingml/2006/main">
               <a:ext uri="{FF2B5EF4-FFF2-40B4-BE49-F238E27FC236}">
-                <a16:creationId xmlns:a16="http://schemas.microsoft.com/office/drawing/2014/main" id="{B523CDA1-9206-40E2-9170-2EA94E4716A8}"/>
+                <a16:creationId xmlns:a16="http://schemas.microsoft.com/office/drawing/2014/main" id="{ACAA96CB-4EA6-4F3A-BB7B-9845F4A89C1A}"/>
               </a:ext>
             </a:extLst>
           </p:cNvPr>
@@ -2587,7 +2587,7 @@
           <p:cNvPr id="17" name="">
             <a:extLst xmlns:a="http://schemas.openxmlformats.org/drawingml/2006/main">
               <a:ext uri="{FF2B5EF4-FFF2-40B4-BE49-F238E27FC236}">
-                <a16:creationId xmlns:a16="http://schemas.microsoft.com/office/drawing/2014/main" id="{5A8D44FD-350F-4300-A12A-C8B9BFA76096}"/>
+                <a16:creationId xmlns:a16="http://schemas.microsoft.com/office/drawing/2014/main" id="{DAA7AFF5-241D-47FB-BF73-D0581F9D79A8}"/>
               </a:ext>
             </a:extLst>
           </p:cNvPr>
@@ -2649,7 +2649,7 @@
     </p:spTree>
     <p:extLst>
       <p:ext uri="{BB962C8B-B14F-4D97-AF65-F5344CB8AC3E}">
-        <p14:creationId xmlns:p14="http://schemas.microsoft.com/office/powerpoint/2010/main" val="1357210304"/>
+        <p14:creationId xmlns:p14="http://schemas.microsoft.com/office/powerpoint/2010/main" val="236783816"/>
       </p:ext>
     </p:extLst>
   </p:cSld>
@@ -2673,7 +2673,7 @@
           <p:cNvPr id="1" name="">
             <a:extLst xmlns:a="http://schemas.openxmlformats.org/drawingml/2006/main">
               <a:ext uri="{FF2B5EF4-FFF2-40B4-BE49-F238E27FC236}">
-                <a16:creationId xmlns:a16="http://schemas.microsoft.com/office/drawing/2014/main" id="{E0C26237-BEB7-4B4E-8CB3-62D0BEDB2FF1}"/>
+                <a16:creationId xmlns:a16="http://schemas.microsoft.com/office/drawing/2014/main" id="{D43D0636-2CC8-4971-8A75-A85787035A4F}"/>
               </a:ext>
             </a:extLst>
           </p:cNvPr>
@@ -2708,7 +2708,7 @@
           <p:cNvPr id="2" name="">
             <a:extLst xmlns:a="http://schemas.openxmlformats.org/drawingml/2006/main">
               <a:ext uri="{FF2B5EF4-FFF2-40B4-BE49-F238E27FC236}">
-                <a16:creationId xmlns:a16="http://schemas.microsoft.com/office/drawing/2014/main" id="{3F419927-E78A-4B4C-A970-240E5F647A6A}"/>
+                <a16:creationId xmlns:a16="http://schemas.microsoft.com/office/drawing/2014/main" id="{F5E1726A-6345-425D-B738-463657A66B00}"/>
               </a:ext>
             </a:extLst>
           </p:cNvPr>
@@ -2743,7 +2743,7 @@
           <p:cNvPr id="3" name="">
             <a:extLst xmlns:a="http://schemas.openxmlformats.org/drawingml/2006/main">
               <a:ext uri="{FF2B5EF4-FFF2-40B4-BE49-F238E27FC236}">
-                <a16:creationId xmlns:a16="http://schemas.microsoft.com/office/drawing/2014/main" id="{B4425D7B-4E94-4B89-8290-ED3850202F7D}"/>
+                <a16:creationId xmlns:a16="http://schemas.microsoft.com/office/drawing/2014/main" id="{998EEE47-84DD-40B7-834A-8F2C1296A7D4}"/>
               </a:ext>
             </a:extLst>
           </p:cNvPr>
@@ -2807,7 +2807,7 @@
           <p:cNvPr id="4" name="">
             <a:extLst xmlns:a="http://schemas.openxmlformats.org/drawingml/2006/main">
               <a:ext uri="{FF2B5EF4-FFF2-40B4-BE49-F238E27FC236}">
-                <a16:creationId xmlns:a16="http://schemas.microsoft.com/office/drawing/2014/main" id="{B052BA61-E30E-47BC-9594-9B2A53FDB7EA}"/>
+                <a16:creationId xmlns:a16="http://schemas.microsoft.com/office/drawing/2014/main" id="{1847A6ED-4C5A-4992-8565-1D5217D129FE}"/>
               </a:ext>
             </a:extLst>
           </p:cNvPr>
@@ -2875,7 +2875,7 @@
           <p:nvPr/>
         </p:nvPicPr>
         <p:blipFill>
-          <a:blip xmlns:r="http://schemas.openxmlformats.org/officeDocument/2006/relationships" xmlns:a="http://schemas.openxmlformats.org/drawingml/2006/main" r:embed="R0a54bd492152432c"/>
+          <a:blip xmlns:r="http://schemas.openxmlformats.org/officeDocument/2006/relationships" xmlns:a="http://schemas.openxmlformats.org/drawingml/2006/main" r:embed="R5d9ae9662e174349"/>
           <a:stretch xmlns:a="http://schemas.openxmlformats.org/drawingml/2006/main"/>
         </p:blipFill>
         <p:spPr>
@@ -2893,7 +2893,7 @@
           <p:cNvPr id="6" name="">
             <a:extLst xmlns:a="http://schemas.openxmlformats.org/drawingml/2006/main">
               <a:ext uri="{FF2B5EF4-FFF2-40B4-BE49-F238E27FC236}">
-                <a16:creationId xmlns:a16="http://schemas.microsoft.com/office/drawing/2014/main" id="{9DAAA746-A0D8-4F33-8130-A63DEA9142F2}"/>
+                <a16:creationId xmlns:a16="http://schemas.microsoft.com/office/drawing/2014/main" id="{C0E75D3D-A4FC-4AAD-9323-40A9AA7AA33F}"/>
               </a:ext>
             </a:extLst>
           </p:cNvPr>
@@ -2957,7 +2957,7 @@
           <p:cNvPr id="7" name="">
             <a:extLst xmlns:a="http://schemas.openxmlformats.org/drawingml/2006/main">
               <a:ext uri="{FF2B5EF4-FFF2-40B4-BE49-F238E27FC236}">
-                <a16:creationId xmlns:a16="http://schemas.microsoft.com/office/drawing/2014/main" id="{DED96DCC-67EB-4770-B026-C0C843241039}"/>
+                <a16:creationId xmlns:a16="http://schemas.microsoft.com/office/drawing/2014/main" id="{D65DC252-21A5-471D-B7E8-AB5AC61A2988}"/>
               </a:ext>
             </a:extLst>
           </p:cNvPr>
@@ -2990,7 +2990,7 @@
           <p:cNvPr id="8" name="">
             <a:extLst xmlns:a="http://schemas.openxmlformats.org/drawingml/2006/main">
               <a:ext uri="{FF2B5EF4-FFF2-40B4-BE49-F238E27FC236}">
-                <a16:creationId xmlns:a16="http://schemas.microsoft.com/office/drawing/2014/main" id="{20A05BEE-4B49-4C3B-934F-38D7EE4CB36C}"/>
+                <a16:creationId xmlns:a16="http://schemas.microsoft.com/office/drawing/2014/main" id="{77243AA0-CEC0-4D3D-86EC-85C518490635}"/>
               </a:ext>
             </a:extLst>
           </p:cNvPr>
@@ -3023,7 +3023,7 @@
           <p:cNvPr id="9" name="">
             <a:extLst xmlns:a="http://schemas.openxmlformats.org/drawingml/2006/main">
               <a:ext uri="{FF2B5EF4-FFF2-40B4-BE49-F238E27FC236}">
-                <a16:creationId xmlns:a16="http://schemas.microsoft.com/office/drawing/2014/main" id="{6B5A6435-0009-4F0F-AE8D-A86FB3B53FE9}"/>
+                <a16:creationId xmlns:a16="http://schemas.microsoft.com/office/drawing/2014/main" id="{40F6DF14-CB20-463B-A876-E4674731227E}"/>
               </a:ext>
             </a:extLst>
           </p:cNvPr>
@@ -3087,7 +3087,7 @@
           <p:cNvPr id="10" name="">
             <a:extLst xmlns:a="http://schemas.openxmlformats.org/drawingml/2006/main">
               <a:ext uri="{FF2B5EF4-FFF2-40B4-BE49-F238E27FC236}">
-                <a16:creationId xmlns:a16="http://schemas.microsoft.com/office/drawing/2014/main" id="{1BDC1B66-CD04-4D5E-858B-8B81A911382A}"/>
+                <a16:creationId xmlns:a16="http://schemas.microsoft.com/office/drawing/2014/main" id="{5DB62D96-AD25-404C-AD50-B3891BC3C444}"/>
               </a:ext>
             </a:extLst>
           </p:cNvPr>
@@ -3151,7 +3151,7 @@
           <p:cNvPr id="11" name="">
             <a:extLst xmlns:a="http://schemas.openxmlformats.org/drawingml/2006/main">
               <a:ext uri="{FF2B5EF4-FFF2-40B4-BE49-F238E27FC236}">
-                <a16:creationId xmlns:a16="http://schemas.microsoft.com/office/drawing/2014/main" id="{9EA3D4AD-7E57-425D-B933-600339F7E4FB}"/>
+                <a16:creationId xmlns:a16="http://schemas.microsoft.com/office/drawing/2014/main" id="{9E193E0E-5A8C-4CBD-ADCF-659B82F25E87}"/>
               </a:ext>
             </a:extLst>
           </p:cNvPr>
@@ -3184,7 +3184,7 @@
           <p:cNvPr id="12" name="">
             <a:extLst xmlns:a="http://schemas.openxmlformats.org/drawingml/2006/main">
               <a:ext uri="{FF2B5EF4-FFF2-40B4-BE49-F238E27FC236}">
-                <a16:creationId xmlns:a16="http://schemas.microsoft.com/office/drawing/2014/main" id="{9E8A4084-A251-4621-90F6-50F552AF3D29}"/>
+                <a16:creationId xmlns:a16="http://schemas.microsoft.com/office/drawing/2014/main" id="{41685E4E-9064-48DF-B1E3-09D51F9FD3CC}"/>
               </a:ext>
             </a:extLst>
           </p:cNvPr>
@@ -3196,7 +3196,7 @@
         <p:spPr>
           <a:xfrm xmlns:a="http://schemas.openxmlformats.org/drawingml/2006/main">
             <a:off x="8715375" y="2028825"/>
-            <a:ext cx="357233" cy="171450"/>
+            <a:ext cx="684530" cy="171450"/>
           </a:xfrm>
           <a:prstGeom xmlns:a="http://schemas.openxmlformats.org/drawingml/2006/main" prst="rect">
             <a:avLst/>
@@ -3217,7 +3217,7 @@
           <p:cNvPr id="13" name="">
             <a:extLst xmlns:a="http://schemas.openxmlformats.org/drawingml/2006/main">
               <a:ext uri="{FF2B5EF4-FFF2-40B4-BE49-F238E27FC236}">
-                <a16:creationId xmlns:a16="http://schemas.microsoft.com/office/drawing/2014/main" id="{B7160A52-64B7-497B-9C46-F7B603061225}"/>
+                <a16:creationId xmlns:a16="http://schemas.microsoft.com/office/drawing/2014/main" id="{38146616-D1AB-4DBD-9280-D2B637B402F1}"/>
               </a:ext>
             </a:extLst>
           </p:cNvPr>
@@ -3271,7 +3271,7 @@
                 <a:ea typeface="Aptos"/>
                 <a:cs typeface="Aptos"/>
               </a:rPr>
-              <a:t>0.8779</a:t>
+              <a:t>0.8943</a:t>
             </a:r>
           </a:p>
         </p:txBody>
@@ -3281,7 +3281,7 @@
           <p:cNvPr id="14" name="">
             <a:extLst xmlns:a="http://schemas.openxmlformats.org/drawingml/2006/main">
               <a:ext uri="{FF2B5EF4-FFF2-40B4-BE49-F238E27FC236}">
-                <a16:creationId xmlns:a16="http://schemas.microsoft.com/office/drawing/2014/main" id="{5CFC9E1D-B775-4B50-A018-D06BD0B57FC4}"/>
+                <a16:creationId xmlns:a16="http://schemas.microsoft.com/office/drawing/2014/main" id="{10CBAB8D-2A05-415B-8D44-85517D30EFA2}"/>
               </a:ext>
             </a:extLst>
           </p:cNvPr>
@@ -3345,7 +3345,7 @@
           <p:cNvPr id="15" name="">
             <a:extLst xmlns:a="http://schemas.openxmlformats.org/drawingml/2006/main">
               <a:ext uri="{FF2B5EF4-FFF2-40B4-BE49-F238E27FC236}">
-                <a16:creationId xmlns:a16="http://schemas.microsoft.com/office/drawing/2014/main" id="{C0DA8EC0-B9D6-4541-B5E1-54D39F5A309E}"/>
+                <a16:creationId xmlns:a16="http://schemas.microsoft.com/office/drawing/2014/main" id="{9D03F4D2-F53A-43E5-B1B0-5E87B3C301ED}"/>
               </a:ext>
             </a:extLst>
           </p:cNvPr>
@@ -3378,7 +3378,7 @@
           <p:cNvPr id="16" name="">
             <a:extLst xmlns:a="http://schemas.openxmlformats.org/drawingml/2006/main">
               <a:ext uri="{FF2B5EF4-FFF2-40B4-BE49-F238E27FC236}">
-                <a16:creationId xmlns:a16="http://schemas.microsoft.com/office/drawing/2014/main" id="{A0949F1A-4587-4895-B0ED-A1C9A9C6C3C7}"/>
+                <a16:creationId xmlns:a16="http://schemas.microsoft.com/office/drawing/2014/main" id="{566361D7-FDAB-4FE9-A673-3297D486ACFE}"/>
               </a:ext>
             </a:extLst>
           </p:cNvPr>
@@ -3411,7 +3411,7 @@
           <p:cNvPr id="17" name="">
             <a:extLst xmlns:a="http://schemas.openxmlformats.org/drawingml/2006/main">
               <a:ext uri="{FF2B5EF4-FFF2-40B4-BE49-F238E27FC236}">
-                <a16:creationId xmlns:a16="http://schemas.microsoft.com/office/drawing/2014/main" id="{BF9E7641-E014-45D1-920F-5125A252108D}"/>
+                <a16:creationId xmlns:a16="http://schemas.microsoft.com/office/drawing/2014/main" id="{560523F7-C33B-4581-BBCE-015D536F089C}"/>
               </a:ext>
             </a:extLst>
           </p:cNvPr>
@@ -3475,7 +3475,7 @@
           <p:cNvPr id="18" name="">
             <a:extLst xmlns:a="http://schemas.openxmlformats.org/drawingml/2006/main">
               <a:ext uri="{FF2B5EF4-FFF2-40B4-BE49-F238E27FC236}">
-                <a16:creationId xmlns:a16="http://schemas.microsoft.com/office/drawing/2014/main" id="{8C6D5573-3145-45C0-8C78-49436A2186FC}"/>
+                <a16:creationId xmlns:a16="http://schemas.microsoft.com/office/drawing/2014/main" id="{34ED26F9-F37F-4254-BBA0-ED20F2EE3082}"/>
               </a:ext>
             </a:extLst>
           </p:cNvPr>
@@ -3539,7 +3539,7 @@
           <p:cNvPr id="19" name="">
             <a:extLst xmlns:a="http://schemas.openxmlformats.org/drawingml/2006/main">
               <a:ext uri="{FF2B5EF4-FFF2-40B4-BE49-F238E27FC236}">
-                <a16:creationId xmlns:a16="http://schemas.microsoft.com/office/drawing/2014/main" id="{8F79C08C-A249-49BC-8233-591771EDCDBE}"/>
+                <a16:creationId xmlns:a16="http://schemas.microsoft.com/office/drawing/2014/main" id="{86A02A82-5BA1-492A-A978-CD8954263066}"/>
               </a:ext>
             </a:extLst>
           </p:cNvPr>
@@ -3572,7 +3572,7 @@
           <p:cNvPr id="20" name="">
             <a:extLst xmlns:a="http://schemas.openxmlformats.org/drawingml/2006/main">
               <a:ext uri="{FF2B5EF4-FFF2-40B4-BE49-F238E27FC236}">
-                <a16:creationId xmlns:a16="http://schemas.microsoft.com/office/drawing/2014/main" id="{5A8EB95A-48E1-4BC3-B614-F0860D25C920}"/>
+                <a16:creationId xmlns:a16="http://schemas.microsoft.com/office/drawing/2014/main" id="{C050E0BE-A92E-485F-A6DD-CD1468D51ABD}"/>
               </a:ext>
             </a:extLst>
           </p:cNvPr>
@@ -3605,7 +3605,7 @@
           <p:cNvPr id="21" name="">
             <a:extLst xmlns:a="http://schemas.openxmlformats.org/drawingml/2006/main">
               <a:ext uri="{FF2B5EF4-FFF2-40B4-BE49-F238E27FC236}">
-                <a16:creationId xmlns:a16="http://schemas.microsoft.com/office/drawing/2014/main" id="{41CA715F-B3BE-4012-AA35-F7BA87374E4C}"/>
+                <a16:creationId xmlns:a16="http://schemas.microsoft.com/office/drawing/2014/main" id="{72C9172E-C53B-47E3-AF0C-C9F90CDD181C}"/>
               </a:ext>
             </a:extLst>
           </p:cNvPr>
@@ -3669,7 +3669,7 @@
           <p:cNvPr id="22" name="">
             <a:extLst xmlns:a="http://schemas.openxmlformats.org/drawingml/2006/main">
               <a:ext uri="{FF2B5EF4-FFF2-40B4-BE49-F238E27FC236}">
-                <a16:creationId xmlns:a16="http://schemas.microsoft.com/office/drawing/2014/main" id="{34E4FFC3-4F76-4876-8C4B-982674D460AB}"/>
+                <a16:creationId xmlns:a16="http://schemas.microsoft.com/office/drawing/2014/main" id="{3A292F50-4788-487F-AE4B-4951738BFBD3}"/>
               </a:ext>
             </a:extLst>
           </p:cNvPr>
@@ -3733,7 +3733,7 @@
           <p:cNvPr id="23" name="">
             <a:extLst xmlns:a="http://schemas.openxmlformats.org/drawingml/2006/main">
               <a:ext uri="{FF2B5EF4-FFF2-40B4-BE49-F238E27FC236}">
-                <a16:creationId xmlns:a16="http://schemas.microsoft.com/office/drawing/2014/main" id="{D519B075-1EE5-4842-925D-6143FF2B2062}"/>
+                <a16:creationId xmlns:a16="http://schemas.microsoft.com/office/drawing/2014/main" id="{1DE06B00-3977-47FE-B189-603110EDA540}"/>
               </a:ext>
             </a:extLst>
           </p:cNvPr>
@@ -3797,7 +3797,7 @@
           <p:cNvPr id="24" name="">
             <a:extLst xmlns:a="http://schemas.openxmlformats.org/drawingml/2006/main">
               <a:ext uri="{FF2B5EF4-FFF2-40B4-BE49-F238E27FC236}">
-                <a16:creationId xmlns:a16="http://schemas.microsoft.com/office/drawing/2014/main" id="{7935DC7E-3AAC-407C-9092-1C0DCBB34A0F}"/>
+                <a16:creationId xmlns:a16="http://schemas.microsoft.com/office/drawing/2014/main" id="{5A5F218A-3936-472F-974F-4F3E6F80B87F}"/>
               </a:ext>
             </a:extLst>
           </p:cNvPr>
@@ -3859,7 +3859,7 @@
     </p:spTree>
     <p:extLst>
       <p:ext uri="{BB962C8B-B14F-4D97-AF65-F5344CB8AC3E}">
-        <p14:creationId xmlns:p14="http://schemas.microsoft.com/office/powerpoint/2010/main" val="139116302"/>
+        <p14:creationId xmlns:p14="http://schemas.microsoft.com/office/powerpoint/2010/main" val="497044031"/>
       </p:ext>
     </p:extLst>
   </p:cSld>
@@ -3883,7 +3883,7 @@
           <p:cNvPr id="1" name="">
             <a:extLst xmlns:a="http://schemas.openxmlformats.org/drawingml/2006/main">
               <a:ext uri="{FF2B5EF4-FFF2-40B4-BE49-F238E27FC236}">
-                <a16:creationId xmlns:a16="http://schemas.microsoft.com/office/drawing/2014/main" id="{823EF604-194E-4BB3-94FC-FF7F980593FB}"/>
+                <a16:creationId xmlns:a16="http://schemas.microsoft.com/office/drawing/2014/main" id="{3E67423D-C69C-486B-92D3-05D17A3CEAED}"/>
               </a:ext>
             </a:extLst>
           </p:cNvPr>
@@ -3918,7 +3918,7 @@
           <p:cNvPr id="2" name="">
             <a:extLst xmlns:a="http://schemas.openxmlformats.org/drawingml/2006/main">
               <a:ext uri="{FF2B5EF4-FFF2-40B4-BE49-F238E27FC236}">
-                <a16:creationId xmlns:a16="http://schemas.microsoft.com/office/drawing/2014/main" id="{4C550CB9-06C7-45B1-B1A0-DCED0E3AEDEB}"/>
+                <a16:creationId xmlns:a16="http://schemas.microsoft.com/office/drawing/2014/main" id="{E861736C-D417-4334-BACF-6CE9C4C8D123}"/>
               </a:ext>
             </a:extLst>
           </p:cNvPr>
@@ -3953,7 +3953,7 @@
           <p:cNvPr id="3" name="">
             <a:extLst xmlns:a="http://schemas.openxmlformats.org/drawingml/2006/main">
               <a:ext uri="{FF2B5EF4-FFF2-40B4-BE49-F238E27FC236}">
-                <a16:creationId xmlns:a16="http://schemas.microsoft.com/office/drawing/2014/main" id="{A412CA1A-4F2C-4CE8-9BE4-498BDE0AA829}"/>
+                <a16:creationId xmlns:a16="http://schemas.microsoft.com/office/drawing/2014/main" id="{3130B6E1-E06C-4F14-8C40-1FA96AD7F9A8}"/>
               </a:ext>
             </a:extLst>
           </p:cNvPr>
@@ -4017,7 +4017,7 @@
           <p:cNvPr id="4" name="">
             <a:extLst xmlns:a="http://schemas.openxmlformats.org/drawingml/2006/main">
               <a:ext uri="{FF2B5EF4-FFF2-40B4-BE49-F238E27FC236}">
-                <a16:creationId xmlns:a16="http://schemas.microsoft.com/office/drawing/2014/main" id="{BC205139-97A4-4971-B8E5-B03D2CF6A41B}"/>
+                <a16:creationId xmlns:a16="http://schemas.microsoft.com/office/drawing/2014/main" id="{1FE03B20-415F-4563-855A-7F6EBB47F01C}"/>
               </a:ext>
             </a:extLst>
           </p:cNvPr>
@@ -4081,7 +4081,7 @@
           <p:cNvPr id="5" name="">
             <a:extLst xmlns:a="http://schemas.openxmlformats.org/drawingml/2006/main">
               <a:ext uri="{FF2B5EF4-FFF2-40B4-BE49-F238E27FC236}">
-                <a16:creationId xmlns:a16="http://schemas.microsoft.com/office/drawing/2014/main" id="{E23F0F91-748C-4219-8C79-C0BB9F8C3BE7}"/>
+                <a16:creationId xmlns:a16="http://schemas.microsoft.com/office/drawing/2014/main" id="{10C348BD-CDA4-49ED-AF88-59D6AB5ACA38}"/>
               </a:ext>
             </a:extLst>
           </p:cNvPr>
@@ -4114,7 +4114,7 @@
           <p:cNvPr id="6" name="">
             <a:extLst xmlns:a="http://schemas.openxmlformats.org/drawingml/2006/main">
               <a:ext uri="{FF2B5EF4-FFF2-40B4-BE49-F238E27FC236}">
-                <a16:creationId xmlns:a16="http://schemas.microsoft.com/office/drawing/2014/main" id="{414D173C-082E-44F1-A5EF-B5FEBF70C7C7}"/>
+                <a16:creationId xmlns:a16="http://schemas.microsoft.com/office/drawing/2014/main" id="{6B677890-1E6A-4F0C-A92A-4BBC21717D66}"/>
               </a:ext>
             </a:extLst>
           </p:cNvPr>
@@ -4178,7 +4178,7 @@
           <p:cNvPr id="7" name="">
             <a:extLst xmlns:a="http://schemas.openxmlformats.org/drawingml/2006/main">
               <a:ext uri="{FF2B5EF4-FFF2-40B4-BE49-F238E27FC236}">
-                <a16:creationId xmlns:a16="http://schemas.microsoft.com/office/drawing/2014/main" id="{05421C87-1210-4484-85B1-CFEE646C3AD5}"/>
+                <a16:creationId xmlns:a16="http://schemas.microsoft.com/office/drawing/2014/main" id="{260CFFE4-B27A-4E5E-AD89-89739ED59CF2}"/>
               </a:ext>
             </a:extLst>
           </p:cNvPr>
@@ -4211,7 +4211,7 @@
           <p:cNvPr id="8" name="">
             <a:extLst xmlns:a="http://schemas.openxmlformats.org/drawingml/2006/main">
               <a:ext uri="{FF2B5EF4-FFF2-40B4-BE49-F238E27FC236}">
-                <a16:creationId xmlns:a16="http://schemas.microsoft.com/office/drawing/2014/main" id="{C2636538-9A21-42E8-B6FC-0A52199D0593}"/>
+                <a16:creationId xmlns:a16="http://schemas.microsoft.com/office/drawing/2014/main" id="{A0089883-B07A-495A-AABE-82A37D969884}"/>
               </a:ext>
             </a:extLst>
           </p:cNvPr>
@@ -4275,7 +4275,7 @@
           <p:cNvPr id="9" name="">
             <a:extLst xmlns:a="http://schemas.openxmlformats.org/drawingml/2006/main">
               <a:ext uri="{FF2B5EF4-FFF2-40B4-BE49-F238E27FC236}">
-                <a16:creationId xmlns:a16="http://schemas.microsoft.com/office/drawing/2014/main" id="{2D04E41A-D3A7-4018-B4F6-48BF44BD7EA3}"/>
+                <a16:creationId xmlns:a16="http://schemas.microsoft.com/office/drawing/2014/main" id="{48479E9A-6949-40BF-A382-F8618726A3E6}"/>
               </a:ext>
             </a:extLst>
           </p:cNvPr>
@@ -4308,7 +4308,7 @@
           <p:cNvPr id="10" name="">
             <a:extLst xmlns:a="http://schemas.openxmlformats.org/drawingml/2006/main">
               <a:ext uri="{FF2B5EF4-FFF2-40B4-BE49-F238E27FC236}">
-                <a16:creationId xmlns:a16="http://schemas.microsoft.com/office/drawing/2014/main" id="{A2D391D9-23B0-4B0C-9F02-3322A47656BD}"/>
+                <a16:creationId xmlns:a16="http://schemas.microsoft.com/office/drawing/2014/main" id="{4FAFDBFE-C9C4-4F90-9436-AD46DC8AE479}"/>
               </a:ext>
             </a:extLst>
           </p:cNvPr>
@@ -4372,7 +4372,7 @@
           <p:cNvPr id="11" name="">
             <a:extLst xmlns:a="http://schemas.openxmlformats.org/drawingml/2006/main">
               <a:ext uri="{FF2B5EF4-FFF2-40B4-BE49-F238E27FC236}">
-                <a16:creationId xmlns:a16="http://schemas.microsoft.com/office/drawing/2014/main" id="{E8AFD285-1D58-47F4-A4E8-133FA3E04A89}"/>
+                <a16:creationId xmlns:a16="http://schemas.microsoft.com/office/drawing/2014/main" id="{2260DAB6-808D-46EE-BDA3-8C693FC2346E}"/>
               </a:ext>
             </a:extLst>
           </p:cNvPr>
@@ -4405,7 +4405,7 @@
           <p:cNvPr id="12" name="">
             <a:extLst xmlns:a="http://schemas.openxmlformats.org/drawingml/2006/main">
               <a:ext uri="{FF2B5EF4-FFF2-40B4-BE49-F238E27FC236}">
-                <a16:creationId xmlns:a16="http://schemas.microsoft.com/office/drawing/2014/main" id="{FD1CD6AD-A57C-4F1C-B4C6-C3665486BC15}"/>
+                <a16:creationId xmlns:a16="http://schemas.microsoft.com/office/drawing/2014/main" id="{F0240ED1-601A-48E7-A3A4-B0FCD52A3DA4}"/>
               </a:ext>
             </a:extLst>
           </p:cNvPr>
@@ -4469,7 +4469,7 @@
           <p:cNvPr id="13" name="">
             <a:extLst xmlns:a="http://schemas.openxmlformats.org/drawingml/2006/main">
               <a:ext uri="{FF2B5EF4-FFF2-40B4-BE49-F238E27FC236}">
-                <a16:creationId xmlns:a16="http://schemas.microsoft.com/office/drawing/2014/main" id="{7C52198A-FAFD-4F35-BB55-29ACE8BC7A5D}"/>
+                <a16:creationId xmlns:a16="http://schemas.microsoft.com/office/drawing/2014/main" id="{7669E6A1-D618-4170-99F8-C2D85A8DD488}"/>
               </a:ext>
             </a:extLst>
           </p:cNvPr>
@@ -4502,7 +4502,7 @@
           <p:cNvPr id="14" name="">
             <a:extLst xmlns:a="http://schemas.openxmlformats.org/drawingml/2006/main">
               <a:ext uri="{FF2B5EF4-FFF2-40B4-BE49-F238E27FC236}">
-                <a16:creationId xmlns:a16="http://schemas.microsoft.com/office/drawing/2014/main" id="{51484078-311D-47FA-8A6F-2CFDE8B86037}"/>
+                <a16:creationId xmlns:a16="http://schemas.microsoft.com/office/drawing/2014/main" id="{5E5B1EF3-B5A8-4506-AC88-1081D13743AE}"/>
               </a:ext>
             </a:extLst>
           </p:cNvPr>
@@ -4566,7 +4566,7 @@
           <p:cNvPr id="15" name="">
             <a:extLst xmlns:a="http://schemas.openxmlformats.org/drawingml/2006/main">
               <a:ext uri="{FF2B5EF4-FFF2-40B4-BE49-F238E27FC236}">
-                <a16:creationId xmlns:a16="http://schemas.microsoft.com/office/drawing/2014/main" id="{C86EDE5D-08F1-4BD7-B341-1EADBE24F93A}"/>
+                <a16:creationId xmlns:a16="http://schemas.microsoft.com/office/drawing/2014/main" id="{8A82D2A0-8153-462B-B9C4-032A01ABB830}"/>
               </a:ext>
             </a:extLst>
           </p:cNvPr>
@@ -4630,7 +4630,7 @@
           <p:cNvPr id="16" name="">
             <a:extLst xmlns:a="http://schemas.openxmlformats.org/drawingml/2006/main">
               <a:ext uri="{FF2B5EF4-FFF2-40B4-BE49-F238E27FC236}">
-                <a16:creationId xmlns:a16="http://schemas.microsoft.com/office/drawing/2014/main" id="{95730143-1194-43AA-ACE2-4A3CE57C0392}"/>
+                <a16:creationId xmlns:a16="http://schemas.microsoft.com/office/drawing/2014/main" id="{89FDA513-D4E7-4E05-8A9F-5E8A2E514F67}"/>
               </a:ext>
             </a:extLst>
           </p:cNvPr>
@@ -4694,7 +4694,7 @@
           <p:cNvPr id="17" name="">
             <a:extLst xmlns:a="http://schemas.openxmlformats.org/drawingml/2006/main">
               <a:ext uri="{FF2B5EF4-FFF2-40B4-BE49-F238E27FC236}">
-                <a16:creationId xmlns:a16="http://schemas.microsoft.com/office/drawing/2014/main" id="{C436566C-1208-4230-AE42-3EADBDB17B20}"/>
+                <a16:creationId xmlns:a16="http://schemas.microsoft.com/office/drawing/2014/main" id="{6904CF8C-6E63-45CC-918D-7DF79FAB69E7}"/>
               </a:ext>
             </a:extLst>
           </p:cNvPr>
@@ -4756,7 +4756,7 @@
     </p:spTree>
     <p:extLst>
       <p:ext uri="{BB962C8B-B14F-4D97-AF65-F5344CB8AC3E}">
-        <p14:creationId xmlns:p14="http://schemas.microsoft.com/office/powerpoint/2010/main" val="1744615951"/>
+        <p14:creationId xmlns:p14="http://schemas.microsoft.com/office/powerpoint/2010/main" val="264656861"/>
       </p:ext>
     </p:extLst>
   </p:cSld>
@@ -4780,7 +4780,7 @@
           <p:cNvPr id="1" name="">
             <a:extLst xmlns:a="http://schemas.openxmlformats.org/drawingml/2006/main">
               <a:ext uri="{FF2B5EF4-FFF2-40B4-BE49-F238E27FC236}">
-                <a16:creationId xmlns:a16="http://schemas.microsoft.com/office/drawing/2014/main" id="{6B89E632-8CBC-4328-9682-ECE59863A23F}"/>
+                <a16:creationId xmlns:a16="http://schemas.microsoft.com/office/drawing/2014/main" id="{2CC90EE8-E91E-49B8-A223-FFB87BA7E8D7}"/>
               </a:ext>
             </a:extLst>
           </p:cNvPr>
@@ -4815,7 +4815,7 @@
           <p:cNvPr id="2" name="">
             <a:extLst xmlns:a="http://schemas.openxmlformats.org/drawingml/2006/main">
               <a:ext uri="{FF2B5EF4-FFF2-40B4-BE49-F238E27FC236}">
-                <a16:creationId xmlns:a16="http://schemas.microsoft.com/office/drawing/2014/main" id="{522109FB-07A1-4C0F-AB00-505009522336}"/>
+                <a16:creationId xmlns:a16="http://schemas.microsoft.com/office/drawing/2014/main" id="{8659479B-74B2-4DCC-978B-F4DC3E65E5A6}"/>
               </a:ext>
             </a:extLst>
           </p:cNvPr>
@@ -4850,7 +4850,7 @@
           <p:cNvPr id="3" name="">
             <a:extLst xmlns:a="http://schemas.openxmlformats.org/drawingml/2006/main">
               <a:ext uri="{FF2B5EF4-FFF2-40B4-BE49-F238E27FC236}">
-                <a16:creationId xmlns:a16="http://schemas.microsoft.com/office/drawing/2014/main" id="{44F05935-23AA-40FD-A452-81880A1F7A40}"/>
+                <a16:creationId xmlns:a16="http://schemas.microsoft.com/office/drawing/2014/main" id="{71805723-6588-4784-9C6B-529BEBD4B142}"/>
               </a:ext>
             </a:extLst>
           </p:cNvPr>
@@ -4914,7 +4914,7 @@
           <p:cNvPr id="4" name="">
             <a:extLst xmlns:a="http://schemas.openxmlformats.org/drawingml/2006/main">
               <a:ext uri="{FF2B5EF4-FFF2-40B4-BE49-F238E27FC236}">
-                <a16:creationId xmlns:a16="http://schemas.microsoft.com/office/drawing/2014/main" id="{663B49B3-8280-4133-84D1-C7D731D3A551}"/>
+                <a16:creationId xmlns:a16="http://schemas.microsoft.com/office/drawing/2014/main" id="{743E98D7-85D6-4D8E-A658-C6AAA05C7625}"/>
               </a:ext>
             </a:extLst>
           </p:cNvPr>
@@ -4978,7 +4978,7 @@
           <p:cNvPr id="5" name="">
             <a:extLst xmlns:a="http://schemas.openxmlformats.org/drawingml/2006/main">
               <a:ext uri="{FF2B5EF4-FFF2-40B4-BE49-F238E27FC236}">
-                <a16:creationId xmlns:a16="http://schemas.microsoft.com/office/drawing/2014/main" id="{637DF6C3-E0BD-4FBB-83F4-997FE7A81761}"/>
+                <a16:creationId xmlns:a16="http://schemas.microsoft.com/office/drawing/2014/main" id="{79FACFD7-C6A7-443E-B5D1-4798027ADBF4}"/>
               </a:ext>
             </a:extLst>
           </p:cNvPr>
@@ -5011,7 +5011,7 @@
           <p:cNvPr id="6" name="">
             <a:extLst xmlns:a="http://schemas.openxmlformats.org/drawingml/2006/main">
               <a:ext uri="{FF2B5EF4-FFF2-40B4-BE49-F238E27FC236}">
-                <a16:creationId xmlns:a16="http://schemas.microsoft.com/office/drawing/2014/main" id="{A825E232-1071-4586-A622-DBA0D82601AE}"/>
+                <a16:creationId xmlns:a16="http://schemas.microsoft.com/office/drawing/2014/main" id="{6EBDF157-17BB-4F0F-8F97-954F16442027}"/>
               </a:ext>
             </a:extLst>
           </p:cNvPr>
@@ -5075,7 +5075,7 @@
           <p:cNvPr id="7" name="">
             <a:extLst xmlns:a="http://schemas.openxmlformats.org/drawingml/2006/main">
               <a:ext uri="{FF2B5EF4-FFF2-40B4-BE49-F238E27FC236}">
-                <a16:creationId xmlns:a16="http://schemas.microsoft.com/office/drawing/2014/main" id="{CD587613-D644-4D2E-A56E-061E31CF9E6C}"/>
+                <a16:creationId xmlns:a16="http://schemas.microsoft.com/office/drawing/2014/main" id="{CF27197D-18ED-42B9-A3B1-9F89FA6C1B5A}"/>
               </a:ext>
             </a:extLst>
           </p:cNvPr>
@@ -5108,7 +5108,7 @@
           <p:cNvPr id="8" name="">
             <a:extLst xmlns:a="http://schemas.openxmlformats.org/drawingml/2006/main">
               <a:ext uri="{FF2B5EF4-FFF2-40B4-BE49-F238E27FC236}">
-                <a16:creationId xmlns:a16="http://schemas.microsoft.com/office/drawing/2014/main" id="{B8CC436D-C189-4855-A52C-3C0038D4A903}"/>
+                <a16:creationId xmlns:a16="http://schemas.microsoft.com/office/drawing/2014/main" id="{382CB301-3461-477B-9B65-D3BBBADF64CD}"/>
               </a:ext>
             </a:extLst>
           </p:cNvPr>
@@ -5172,7 +5172,7 @@
           <p:cNvPr id="9" name="">
             <a:extLst xmlns:a="http://schemas.openxmlformats.org/drawingml/2006/main">
               <a:ext uri="{FF2B5EF4-FFF2-40B4-BE49-F238E27FC236}">
-                <a16:creationId xmlns:a16="http://schemas.microsoft.com/office/drawing/2014/main" id="{C7343FE0-A796-4B04-A5DC-4DB5DF361AE3}"/>
+                <a16:creationId xmlns:a16="http://schemas.microsoft.com/office/drawing/2014/main" id="{1C64C405-04EB-4B7B-9821-7978C551CC91}"/>
               </a:ext>
             </a:extLst>
           </p:cNvPr>
@@ -5205,7 +5205,7 @@
           <p:cNvPr id="10" name="">
             <a:extLst xmlns:a="http://schemas.openxmlformats.org/drawingml/2006/main">
               <a:ext uri="{FF2B5EF4-FFF2-40B4-BE49-F238E27FC236}">
-                <a16:creationId xmlns:a16="http://schemas.microsoft.com/office/drawing/2014/main" id="{F96F17E7-1AAB-4AD2-975F-508EB90DA579}"/>
+                <a16:creationId xmlns:a16="http://schemas.microsoft.com/office/drawing/2014/main" id="{C1EB5D64-589E-4E27-BA52-FF4B9EFC65AD}"/>
               </a:ext>
             </a:extLst>
           </p:cNvPr>
@@ -5269,7 +5269,7 @@
           <p:cNvPr id="11" name="">
             <a:extLst xmlns:a="http://schemas.openxmlformats.org/drawingml/2006/main">
               <a:ext uri="{FF2B5EF4-FFF2-40B4-BE49-F238E27FC236}">
-                <a16:creationId xmlns:a16="http://schemas.microsoft.com/office/drawing/2014/main" id="{21CC5494-CE0C-4D8C-B7CA-7D484521CB7D}"/>
+                <a16:creationId xmlns:a16="http://schemas.microsoft.com/office/drawing/2014/main" id="{D3EC9921-614F-43EB-AA53-A066CA4D3DC5}"/>
               </a:ext>
             </a:extLst>
           </p:cNvPr>
@@ -5302,7 +5302,7 @@
           <p:cNvPr id="12" name="">
             <a:extLst xmlns:a="http://schemas.openxmlformats.org/drawingml/2006/main">
               <a:ext uri="{FF2B5EF4-FFF2-40B4-BE49-F238E27FC236}">
-                <a16:creationId xmlns:a16="http://schemas.microsoft.com/office/drawing/2014/main" id="{CD22DFE4-EF1B-4E73-94A3-281A352FB7AC}"/>
+                <a16:creationId xmlns:a16="http://schemas.microsoft.com/office/drawing/2014/main" id="{0EE33C34-33A9-439D-B9B8-BA7AE13CBAFF}"/>
               </a:ext>
             </a:extLst>
           </p:cNvPr>
@@ -5366,7 +5366,7 @@
           <p:cNvPr id="13" name="">
             <a:extLst xmlns:a="http://schemas.openxmlformats.org/drawingml/2006/main">
               <a:ext uri="{FF2B5EF4-FFF2-40B4-BE49-F238E27FC236}">
-                <a16:creationId xmlns:a16="http://schemas.microsoft.com/office/drawing/2014/main" id="{2DC5E550-FACE-4278-A20E-BF6B6E8CB55C}"/>
+                <a16:creationId xmlns:a16="http://schemas.microsoft.com/office/drawing/2014/main" id="{3D3F4809-173B-4847-BA3F-D7D46EB8F039}"/>
               </a:ext>
             </a:extLst>
           </p:cNvPr>
@@ -5399,7 +5399,7 @@
           <p:cNvPr id="14" name="">
             <a:extLst xmlns:a="http://schemas.openxmlformats.org/drawingml/2006/main">
               <a:ext uri="{FF2B5EF4-FFF2-40B4-BE49-F238E27FC236}">
-                <a16:creationId xmlns:a16="http://schemas.microsoft.com/office/drawing/2014/main" id="{693F62E9-C88B-48B1-A1F0-761D708B23C6}"/>
+                <a16:creationId xmlns:a16="http://schemas.microsoft.com/office/drawing/2014/main" id="{BC9217E5-D984-400B-BA7C-0412307B9007}"/>
               </a:ext>
             </a:extLst>
           </p:cNvPr>
@@ -5463,7 +5463,7 @@
           <p:cNvPr id="15" name="">
             <a:extLst xmlns:a="http://schemas.openxmlformats.org/drawingml/2006/main">
               <a:ext uri="{FF2B5EF4-FFF2-40B4-BE49-F238E27FC236}">
-                <a16:creationId xmlns:a16="http://schemas.microsoft.com/office/drawing/2014/main" id="{C3D6DC16-2815-4F9A-991A-5A5F4A947939}"/>
+                <a16:creationId xmlns:a16="http://schemas.microsoft.com/office/drawing/2014/main" id="{69F4AEF5-7D72-40A6-BB61-381DD0282394}"/>
               </a:ext>
             </a:extLst>
           </p:cNvPr>
@@ -5496,7 +5496,7 @@
           <p:cNvPr id="16" name="">
             <a:extLst xmlns:a="http://schemas.openxmlformats.org/drawingml/2006/main">
               <a:ext uri="{FF2B5EF4-FFF2-40B4-BE49-F238E27FC236}">
-                <a16:creationId xmlns:a16="http://schemas.microsoft.com/office/drawing/2014/main" id="{924B05C6-F7E8-40CF-B6C9-5E949131206C}"/>
+                <a16:creationId xmlns:a16="http://schemas.microsoft.com/office/drawing/2014/main" id="{2F5896F4-D25E-44EB-8D9E-F87DFA0A160C}"/>
               </a:ext>
             </a:extLst>
           </p:cNvPr>
@@ -5560,7 +5560,7 @@
           <p:cNvPr id="17" name="">
             <a:extLst xmlns:a="http://schemas.openxmlformats.org/drawingml/2006/main">
               <a:ext uri="{FF2B5EF4-FFF2-40B4-BE49-F238E27FC236}">
-                <a16:creationId xmlns:a16="http://schemas.microsoft.com/office/drawing/2014/main" id="{DE165C63-01C6-4EB7-B675-048C579E4586}"/>
+                <a16:creationId xmlns:a16="http://schemas.microsoft.com/office/drawing/2014/main" id="{8320AA5B-5F70-4450-8D30-5AA027EE6C8B}"/>
               </a:ext>
             </a:extLst>
           </p:cNvPr>
@@ -5593,7 +5593,7 @@
           <p:cNvPr id="18" name="">
             <a:extLst xmlns:a="http://schemas.openxmlformats.org/drawingml/2006/main">
               <a:ext uri="{FF2B5EF4-FFF2-40B4-BE49-F238E27FC236}">
-                <a16:creationId xmlns:a16="http://schemas.microsoft.com/office/drawing/2014/main" id="{D91EAEBC-4405-4371-9A6F-6A814296029F}"/>
+                <a16:creationId xmlns:a16="http://schemas.microsoft.com/office/drawing/2014/main" id="{A767FBF1-C8FD-4439-86C7-63042CBD939A}"/>
               </a:ext>
             </a:extLst>
           </p:cNvPr>
@@ -5657,7 +5657,7 @@
           <p:cNvPr id="19" name="">
             <a:extLst xmlns:a="http://schemas.openxmlformats.org/drawingml/2006/main">
               <a:ext uri="{FF2B5EF4-FFF2-40B4-BE49-F238E27FC236}">
-                <a16:creationId xmlns:a16="http://schemas.microsoft.com/office/drawing/2014/main" id="{2E54B206-7654-4ACC-869E-044619B098D9}"/>
+                <a16:creationId xmlns:a16="http://schemas.microsoft.com/office/drawing/2014/main" id="{7FD9942C-9572-4863-8C18-62377E166DDF}"/>
               </a:ext>
             </a:extLst>
           </p:cNvPr>
@@ -5690,7 +5690,7 @@
           <p:cNvPr id="20" name="">
             <a:extLst xmlns:a="http://schemas.openxmlformats.org/drawingml/2006/main">
               <a:ext uri="{FF2B5EF4-FFF2-40B4-BE49-F238E27FC236}">
-                <a16:creationId xmlns:a16="http://schemas.microsoft.com/office/drawing/2014/main" id="{02FEBA5F-2A93-4441-A042-F1A73B309BAB}"/>
+                <a16:creationId xmlns:a16="http://schemas.microsoft.com/office/drawing/2014/main" id="{9010A987-A97B-4F92-B45E-48D469D756E2}"/>
               </a:ext>
             </a:extLst>
           </p:cNvPr>
@@ -5754,7 +5754,7 @@
           <p:cNvPr id="21" name="">
             <a:extLst xmlns:a="http://schemas.openxmlformats.org/drawingml/2006/main">
               <a:ext uri="{FF2B5EF4-FFF2-40B4-BE49-F238E27FC236}">
-                <a16:creationId xmlns:a16="http://schemas.microsoft.com/office/drawing/2014/main" id="{43B3316D-71CF-4250-8EF4-AB7C50D27B6E}"/>
+                <a16:creationId xmlns:a16="http://schemas.microsoft.com/office/drawing/2014/main" id="{CC367D01-8E0B-43AA-936A-45E40FD4CBCE}"/>
               </a:ext>
             </a:extLst>
           </p:cNvPr>
@@ -5787,7 +5787,7 @@
           <p:cNvPr id="22" name="">
             <a:extLst xmlns:a="http://schemas.openxmlformats.org/drawingml/2006/main">
               <a:ext uri="{FF2B5EF4-FFF2-40B4-BE49-F238E27FC236}">
-                <a16:creationId xmlns:a16="http://schemas.microsoft.com/office/drawing/2014/main" id="{81FF20FE-A6BC-4F06-8C78-A91D709A288D}"/>
+                <a16:creationId xmlns:a16="http://schemas.microsoft.com/office/drawing/2014/main" id="{D946EBB3-B1D0-4AAA-A2E1-35969B14688F}"/>
               </a:ext>
             </a:extLst>
           </p:cNvPr>
@@ -5851,7 +5851,7 @@
           <p:cNvPr id="23" name="">
             <a:extLst xmlns:a="http://schemas.openxmlformats.org/drawingml/2006/main">
               <a:ext uri="{FF2B5EF4-FFF2-40B4-BE49-F238E27FC236}">
-                <a16:creationId xmlns:a16="http://schemas.microsoft.com/office/drawing/2014/main" id="{1A36224A-EC5C-40A9-90AA-AF5FB8405814}"/>
+                <a16:creationId xmlns:a16="http://schemas.microsoft.com/office/drawing/2014/main" id="{2A3DEEF5-FD0A-43A7-A9A2-EBD9BC034C66}"/>
               </a:ext>
             </a:extLst>
           </p:cNvPr>
@@ -5884,7 +5884,7 @@
           <p:cNvPr id="24" name="">
             <a:extLst xmlns:a="http://schemas.openxmlformats.org/drawingml/2006/main">
               <a:ext uri="{FF2B5EF4-FFF2-40B4-BE49-F238E27FC236}">
-                <a16:creationId xmlns:a16="http://schemas.microsoft.com/office/drawing/2014/main" id="{5562C1FA-3DBE-4513-8039-BE17A125AFA0}"/>
+                <a16:creationId xmlns:a16="http://schemas.microsoft.com/office/drawing/2014/main" id="{86FF4761-406A-401D-8633-AE1E09367950}"/>
               </a:ext>
             </a:extLst>
           </p:cNvPr>
@@ -5948,7 +5948,7 @@
           <p:cNvPr id="25" name="">
             <a:extLst xmlns:a="http://schemas.openxmlformats.org/drawingml/2006/main">
               <a:ext uri="{FF2B5EF4-FFF2-40B4-BE49-F238E27FC236}">
-                <a16:creationId xmlns:a16="http://schemas.microsoft.com/office/drawing/2014/main" id="{59C9F016-BD50-40AE-9443-D692CE11DF18}"/>
+                <a16:creationId xmlns:a16="http://schemas.microsoft.com/office/drawing/2014/main" id="{E8B3E79C-EB91-4792-936C-06CC84466556}"/>
               </a:ext>
             </a:extLst>
           </p:cNvPr>
@@ -5981,7 +5981,7 @@
           <p:cNvPr id="26" name="">
             <a:extLst xmlns:a="http://schemas.openxmlformats.org/drawingml/2006/main">
               <a:ext uri="{FF2B5EF4-FFF2-40B4-BE49-F238E27FC236}">
-                <a16:creationId xmlns:a16="http://schemas.microsoft.com/office/drawing/2014/main" id="{A05AF948-BC9C-443A-A5CD-8C85480C0354}"/>
+                <a16:creationId xmlns:a16="http://schemas.microsoft.com/office/drawing/2014/main" id="{9E83697B-5837-487A-9566-7CBB11D72113}"/>
               </a:ext>
             </a:extLst>
           </p:cNvPr>
@@ -6045,7 +6045,7 @@
           <p:cNvPr id="27" name="">
             <a:extLst xmlns:a="http://schemas.openxmlformats.org/drawingml/2006/main">
               <a:ext uri="{FF2B5EF4-FFF2-40B4-BE49-F238E27FC236}">
-                <a16:creationId xmlns:a16="http://schemas.microsoft.com/office/drawing/2014/main" id="{14484698-D5EE-43AD-B8FE-145325B09055}"/>
+                <a16:creationId xmlns:a16="http://schemas.microsoft.com/office/drawing/2014/main" id="{6C4DB360-58B8-45CA-8178-C1100D10BDCE}"/>
               </a:ext>
             </a:extLst>
           </p:cNvPr>
@@ -6078,7 +6078,7 @@
           <p:cNvPr id="28" name="">
             <a:extLst xmlns:a="http://schemas.openxmlformats.org/drawingml/2006/main">
               <a:ext uri="{FF2B5EF4-FFF2-40B4-BE49-F238E27FC236}">
-                <a16:creationId xmlns:a16="http://schemas.microsoft.com/office/drawing/2014/main" id="{4A1B64FE-CA24-4F53-AA8A-B88297A6D47C}"/>
+                <a16:creationId xmlns:a16="http://schemas.microsoft.com/office/drawing/2014/main" id="{EF6629DD-95F7-4CDB-9F5A-3DF255E94C0C}"/>
               </a:ext>
             </a:extLst>
           </p:cNvPr>
@@ -6142,7 +6142,7 @@
           <p:cNvPr id="29" name="">
             <a:extLst xmlns:a="http://schemas.openxmlformats.org/drawingml/2006/main">
               <a:ext uri="{FF2B5EF4-FFF2-40B4-BE49-F238E27FC236}">
-                <a16:creationId xmlns:a16="http://schemas.microsoft.com/office/drawing/2014/main" id="{EA75D430-6C2E-496F-8DE9-BAAB6DD220BC}"/>
+                <a16:creationId xmlns:a16="http://schemas.microsoft.com/office/drawing/2014/main" id="{3A336436-6A0C-4E21-8E7C-E811354570E9}"/>
               </a:ext>
             </a:extLst>
           </p:cNvPr>
@@ -6206,7 +6206,7 @@
           <p:cNvPr id="30" name="">
             <a:extLst xmlns:a="http://schemas.openxmlformats.org/drawingml/2006/main">
               <a:ext uri="{FF2B5EF4-FFF2-40B4-BE49-F238E27FC236}">
-                <a16:creationId xmlns:a16="http://schemas.microsoft.com/office/drawing/2014/main" id="{EB12DB7C-019A-42DD-AAF2-77BEEC19949E}"/>
+                <a16:creationId xmlns:a16="http://schemas.microsoft.com/office/drawing/2014/main" id="{B3CC4BD0-6DC1-4355-8B6B-5FFF63E9AE57}"/>
               </a:ext>
             </a:extLst>
           </p:cNvPr>
@@ -6239,7 +6239,7 @@
           <p:cNvPr id="31" name="">
             <a:extLst xmlns:a="http://schemas.openxmlformats.org/drawingml/2006/main">
               <a:ext uri="{FF2B5EF4-FFF2-40B4-BE49-F238E27FC236}">
-                <a16:creationId xmlns:a16="http://schemas.microsoft.com/office/drawing/2014/main" id="{C42C7597-92A7-4112-85AF-AA935DCA847A}"/>
+                <a16:creationId xmlns:a16="http://schemas.microsoft.com/office/drawing/2014/main" id="{6DA70E32-B1D2-41A8-9F10-7DFDF2A9D009}"/>
               </a:ext>
             </a:extLst>
           </p:cNvPr>
@@ -6303,7 +6303,7 @@
           <p:cNvPr id="32" name="">
             <a:extLst xmlns:a="http://schemas.openxmlformats.org/drawingml/2006/main">
               <a:ext uri="{FF2B5EF4-FFF2-40B4-BE49-F238E27FC236}">
-                <a16:creationId xmlns:a16="http://schemas.microsoft.com/office/drawing/2014/main" id="{CC148296-9810-401F-83D1-FCCF12E6DC05}"/>
+                <a16:creationId xmlns:a16="http://schemas.microsoft.com/office/drawing/2014/main" id="{507C21F4-DBD4-4C07-866E-F2E4549BB395}"/>
               </a:ext>
             </a:extLst>
           </p:cNvPr>
@@ -6367,7 +6367,7 @@
           <p:cNvPr id="33" name="">
             <a:extLst xmlns:a="http://schemas.openxmlformats.org/drawingml/2006/main">
               <a:ext uri="{FF2B5EF4-FFF2-40B4-BE49-F238E27FC236}">
-                <a16:creationId xmlns:a16="http://schemas.microsoft.com/office/drawing/2014/main" id="{8BEE0B69-F7C3-4028-845D-92040A024E64}"/>
+                <a16:creationId xmlns:a16="http://schemas.microsoft.com/office/drawing/2014/main" id="{D100286A-A4F3-444C-A8F5-320644138DEF}"/>
               </a:ext>
             </a:extLst>
           </p:cNvPr>
@@ -6431,7 +6431,7 @@
           <p:cNvPr id="34" name="">
             <a:extLst xmlns:a="http://schemas.openxmlformats.org/drawingml/2006/main">
               <a:ext uri="{FF2B5EF4-FFF2-40B4-BE49-F238E27FC236}">
-                <a16:creationId xmlns:a16="http://schemas.microsoft.com/office/drawing/2014/main" id="{41E2BF7B-69AB-43DA-8300-BDA1C1880FDB}"/>
+                <a16:creationId xmlns:a16="http://schemas.microsoft.com/office/drawing/2014/main" id="{66351F83-BF21-4FE4-BC3E-9D8463EA5D85}"/>
               </a:ext>
             </a:extLst>
           </p:cNvPr>
@@ -6493,7 +6493,7 @@
     </p:spTree>
     <p:extLst>
       <p:ext uri="{BB962C8B-B14F-4D97-AF65-F5344CB8AC3E}">
-        <p14:creationId xmlns:p14="http://schemas.microsoft.com/office/powerpoint/2010/main" val="1226828108"/>
+        <p14:creationId xmlns:p14="http://schemas.microsoft.com/office/powerpoint/2010/main" val="330338563"/>
       </p:ext>
     </p:extLst>
   </p:cSld>
@@ -6517,7 +6517,7 @@
           <p:cNvPr id="1" name="">
             <a:extLst xmlns:a="http://schemas.openxmlformats.org/drawingml/2006/main">
               <a:ext uri="{FF2B5EF4-FFF2-40B4-BE49-F238E27FC236}">
-                <a16:creationId xmlns:a16="http://schemas.microsoft.com/office/drawing/2014/main" id="{279F40F8-AEF6-4112-AC20-DF1678E4BECF}"/>
+                <a16:creationId xmlns:a16="http://schemas.microsoft.com/office/drawing/2014/main" id="{D9821D43-28E6-4520-A6DC-12336B0306AF}"/>
               </a:ext>
             </a:extLst>
           </p:cNvPr>
@@ -6552,7 +6552,7 @@
           <p:cNvPr id="2" name="">
             <a:extLst xmlns:a="http://schemas.openxmlformats.org/drawingml/2006/main">
               <a:ext uri="{FF2B5EF4-FFF2-40B4-BE49-F238E27FC236}">
-                <a16:creationId xmlns:a16="http://schemas.microsoft.com/office/drawing/2014/main" id="{D5735F3D-81D1-408C-8C45-019122727320}"/>
+                <a16:creationId xmlns:a16="http://schemas.microsoft.com/office/drawing/2014/main" id="{EBEFDA83-72D0-4333-88EC-0BF9D0603368}"/>
               </a:ext>
             </a:extLst>
           </p:cNvPr>
@@ -6587,7 +6587,7 @@
           <p:cNvPr id="3" name="">
             <a:extLst xmlns:a="http://schemas.openxmlformats.org/drawingml/2006/main">
               <a:ext uri="{FF2B5EF4-FFF2-40B4-BE49-F238E27FC236}">
-                <a16:creationId xmlns:a16="http://schemas.microsoft.com/office/drawing/2014/main" id="{3D8E7497-702D-4750-A884-8900305A7277}"/>
+                <a16:creationId xmlns:a16="http://schemas.microsoft.com/office/drawing/2014/main" id="{8AEB8BC9-4AF3-42D9-9955-4F81ECC05EF6}"/>
               </a:ext>
             </a:extLst>
           </p:cNvPr>
@@ -6651,7 +6651,7 @@
           <p:cNvPr id="4" name="">
             <a:extLst xmlns:a="http://schemas.openxmlformats.org/drawingml/2006/main">
               <a:ext uri="{FF2B5EF4-FFF2-40B4-BE49-F238E27FC236}">
-                <a16:creationId xmlns:a16="http://schemas.microsoft.com/office/drawing/2014/main" id="{86AF708E-5154-4B78-8833-7315764A761F}"/>
+                <a16:creationId xmlns:a16="http://schemas.microsoft.com/office/drawing/2014/main" id="{65E1E589-B9D8-4CE6-A971-77361ADE90C7}"/>
               </a:ext>
             </a:extLst>
           </p:cNvPr>
@@ -6715,7 +6715,7 @@
           <p:cNvPr id="5" name="">
             <a:extLst xmlns:a="http://schemas.openxmlformats.org/drawingml/2006/main">
               <a:ext uri="{FF2B5EF4-FFF2-40B4-BE49-F238E27FC236}">
-                <a16:creationId xmlns:a16="http://schemas.microsoft.com/office/drawing/2014/main" id="{7038996E-2983-49DD-85C2-BDD3C3CD8561}"/>
+                <a16:creationId xmlns:a16="http://schemas.microsoft.com/office/drawing/2014/main" id="{04964BBA-9D4B-4625-8713-FBA2A64CA2DB}"/>
               </a:ext>
             </a:extLst>
           </p:cNvPr>
@@ -6748,7 +6748,7 @@
           <p:cNvPr id="6" name="">
             <a:extLst xmlns:a="http://schemas.openxmlformats.org/drawingml/2006/main">
               <a:ext uri="{FF2B5EF4-FFF2-40B4-BE49-F238E27FC236}">
-                <a16:creationId xmlns:a16="http://schemas.microsoft.com/office/drawing/2014/main" id="{8EB4CEB1-094E-4925-854B-D4ADCC04F35A}"/>
+                <a16:creationId xmlns:a16="http://schemas.microsoft.com/office/drawing/2014/main" id="{AA341A81-180A-4C4C-B670-AE77409A0E43}"/>
               </a:ext>
             </a:extLst>
           </p:cNvPr>
@@ -6812,7 +6812,7 @@
           <p:cNvPr id="7" name="">
             <a:extLst xmlns:a="http://schemas.openxmlformats.org/drawingml/2006/main">
               <a:ext uri="{FF2B5EF4-FFF2-40B4-BE49-F238E27FC236}">
-                <a16:creationId xmlns:a16="http://schemas.microsoft.com/office/drawing/2014/main" id="{EE5A1F50-9FDE-4D35-8192-99C3FD37A59C}"/>
+                <a16:creationId xmlns:a16="http://schemas.microsoft.com/office/drawing/2014/main" id="{426E9ABF-6496-430A-94F4-23925194EE88}"/>
               </a:ext>
             </a:extLst>
           </p:cNvPr>
@@ -6876,7 +6876,7 @@
           <p:cNvPr id="8" name="">
             <a:extLst xmlns:a="http://schemas.openxmlformats.org/drawingml/2006/main">
               <a:ext uri="{FF2B5EF4-FFF2-40B4-BE49-F238E27FC236}">
-                <a16:creationId xmlns:a16="http://schemas.microsoft.com/office/drawing/2014/main" id="{307C7D1D-7032-4627-AD1C-573212AEC0AC}"/>
+                <a16:creationId xmlns:a16="http://schemas.microsoft.com/office/drawing/2014/main" id="{9D001470-F170-4EE7-89A1-9A7604074052}"/>
               </a:ext>
             </a:extLst>
           </p:cNvPr>
@@ -6909,7 +6909,7 @@
           <p:cNvPr id="9" name="">
             <a:extLst xmlns:a="http://schemas.openxmlformats.org/drawingml/2006/main">
               <a:ext uri="{FF2B5EF4-FFF2-40B4-BE49-F238E27FC236}">
-                <a16:creationId xmlns:a16="http://schemas.microsoft.com/office/drawing/2014/main" id="{0EFFB837-F905-4A40-BEFD-314671522BEB}"/>
+                <a16:creationId xmlns:a16="http://schemas.microsoft.com/office/drawing/2014/main" id="{91FCD50C-28B6-4025-8400-79E249C7E3E2}"/>
               </a:ext>
             </a:extLst>
           </p:cNvPr>
@@ -6973,7 +6973,7 @@
           <p:cNvPr id="10" name="">
             <a:extLst xmlns:a="http://schemas.openxmlformats.org/drawingml/2006/main">
               <a:ext uri="{FF2B5EF4-FFF2-40B4-BE49-F238E27FC236}">
-                <a16:creationId xmlns:a16="http://schemas.microsoft.com/office/drawing/2014/main" id="{91C95ED1-61D0-4C69-9760-4FA0A85F85BC}"/>
+                <a16:creationId xmlns:a16="http://schemas.microsoft.com/office/drawing/2014/main" id="{99BF9B2E-228A-416B-93B9-E2106D986244}"/>
               </a:ext>
             </a:extLst>
           </p:cNvPr>
@@ -7037,7 +7037,7 @@
           <p:cNvPr id="11" name="">
             <a:extLst xmlns:a="http://schemas.openxmlformats.org/drawingml/2006/main">
               <a:ext uri="{FF2B5EF4-FFF2-40B4-BE49-F238E27FC236}">
-                <a16:creationId xmlns:a16="http://schemas.microsoft.com/office/drawing/2014/main" id="{D2683A75-537D-47FF-A1C2-681D17936F28}"/>
+                <a16:creationId xmlns:a16="http://schemas.microsoft.com/office/drawing/2014/main" id="{5A8C1C43-9859-40DF-BD5A-75C06F0EC22E}"/>
               </a:ext>
             </a:extLst>
           </p:cNvPr>
@@ -7070,7 +7070,7 @@
           <p:cNvPr id="12" name="">
             <a:extLst xmlns:a="http://schemas.openxmlformats.org/drawingml/2006/main">
               <a:ext uri="{FF2B5EF4-FFF2-40B4-BE49-F238E27FC236}">
-                <a16:creationId xmlns:a16="http://schemas.microsoft.com/office/drawing/2014/main" id="{A81ADDA6-192C-4B34-8616-EE7AB74B47ED}"/>
+                <a16:creationId xmlns:a16="http://schemas.microsoft.com/office/drawing/2014/main" id="{FADE272F-80CC-44F1-892E-8DCC43E91607}"/>
               </a:ext>
             </a:extLst>
           </p:cNvPr>
@@ -7134,7 +7134,7 @@
           <p:cNvPr id="13" name="">
             <a:extLst xmlns:a="http://schemas.openxmlformats.org/drawingml/2006/main">
               <a:ext uri="{FF2B5EF4-FFF2-40B4-BE49-F238E27FC236}">
-                <a16:creationId xmlns:a16="http://schemas.microsoft.com/office/drawing/2014/main" id="{37C329CA-1864-4AB7-9C08-29BE740BCB02}"/>
+                <a16:creationId xmlns:a16="http://schemas.microsoft.com/office/drawing/2014/main" id="{8BD9A6F7-53C0-4296-BD0C-E43B473FBAAA}"/>
               </a:ext>
             </a:extLst>
           </p:cNvPr>
@@ -7198,7 +7198,7 @@
           <p:cNvPr id="14" name="">
             <a:extLst xmlns:a="http://schemas.openxmlformats.org/drawingml/2006/main">
               <a:ext uri="{FF2B5EF4-FFF2-40B4-BE49-F238E27FC236}">
-                <a16:creationId xmlns:a16="http://schemas.microsoft.com/office/drawing/2014/main" id="{D4114EB6-BC93-47F9-8DE5-65C351B25FDB}"/>
+                <a16:creationId xmlns:a16="http://schemas.microsoft.com/office/drawing/2014/main" id="{B12E8785-99B3-472C-A173-EB3F5F0FB66D}"/>
               </a:ext>
             </a:extLst>
           </p:cNvPr>
@@ -7231,7 +7231,7 @@
           <p:cNvPr id="15" name="">
             <a:extLst xmlns:a="http://schemas.openxmlformats.org/drawingml/2006/main">
               <a:ext uri="{FF2B5EF4-FFF2-40B4-BE49-F238E27FC236}">
-                <a16:creationId xmlns:a16="http://schemas.microsoft.com/office/drawing/2014/main" id="{1844BDBF-FF16-4327-94B8-AFCB28CB7AEA}"/>
+                <a16:creationId xmlns:a16="http://schemas.microsoft.com/office/drawing/2014/main" id="{5407B8D5-B70B-4103-8CC2-27F8A41B362B}"/>
               </a:ext>
             </a:extLst>
           </p:cNvPr>
@@ -7295,7 +7295,7 @@
           <p:cNvPr id="16" name="">
             <a:extLst xmlns:a="http://schemas.openxmlformats.org/drawingml/2006/main">
               <a:ext uri="{FF2B5EF4-FFF2-40B4-BE49-F238E27FC236}">
-                <a16:creationId xmlns:a16="http://schemas.microsoft.com/office/drawing/2014/main" id="{2DC5FCBA-83E8-4FA1-B29E-F803E0494024}"/>
+                <a16:creationId xmlns:a16="http://schemas.microsoft.com/office/drawing/2014/main" id="{501BA1B2-FEFD-4694-AFF6-C5B24ED48B02}"/>
               </a:ext>
             </a:extLst>
           </p:cNvPr>
@@ -7359,7 +7359,7 @@
           <p:cNvPr id="17" name="">
             <a:extLst xmlns:a="http://schemas.openxmlformats.org/drawingml/2006/main">
               <a:ext uri="{FF2B5EF4-FFF2-40B4-BE49-F238E27FC236}">
-                <a16:creationId xmlns:a16="http://schemas.microsoft.com/office/drawing/2014/main" id="{168472B7-0793-471A-A7C3-9BF08AB79F87}"/>
+                <a16:creationId xmlns:a16="http://schemas.microsoft.com/office/drawing/2014/main" id="{920137D0-3D49-44F6-9748-8EB93D7CB706}"/>
               </a:ext>
             </a:extLst>
           </p:cNvPr>
@@ -7392,7 +7392,7 @@
           <p:cNvPr id="18" name="">
             <a:extLst xmlns:a="http://schemas.openxmlformats.org/drawingml/2006/main">
               <a:ext uri="{FF2B5EF4-FFF2-40B4-BE49-F238E27FC236}">
-                <a16:creationId xmlns:a16="http://schemas.microsoft.com/office/drawing/2014/main" id="{4B524EE8-260D-4C22-9DF7-65BA217E79C6}"/>
+                <a16:creationId xmlns:a16="http://schemas.microsoft.com/office/drawing/2014/main" id="{7B5889EB-3CB3-4A7C-9E25-C0E019D082E6}"/>
               </a:ext>
             </a:extLst>
           </p:cNvPr>
@@ -7456,7 +7456,7 @@
           <p:cNvPr id="19" name="">
             <a:extLst xmlns:a="http://schemas.openxmlformats.org/drawingml/2006/main">
               <a:ext uri="{FF2B5EF4-FFF2-40B4-BE49-F238E27FC236}">
-                <a16:creationId xmlns:a16="http://schemas.microsoft.com/office/drawing/2014/main" id="{5F6B4605-BAA9-4CC7-89AC-65990B8F2113}"/>
+                <a16:creationId xmlns:a16="http://schemas.microsoft.com/office/drawing/2014/main" id="{57D17C82-D360-423C-8FED-F01618E123CB}"/>
               </a:ext>
             </a:extLst>
           </p:cNvPr>
@@ -7520,7 +7520,7 @@
           <p:cNvPr id="20" name="">
             <a:extLst xmlns:a="http://schemas.openxmlformats.org/drawingml/2006/main">
               <a:ext uri="{FF2B5EF4-FFF2-40B4-BE49-F238E27FC236}">
-                <a16:creationId xmlns:a16="http://schemas.microsoft.com/office/drawing/2014/main" id="{2D49F379-6AF5-49F7-AE90-196D2563B18F}"/>
+                <a16:creationId xmlns:a16="http://schemas.microsoft.com/office/drawing/2014/main" id="{1CC58518-7732-4624-97EE-B6D38027DDD8}"/>
               </a:ext>
             </a:extLst>
           </p:cNvPr>
@@ -7553,7 +7553,7 @@
           <p:cNvPr id="21" name="">
             <a:extLst xmlns:a="http://schemas.openxmlformats.org/drawingml/2006/main">
               <a:ext uri="{FF2B5EF4-FFF2-40B4-BE49-F238E27FC236}">
-                <a16:creationId xmlns:a16="http://schemas.microsoft.com/office/drawing/2014/main" id="{7920AE67-DE16-46C6-966D-02E6AE08C27B}"/>
+                <a16:creationId xmlns:a16="http://schemas.microsoft.com/office/drawing/2014/main" id="{3782172D-86DB-4BC5-9460-429638DA8ED7}"/>
               </a:ext>
             </a:extLst>
           </p:cNvPr>
@@ -7617,7 +7617,7 @@
           <p:cNvPr id="22" name="">
             <a:extLst xmlns:a="http://schemas.openxmlformats.org/drawingml/2006/main">
               <a:ext uri="{FF2B5EF4-FFF2-40B4-BE49-F238E27FC236}">
-                <a16:creationId xmlns:a16="http://schemas.microsoft.com/office/drawing/2014/main" id="{58623D87-1F32-4C45-A15B-8995195746F5}"/>
+                <a16:creationId xmlns:a16="http://schemas.microsoft.com/office/drawing/2014/main" id="{F4C7E8DC-C0F8-42E7-8521-EC3A5B916E0A}"/>
               </a:ext>
             </a:extLst>
           </p:cNvPr>
@@ -7681,7 +7681,7 @@
           <p:cNvPr id="23" name="">
             <a:extLst xmlns:a="http://schemas.openxmlformats.org/drawingml/2006/main">
               <a:ext uri="{FF2B5EF4-FFF2-40B4-BE49-F238E27FC236}">
-                <a16:creationId xmlns:a16="http://schemas.microsoft.com/office/drawing/2014/main" id="{3B8AAF41-A3F0-4057-8547-D23FF8B15EAD}"/>
+                <a16:creationId xmlns:a16="http://schemas.microsoft.com/office/drawing/2014/main" id="{AC048D63-5398-4A7C-B433-D56ED67C90C1}"/>
               </a:ext>
             </a:extLst>
           </p:cNvPr>
@@ -7745,7 +7745,7 @@
           <p:cNvPr id="24" name="">
             <a:extLst xmlns:a="http://schemas.openxmlformats.org/drawingml/2006/main">
               <a:ext uri="{FF2B5EF4-FFF2-40B4-BE49-F238E27FC236}">
-                <a16:creationId xmlns:a16="http://schemas.microsoft.com/office/drawing/2014/main" id="{0E586E35-3680-4DE3-871E-6095396E3F4F}"/>
+                <a16:creationId xmlns:a16="http://schemas.microsoft.com/office/drawing/2014/main" id="{550B9E1E-26CC-4987-8CBE-720A019BCC88}"/>
               </a:ext>
             </a:extLst>
           </p:cNvPr>
@@ -7809,7 +7809,7 @@
           <p:cNvPr id="25" name="">
             <a:extLst xmlns:a="http://schemas.openxmlformats.org/drawingml/2006/main">
               <a:ext uri="{FF2B5EF4-FFF2-40B4-BE49-F238E27FC236}">
-                <a16:creationId xmlns:a16="http://schemas.microsoft.com/office/drawing/2014/main" id="{CDB80A03-14B4-4A07-B13B-13885701AB46}"/>
+                <a16:creationId xmlns:a16="http://schemas.microsoft.com/office/drawing/2014/main" id="{883DD98A-45DB-46DC-8AB0-306CF3E8DD79}"/>
               </a:ext>
             </a:extLst>
           </p:cNvPr>
@@ -7871,7 +7871,7 @@
     </p:spTree>
     <p:extLst>
       <p:ext uri="{BB962C8B-B14F-4D97-AF65-F5344CB8AC3E}">
-        <p14:creationId xmlns:p14="http://schemas.microsoft.com/office/powerpoint/2010/main" val="379747219"/>
+        <p14:creationId xmlns:p14="http://schemas.microsoft.com/office/powerpoint/2010/main" val="1522555358"/>
       </p:ext>
     </p:extLst>
   </p:cSld>
@@ -7895,7 +7895,7 @@
           <p:cNvPr id="1" name="">
             <a:extLst xmlns:a="http://schemas.openxmlformats.org/drawingml/2006/main">
               <a:ext uri="{FF2B5EF4-FFF2-40B4-BE49-F238E27FC236}">
-                <a16:creationId xmlns:a16="http://schemas.microsoft.com/office/drawing/2014/main" id="{D02878DF-2A2F-452B-A1D5-6D7AF9CAEF0A}"/>
+                <a16:creationId xmlns:a16="http://schemas.microsoft.com/office/drawing/2014/main" id="{FE5627C3-DDA0-4ACC-86E4-5F60234FF973}"/>
               </a:ext>
             </a:extLst>
           </p:cNvPr>
@@ -7930,7 +7930,7 @@
           <p:cNvPr id="2" name="">
             <a:extLst xmlns:a="http://schemas.openxmlformats.org/drawingml/2006/main">
               <a:ext uri="{FF2B5EF4-FFF2-40B4-BE49-F238E27FC236}">
-                <a16:creationId xmlns:a16="http://schemas.microsoft.com/office/drawing/2014/main" id="{62336139-D7BA-4060-A8DA-AC8C6C58C5BE}"/>
+                <a16:creationId xmlns:a16="http://schemas.microsoft.com/office/drawing/2014/main" id="{B6D24767-D4D2-464E-834C-A2E0D1566494}"/>
               </a:ext>
             </a:extLst>
           </p:cNvPr>
@@ -7965,7 +7965,7 @@
           <p:cNvPr id="3" name="">
             <a:extLst xmlns:a="http://schemas.openxmlformats.org/drawingml/2006/main">
               <a:ext uri="{FF2B5EF4-FFF2-40B4-BE49-F238E27FC236}">
-                <a16:creationId xmlns:a16="http://schemas.microsoft.com/office/drawing/2014/main" id="{0347F213-F122-4B19-B461-B3E5A9F04ACB}"/>
+                <a16:creationId xmlns:a16="http://schemas.microsoft.com/office/drawing/2014/main" id="{BFB140F8-800B-4995-AF07-ADE1BB3589CB}"/>
               </a:ext>
             </a:extLst>
           </p:cNvPr>
@@ -8029,7 +8029,7 @@
           <p:cNvPr id="4" name="">
             <a:extLst xmlns:a="http://schemas.openxmlformats.org/drawingml/2006/main">
               <a:ext uri="{FF2B5EF4-FFF2-40B4-BE49-F238E27FC236}">
-                <a16:creationId xmlns:a16="http://schemas.microsoft.com/office/drawing/2014/main" id="{DD1709B3-B595-4B93-BDD4-64C4FB574EAE}"/>
+                <a16:creationId xmlns:a16="http://schemas.microsoft.com/office/drawing/2014/main" id="{31437ECB-E935-491C-9243-48A92CC5F8EB}"/>
               </a:ext>
             </a:extLst>
           </p:cNvPr>
@@ -8093,7 +8093,7 @@
           <p:cNvPr id="5" name="">
             <a:extLst xmlns:a="http://schemas.openxmlformats.org/drawingml/2006/main">
               <a:ext uri="{FF2B5EF4-FFF2-40B4-BE49-F238E27FC236}">
-                <a16:creationId xmlns:a16="http://schemas.microsoft.com/office/drawing/2014/main" id="{B84ABCC4-B904-4F4D-B863-0A787DF8416F}"/>
+                <a16:creationId xmlns:a16="http://schemas.microsoft.com/office/drawing/2014/main" id="{CA0789E2-4069-468E-8081-24D01D394804}"/>
               </a:ext>
             </a:extLst>
           </p:cNvPr>
@@ -8126,7 +8126,7 @@
           <p:cNvPr id="6" name="">
             <a:extLst xmlns:a="http://schemas.openxmlformats.org/drawingml/2006/main">
               <a:ext uri="{FF2B5EF4-FFF2-40B4-BE49-F238E27FC236}">
-                <a16:creationId xmlns:a16="http://schemas.microsoft.com/office/drawing/2014/main" id="{1C525BDC-8973-4A9C-A876-240BA09F524A}"/>
+                <a16:creationId xmlns:a16="http://schemas.microsoft.com/office/drawing/2014/main" id="{0AD423EE-5C31-4612-8783-B05A0271E7C9}"/>
               </a:ext>
             </a:extLst>
           </p:cNvPr>
@@ -8161,7 +8161,7 @@
           <p:cNvPr id="7" name="">
             <a:extLst xmlns:a="http://schemas.openxmlformats.org/drawingml/2006/main">
               <a:ext uri="{FF2B5EF4-FFF2-40B4-BE49-F238E27FC236}">
-                <a16:creationId xmlns:a16="http://schemas.microsoft.com/office/drawing/2014/main" id="{1C97785C-5B5B-4760-B201-99731DF4A018}"/>
+                <a16:creationId xmlns:a16="http://schemas.microsoft.com/office/drawing/2014/main" id="{8A2DFAA4-ACE1-47ED-8718-D170447A6DF4}"/>
               </a:ext>
             </a:extLst>
           </p:cNvPr>
@@ -8225,7 +8225,7 @@
           <p:cNvPr id="8" name="">
             <a:extLst xmlns:a="http://schemas.openxmlformats.org/drawingml/2006/main">
               <a:ext uri="{FF2B5EF4-FFF2-40B4-BE49-F238E27FC236}">
-                <a16:creationId xmlns:a16="http://schemas.microsoft.com/office/drawing/2014/main" id="{B67C3978-D01B-42FD-A7FB-C2F245CF8B79}"/>
+                <a16:creationId xmlns:a16="http://schemas.microsoft.com/office/drawing/2014/main" id="{AF4AAE22-69BC-4010-852D-A401EDF26114}"/>
               </a:ext>
             </a:extLst>
           </p:cNvPr>
@@ -8289,7 +8289,7 @@
           <p:cNvPr id="9" name="">
             <a:extLst xmlns:a="http://schemas.openxmlformats.org/drawingml/2006/main">
               <a:ext uri="{FF2B5EF4-FFF2-40B4-BE49-F238E27FC236}">
-                <a16:creationId xmlns:a16="http://schemas.microsoft.com/office/drawing/2014/main" id="{2E796338-ED2C-4C30-9FF1-C0478DC8F569}"/>
+                <a16:creationId xmlns:a16="http://schemas.microsoft.com/office/drawing/2014/main" id="{9410251A-5D08-4010-8BB6-649D1BA9639C}"/>
               </a:ext>
             </a:extLst>
           </p:cNvPr>
@@ -8322,7 +8322,7 @@
           <p:cNvPr id="10" name="">
             <a:extLst xmlns:a="http://schemas.openxmlformats.org/drawingml/2006/main">
               <a:ext uri="{FF2B5EF4-FFF2-40B4-BE49-F238E27FC236}">
-                <a16:creationId xmlns:a16="http://schemas.microsoft.com/office/drawing/2014/main" id="{3CBB53D5-C6CE-476D-A44F-626556FE9435}"/>
+                <a16:creationId xmlns:a16="http://schemas.microsoft.com/office/drawing/2014/main" id="{1F2FAB4D-BD15-4F80-B6EB-D82506CCE09F}"/>
               </a:ext>
             </a:extLst>
           </p:cNvPr>
@@ -8357,7 +8357,7 @@
           <p:cNvPr id="11" name="">
             <a:extLst xmlns:a="http://schemas.openxmlformats.org/drawingml/2006/main">
               <a:ext uri="{FF2B5EF4-FFF2-40B4-BE49-F238E27FC236}">
-                <a16:creationId xmlns:a16="http://schemas.microsoft.com/office/drawing/2014/main" id="{F82802D0-B139-49B4-A689-76C4414946B7}"/>
+                <a16:creationId xmlns:a16="http://schemas.microsoft.com/office/drawing/2014/main" id="{71B187A9-65B9-4617-9D35-599BAC4A011F}"/>
               </a:ext>
             </a:extLst>
           </p:cNvPr>
@@ -8421,7 +8421,7 @@
           <p:cNvPr id="12" name="">
             <a:extLst xmlns:a="http://schemas.openxmlformats.org/drawingml/2006/main">
               <a:ext uri="{FF2B5EF4-FFF2-40B4-BE49-F238E27FC236}">
-                <a16:creationId xmlns:a16="http://schemas.microsoft.com/office/drawing/2014/main" id="{2B7D0717-24BC-4810-BB87-59EB9538B03E}"/>
+                <a16:creationId xmlns:a16="http://schemas.microsoft.com/office/drawing/2014/main" id="{2A0094E9-0D7C-4DD6-B801-DE0FC28AD9E9}"/>
               </a:ext>
             </a:extLst>
           </p:cNvPr>
@@ -8485,7 +8485,7 @@
           <p:cNvPr id="13" name="">
             <a:extLst xmlns:a="http://schemas.openxmlformats.org/drawingml/2006/main">
               <a:ext uri="{FF2B5EF4-FFF2-40B4-BE49-F238E27FC236}">
-                <a16:creationId xmlns:a16="http://schemas.microsoft.com/office/drawing/2014/main" id="{EABB0D66-3E49-4955-9D81-E56418487CE0}"/>
+                <a16:creationId xmlns:a16="http://schemas.microsoft.com/office/drawing/2014/main" id="{0F1B9209-760A-4566-9160-5603DA02C086}"/>
               </a:ext>
             </a:extLst>
           </p:cNvPr>
@@ -8518,7 +8518,7 @@
           <p:cNvPr id="14" name="">
             <a:extLst xmlns:a="http://schemas.openxmlformats.org/drawingml/2006/main">
               <a:ext uri="{FF2B5EF4-FFF2-40B4-BE49-F238E27FC236}">
-                <a16:creationId xmlns:a16="http://schemas.microsoft.com/office/drawing/2014/main" id="{DBA1814B-55D4-4361-A55B-A92B46AF6CB2}"/>
+                <a16:creationId xmlns:a16="http://schemas.microsoft.com/office/drawing/2014/main" id="{D125343D-2B3B-4E69-85DC-FB0BC5111F6E}"/>
               </a:ext>
             </a:extLst>
           </p:cNvPr>
@@ -8553,7 +8553,7 @@
           <p:cNvPr id="15" name="">
             <a:extLst xmlns:a="http://schemas.openxmlformats.org/drawingml/2006/main">
               <a:ext uri="{FF2B5EF4-FFF2-40B4-BE49-F238E27FC236}">
-                <a16:creationId xmlns:a16="http://schemas.microsoft.com/office/drawing/2014/main" id="{C6935569-B5E6-4BA1-8536-4070F96A9B8D}"/>
+                <a16:creationId xmlns:a16="http://schemas.microsoft.com/office/drawing/2014/main" id="{4B95AE1D-8061-4366-8314-85DA27563DA4}"/>
               </a:ext>
             </a:extLst>
           </p:cNvPr>
@@ -8617,7 +8617,7 @@
           <p:cNvPr id="16" name="">
             <a:extLst xmlns:a="http://schemas.openxmlformats.org/drawingml/2006/main">
               <a:ext uri="{FF2B5EF4-FFF2-40B4-BE49-F238E27FC236}">
-                <a16:creationId xmlns:a16="http://schemas.microsoft.com/office/drawing/2014/main" id="{BA9F39DC-6D86-434B-A5A2-0B5DBFF6BB85}"/>
+                <a16:creationId xmlns:a16="http://schemas.microsoft.com/office/drawing/2014/main" id="{6C901FF5-F97E-4942-8769-BB62947CF113}"/>
               </a:ext>
             </a:extLst>
           </p:cNvPr>
@@ -8681,7 +8681,7 @@
           <p:cNvPr id="17" name="">
             <a:extLst xmlns:a="http://schemas.openxmlformats.org/drawingml/2006/main">
               <a:ext uri="{FF2B5EF4-FFF2-40B4-BE49-F238E27FC236}">
-                <a16:creationId xmlns:a16="http://schemas.microsoft.com/office/drawing/2014/main" id="{56DFCBFE-C4ED-43C2-A05D-BE0C65FBD4BE}"/>
+                <a16:creationId xmlns:a16="http://schemas.microsoft.com/office/drawing/2014/main" id="{5A89BCA5-4FF8-4725-8D34-90F9394B97B8}"/>
               </a:ext>
             </a:extLst>
           </p:cNvPr>
@@ -8714,7 +8714,7 @@
           <p:cNvPr id="18" name="">
             <a:extLst xmlns:a="http://schemas.openxmlformats.org/drawingml/2006/main">
               <a:ext uri="{FF2B5EF4-FFF2-40B4-BE49-F238E27FC236}">
-                <a16:creationId xmlns:a16="http://schemas.microsoft.com/office/drawing/2014/main" id="{F838844C-3E87-4617-B372-829056A68D4E}"/>
+                <a16:creationId xmlns:a16="http://schemas.microsoft.com/office/drawing/2014/main" id="{3685F800-024C-462F-9B47-D07D964F1E2E}"/>
               </a:ext>
             </a:extLst>
           </p:cNvPr>
@@ -8749,7 +8749,7 @@
           <p:cNvPr id="19" name="">
             <a:extLst xmlns:a="http://schemas.openxmlformats.org/drawingml/2006/main">
               <a:ext uri="{FF2B5EF4-FFF2-40B4-BE49-F238E27FC236}">
-                <a16:creationId xmlns:a16="http://schemas.microsoft.com/office/drawing/2014/main" id="{D9EA8D77-3183-4DD8-81F6-034E9CEE8E38}"/>
+                <a16:creationId xmlns:a16="http://schemas.microsoft.com/office/drawing/2014/main" id="{9E2BDC4D-5856-41DC-AB5C-B9405B72CC55}"/>
               </a:ext>
             </a:extLst>
           </p:cNvPr>
@@ -8813,7 +8813,7 @@
           <p:cNvPr id="20" name="">
             <a:extLst xmlns:a="http://schemas.openxmlformats.org/drawingml/2006/main">
               <a:ext uri="{FF2B5EF4-FFF2-40B4-BE49-F238E27FC236}">
-                <a16:creationId xmlns:a16="http://schemas.microsoft.com/office/drawing/2014/main" id="{1F18E44E-EB9E-4361-9819-E2DC7DCA7D41}"/>
+                <a16:creationId xmlns:a16="http://schemas.microsoft.com/office/drawing/2014/main" id="{D8A5E8E3-88ED-4716-8C4F-429AAA2AE5B8}"/>
               </a:ext>
             </a:extLst>
           </p:cNvPr>
@@ -8877,7 +8877,7 @@
           <p:cNvPr id="21" name="">
             <a:extLst xmlns:a="http://schemas.openxmlformats.org/drawingml/2006/main">
               <a:ext uri="{FF2B5EF4-FFF2-40B4-BE49-F238E27FC236}">
-                <a16:creationId xmlns:a16="http://schemas.microsoft.com/office/drawing/2014/main" id="{050646E5-393A-4FF8-B232-FE6BD9D9329F}"/>
+                <a16:creationId xmlns:a16="http://schemas.microsoft.com/office/drawing/2014/main" id="{E01C5CE8-D468-41AA-92DB-7CE5AA9EED1C}"/>
               </a:ext>
             </a:extLst>
           </p:cNvPr>
@@ -8910,7 +8910,7 @@
           <p:cNvPr id="22" name="">
             <a:extLst xmlns:a="http://schemas.openxmlformats.org/drawingml/2006/main">
               <a:ext uri="{FF2B5EF4-FFF2-40B4-BE49-F238E27FC236}">
-                <a16:creationId xmlns:a16="http://schemas.microsoft.com/office/drawing/2014/main" id="{764AD381-B1C3-4D57-9F96-042B990B002A}"/>
+                <a16:creationId xmlns:a16="http://schemas.microsoft.com/office/drawing/2014/main" id="{21B460E7-8AD0-4964-A3A1-E424996589AD}"/>
               </a:ext>
             </a:extLst>
           </p:cNvPr>
@@ -8974,7 +8974,7 @@
           <p:cNvPr id="23" name="">
             <a:extLst xmlns:a="http://schemas.openxmlformats.org/drawingml/2006/main">
               <a:ext uri="{FF2B5EF4-FFF2-40B4-BE49-F238E27FC236}">
-                <a16:creationId xmlns:a16="http://schemas.microsoft.com/office/drawing/2014/main" id="{B61BDBF2-DC90-4C2D-8F10-6427E958B5B2}"/>
+                <a16:creationId xmlns:a16="http://schemas.microsoft.com/office/drawing/2014/main" id="{D6C22AB7-FF7B-46EB-A304-D007079F5B6A}"/>
               </a:ext>
             </a:extLst>
           </p:cNvPr>
@@ -9007,7 +9007,7 @@
           <p:cNvPr id="24" name="">
             <a:extLst xmlns:a="http://schemas.openxmlformats.org/drawingml/2006/main">
               <a:ext uri="{FF2B5EF4-FFF2-40B4-BE49-F238E27FC236}">
-                <a16:creationId xmlns:a16="http://schemas.microsoft.com/office/drawing/2014/main" id="{D94096C4-5FD1-430C-B9DA-1C014FE75D49}"/>
+                <a16:creationId xmlns:a16="http://schemas.microsoft.com/office/drawing/2014/main" id="{4B1CBBE3-5168-49B9-98A4-DD78E109F81B}"/>
               </a:ext>
             </a:extLst>
           </p:cNvPr>
@@ -9071,7 +9071,7 @@
           <p:cNvPr id="25" name="">
             <a:extLst xmlns:a="http://schemas.openxmlformats.org/drawingml/2006/main">
               <a:ext uri="{FF2B5EF4-FFF2-40B4-BE49-F238E27FC236}">
-                <a16:creationId xmlns:a16="http://schemas.microsoft.com/office/drawing/2014/main" id="{9C4EB850-3896-4203-AEAE-5CA3D61A9377}"/>
+                <a16:creationId xmlns:a16="http://schemas.microsoft.com/office/drawing/2014/main" id="{9737BE32-88EB-4B29-BFB1-BA36183B1117}"/>
               </a:ext>
             </a:extLst>
           </p:cNvPr>
@@ -9104,7 +9104,7 @@
           <p:cNvPr id="26" name="">
             <a:extLst xmlns:a="http://schemas.openxmlformats.org/drawingml/2006/main">
               <a:ext uri="{FF2B5EF4-FFF2-40B4-BE49-F238E27FC236}">
-                <a16:creationId xmlns:a16="http://schemas.microsoft.com/office/drawing/2014/main" id="{E9639B4E-0CB5-4FAF-8E76-B45A47FBF4B1}"/>
+                <a16:creationId xmlns:a16="http://schemas.microsoft.com/office/drawing/2014/main" id="{A246053A-CD2C-4E2F-A900-1BA592DEA354}"/>
               </a:ext>
             </a:extLst>
           </p:cNvPr>
@@ -9168,7 +9168,7 @@
           <p:cNvPr id="27" name="">
             <a:extLst xmlns:a="http://schemas.openxmlformats.org/drawingml/2006/main">
               <a:ext uri="{FF2B5EF4-FFF2-40B4-BE49-F238E27FC236}">
-                <a16:creationId xmlns:a16="http://schemas.microsoft.com/office/drawing/2014/main" id="{9A1CD735-E2B6-461C-A30F-63B7E0BE4B48}"/>
+                <a16:creationId xmlns:a16="http://schemas.microsoft.com/office/drawing/2014/main" id="{BBF582B2-1BFA-4FE5-8699-F1CEBB643050}"/>
               </a:ext>
             </a:extLst>
           </p:cNvPr>
@@ -9201,7 +9201,7 @@
           <p:cNvPr id="28" name="">
             <a:extLst xmlns:a="http://schemas.openxmlformats.org/drawingml/2006/main">
               <a:ext uri="{FF2B5EF4-FFF2-40B4-BE49-F238E27FC236}">
-                <a16:creationId xmlns:a16="http://schemas.microsoft.com/office/drawing/2014/main" id="{620CAC67-D8AC-4A00-9D96-64B377BF96C6}"/>
+                <a16:creationId xmlns:a16="http://schemas.microsoft.com/office/drawing/2014/main" id="{CA46C103-AF0D-46C6-872F-C7D146FFB8D3}"/>
               </a:ext>
             </a:extLst>
           </p:cNvPr>
@@ -9265,7 +9265,7 @@
           <p:cNvPr id="29" name="">
             <a:extLst xmlns:a="http://schemas.openxmlformats.org/drawingml/2006/main">
               <a:ext uri="{FF2B5EF4-FFF2-40B4-BE49-F238E27FC236}">
-                <a16:creationId xmlns:a16="http://schemas.microsoft.com/office/drawing/2014/main" id="{B418F624-6F42-43F0-93E8-A774BFABD61A}"/>
+                <a16:creationId xmlns:a16="http://schemas.microsoft.com/office/drawing/2014/main" id="{F991C342-74D2-453F-89FF-7C038D90A2D7}"/>
               </a:ext>
             </a:extLst>
           </p:cNvPr>
@@ -9329,7 +9329,7 @@
           <p:cNvPr id="30" name="">
             <a:extLst xmlns:a="http://schemas.openxmlformats.org/drawingml/2006/main">
               <a:ext uri="{FF2B5EF4-FFF2-40B4-BE49-F238E27FC236}">
-                <a16:creationId xmlns:a16="http://schemas.microsoft.com/office/drawing/2014/main" id="{E828585F-5D8F-4BFB-A733-062AAAA87F9D}"/>
+                <a16:creationId xmlns:a16="http://schemas.microsoft.com/office/drawing/2014/main" id="{1362DC16-4E54-4DC5-ABC1-7D621787776C}"/>
               </a:ext>
             </a:extLst>
           </p:cNvPr>
@@ -9391,7 +9391,7 @@
     </p:spTree>
     <p:extLst>
       <p:ext uri="{BB962C8B-B14F-4D97-AF65-F5344CB8AC3E}">
-        <p14:creationId xmlns:p14="http://schemas.microsoft.com/office/powerpoint/2010/main" val="1556066613"/>
+        <p14:creationId xmlns:p14="http://schemas.microsoft.com/office/powerpoint/2010/main" val="184237500"/>
       </p:ext>
     </p:extLst>
   </p:cSld>
@@ -9415,7 +9415,7 @@
           <p:cNvPr id="1" name="">
             <a:extLst xmlns:a="http://schemas.openxmlformats.org/drawingml/2006/main">
               <a:ext uri="{FF2B5EF4-FFF2-40B4-BE49-F238E27FC236}">
-                <a16:creationId xmlns:a16="http://schemas.microsoft.com/office/drawing/2014/main" id="{E0E3C33C-B602-4599-A85C-E025AE2A11DA}"/>
+                <a16:creationId xmlns:a16="http://schemas.microsoft.com/office/drawing/2014/main" id="{00E89A1C-1138-4016-AC6D-B6E0139D4384}"/>
               </a:ext>
             </a:extLst>
           </p:cNvPr>
@@ -9450,7 +9450,7 @@
           <p:cNvPr id="2" name="">
             <a:extLst xmlns:a="http://schemas.openxmlformats.org/drawingml/2006/main">
               <a:ext uri="{FF2B5EF4-FFF2-40B4-BE49-F238E27FC236}">
-                <a16:creationId xmlns:a16="http://schemas.microsoft.com/office/drawing/2014/main" id="{9D6CC2AA-CB51-4572-8197-8CF908A240A6}"/>
+                <a16:creationId xmlns:a16="http://schemas.microsoft.com/office/drawing/2014/main" id="{10CD8262-5542-44FC-930D-BD309E203F00}"/>
               </a:ext>
             </a:extLst>
           </p:cNvPr>
@@ -9485,7 +9485,7 @@
           <p:cNvPr id="3" name="">
             <a:extLst xmlns:a="http://schemas.openxmlformats.org/drawingml/2006/main">
               <a:ext uri="{FF2B5EF4-FFF2-40B4-BE49-F238E27FC236}">
-                <a16:creationId xmlns:a16="http://schemas.microsoft.com/office/drawing/2014/main" id="{DF84BF75-5425-4717-BDF3-6C28650EC5D7}"/>
+                <a16:creationId xmlns:a16="http://schemas.microsoft.com/office/drawing/2014/main" id="{7694D75A-B16F-4405-865C-5919C43C4A7F}"/>
               </a:ext>
             </a:extLst>
           </p:cNvPr>
@@ -9549,7 +9549,7 @@
           <p:cNvPr id="4" name="">
             <a:extLst xmlns:a="http://schemas.openxmlformats.org/drawingml/2006/main">
               <a:ext uri="{FF2B5EF4-FFF2-40B4-BE49-F238E27FC236}">
-                <a16:creationId xmlns:a16="http://schemas.microsoft.com/office/drawing/2014/main" id="{8B5C852E-91C9-4473-B706-C2FB0DCE7C6D}"/>
+                <a16:creationId xmlns:a16="http://schemas.microsoft.com/office/drawing/2014/main" id="{AB845941-D8DA-4971-84A6-B913C50A1239}"/>
               </a:ext>
             </a:extLst>
           </p:cNvPr>
@@ -9617,7 +9617,7 @@
           <p:nvPr/>
         </p:nvPicPr>
         <p:blipFill>
-          <a:blip xmlns:r="http://schemas.openxmlformats.org/officeDocument/2006/relationships" xmlns:a="http://schemas.openxmlformats.org/drawingml/2006/main" r:embed="R5df034ee0d9d462e"/>
+          <a:blip xmlns:r="http://schemas.openxmlformats.org/officeDocument/2006/relationships" xmlns:a="http://schemas.openxmlformats.org/drawingml/2006/main" r:embed="R0e11069add624b86"/>
           <a:stretch xmlns:a="http://schemas.openxmlformats.org/drawingml/2006/main"/>
         </p:blipFill>
         <p:spPr>
@@ -9635,7 +9635,7 @@
           <p:cNvPr id="6" name="">
             <a:extLst xmlns:a="http://schemas.openxmlformats.org/drawingml/2006/main">
               <a:ext uri="{FF2B5EF4-FFF2-40B4-BE49-F238E27FC236}">
-                <a16:creationId xmlns:a16="http://schemas.microsoft.com/office/drawing/2014/main" id="{CFEEF257-C946-43DE-8CC0-50936BCA9092}"/>
+                <a16:creationId xmlns:a16="http://schemas.microsoft.com/office/drawing/2014/main" id="{C5EAA3A8-D528-4215-8025-AC40EECF00B5}"/>
               </a:ext>
             </a:extLst>
           </p:cNvPr>
@@ -9699,7 +9699,7 @@
           <p:cNvPr id="7" name="">
             <a:extLst xmlns:a="http://schemas.openxmlformats.org/drawingml/2006/main">
               <a:ext uri="{FF2B5EF4-FFF2-40B4-BE49-F238E27FC236}">
-                <a16:creationId xmlns:a16="http://schemas.microsoft.com/office/drawing/2014/main" id="{A860FFC7-4784-467E-ADFC-DCC1FD8D83E9}"/>
+                <a16:creationId xmlns:a16="http://schemas.microsoft.com/office/drawing/2014/main" id="{0633033B-A3BE-4859-997A-3F177F74CD73}"/>
               </a:ext>
             </a:extLst>
           </p:cNvPr>
@@ -9763,7 +9763,7 @@
           <p:cNvPr id="8" name="">
             <a:extLst xmlns:a="http://schemas.openxmlformats.org/drawingml/2006/main">
               <a:ext uri="{FF2B5EF4-FFF2-40B4-BE49-F238E27FC236}">
-                <a16:creationId xmlns:a16="http://schemas.microsoft.com/office/drawing/2014/main" id="{347712A2-338E-44C0-8476-93658E62B593}"/>
+                <a16:creationId xmlns:a16="http://schemas.microsoft.com/office/drawing/2014/main" id="{FE2F5907-92C3-4980-BF1A-266B2DC85CD3}"/>
               </a:ext>
             </a:extLst>
           </p:cNvPr>
@@ -9825,7 +9825,7 @@
     </p:spTree>
     <p:extLst>
       <p:ext uri="{BB962C8B-B14F-4D97-AF65-F5344CB8AC3E}">
-        <p14:creationId xmlns:p14="http://schemas.microsoft.com/office/powerpoint/2010/main" val="1404448050"/>
+        <p14:creationId xmlns:p14="http://schemas.microsoft.com/office/powerpoint/2010/main" val="999003350"/>
       </p:ext>
     </p:extLst>
   </p:cSld>
@@ -9849,7 +9849,7 @@
           <p:cNvPr id="1" name="">
             <a:extLst xmlns:a="http://schemas.openxmlformats.org/drawingml/2006/main">
               <a:ext uri="{FF2B5EF4-FFF2-40B4-BE49-F238E27FC236}">
-                <a16:creationId xmlns:a16="http://schemas.microsoft.com/office/drawing/2014/main" id="{F18D9039-7BBC-44B2-9BA4-DE574D5136F0}"/>
+                <a16:creationId xmlns:a16="http://schemas.microsoft.com/office/drawing/2014/main" id="{EEE17BF1-9C19-44CD-B8C2-2C08EC3943F1}"/>
               </a:ext>
             </a:extLst>
           </p:cNvPr>
@@ -9884,7 +9884,7 @@
           <p:cNvPr id="2" name="">
             <a:extLst xmlns:a="http://schemas.openxmlformats.org/drawingml/2006/main">
               <a:ext uri="{FF2B5EF4-FFF2-40B4-BE49-F238E27FC236}">
-                <a16:creationId xmlns:a16="http://schemas.microsoft.com/office/drawing/2014/main" id="{F3915999-FF75-4E28-AEE7-EFE032E56D8D}"/>
+                <a16:creationId xmlns:a16="http://schemas.microsoft.com/office/drawing/2014/main" id="{4696AC38-48B9-4FE1-86CD-A4811D74AC45}"/>
               </a:ext>
             </a:extLst>
           </p:cNvPr>
@@ -9919,7 +9919,7 @@
           <p:cNvPr id="3" name="">
             <a:extLst xmlns:a="http://schemas.openxmlformats.org/drawingml/2006/main">
               <a:ext uri="{FF2B5EF4-FFF2-40B4-BE49-F238E27FC236}">
-                <a16:creationId xmlns:a16="http://schemas.microsoft.com/office/drawing/2014/main" id="{48E8B2BC-E08B-4582-B107-2EF07C40FAEF}"/>
+                <a16:creationId xmlns:a16="http://schemas.microsoft.com/office/drawing/2014/main" id="{86E161A5-8127-4453-9D66-2C5AC7F9275D}"/>
               </a:ext>
             </a:extLst>
           </p:cNvPr>
@@ -9983,7 +9983,7 @@
           <p:cNvPr id="4" name="">
             <a:extLst xmlns:a="http://schemas.openxmlformats.org/drawingml/2006/main">
               <a:ext uri="{FF2B5EF4-FFF2-40B4-BE49-F238E27FC236}">
-                <a16:creationId xmlns:a16="http://schemas.microsoft.com/office/drawing/2014/main" id="{E610423D-4E6D-4C59-9984-435B5EEE72A2}"/>
+                <a16:creationId xmlns:a16="http://schemas.microsoft.com/office/drawing/2014/main" id="{DED96ABB-4D86-416B-B72B-AF6091D1EB78}"/>
               </a:ext>
             </a:extLst>
           </p:cNvPr>
@@ -10051,7 +10051,7 @@
           <p:nvPr/>
         </p:nvPicPr>
         <p:blipFill>
-          <a:blip xmlns:r="http://schemas.openxmlformats.org/officeDocument/2006/relationships" xmlns:a="http://schemas.openxmlformats.org/drawingml/2006/main" r:embed="Rcce5634058174035"/>
+          <a:blip xmlns:r="http://schemas.openxmlformats.org/officeDocument/2006/relationships" xmlns:a="http://schemas.openxmlformats.org/drawingml/2006/main" r:embed="R4d5d699519f44b49"/>
           <a:stretch xmlns:a="http://schemas.openxmlformats.org/drawingml/2006/main"/>
         </p:blipFill>
         <p:spPr>
@@ -10069,7 +10069,7 @@
           <p:cNvPr id="6" name="">
             <a:extLst xmlns:a="http://schemas.openxmlformats.org/drawingml/2006/main">
               <a:ext uri="{FF2B5EF4-FFF2-40B4-BE49-F238E27FC236}">
-                <a16:creationId xmlns:a16="http://schemas.microsoft.com/office/drawing/2014/main" id="{D10DF752-C1A3-4F38-B050-9AEF0A4D2B7E}"/>
+                <a16:creationId xmlns:a16="http://schemas.microsoft.com/office/drawing/2014/main" id="{8179F5B8-BB6B-4C8B-A639-6770D6305B8D}"/>
               </a:ext>
             </a:extLst>
           </p:cNvPr>
@@ -10133,7 +10133,7 @@
           <p:cNvPr id="7" name="">
             <a:extLst xmlns:a="http://schemas.openxmlformats.org/drawingml/2006/main">
               <a:ext uri="{FF2B5EF4-FFF2-40B4-BE49-F238E27FC236}">
-                <a16:creationId xmlns:a16="http://schemas.microsoft.com/office/drawing/2014/main" id="{AAF10FED-BF43-4114-BDCF-F6448348021D}"/>
+                <a16:creationId xmlns:a16="http://schemas.microsoft.com/office/drawing/2014/main" id="{82115DC9-0E12-4B4A-87F7-6221B9E0368B}"/>
               </a:ext>
             </a:extLst>
           </p:cNvPr>
@@ -10197,7 +10197,7 @@
           <p:cNvPr id="8" name="">
             <a:extLst xmlns:a="http://schemas.openxmlformats.org/drawingml/2006/main">
               <a:ext uri="{FF2B5EF4-FFF2-40B4-BE49-F238E27FC236}">
-                <a16:creationId xmlns:a16="http://schemas.microsoft.com/office/drawing/2014/main" id="{711270AF-A625-426B-8563-AD5BAFF6A5E4}"/>
+                <a16:creationId xmlns:a16="http://schemas.microsoft.com/office/drawing/2014/main" id="{12C6F5EB-DFD9-4698-80D6-5D846D75FCBB}"/>
               </a:ext>
             </a:extLst>
           </p:cNvPr>
@@ -10259,7 +10259,7 @@
     </p:spTree>
     <p:extLst>
       <p:ext uri="{BB962C8B-B14F-4D97-AF65-F5344CB8AC3E}">
-        <p14:creationId xmlns:p14="http://schemas.microsoft.com/office/powerpoint/2010/main" val="559370844"/>
+        <p14:creationId xmlns:p14="http://schemas.microsoft.com/office/powerpoint/2010/main" val="472984154"/>
       </p:ext>
     </p:extLst>
   </p:cSld>
@@ -10283,7 +10283,7 @@
           <p:cNvPr id="1" name="">
             <a:extLst xmlns:a="http://schemas.openxmlformats.org/drawingml/2006/main">
               <a:ext uri="{FF2B5EF4-FFF2-40B4-BE49-F238E27FC236}">
-                <a16:creationId xmlns:a16="http://schemas.microsoft.com/office/drawing/2014/main" id="{28B95C5E-6FEA-40B0-A9BB-0B84B1D05C69}"/>
+                <a16:creationId xmlns:a16="http://schemas.microsoft.com/office/drawing/2014/main" id="{959B23DA-3ABB-44D6-98B5-ABF429E779B0}"/>
               </a:ext>
             </a:extLst>
           </p:cNvPr>
@@ -10318,7 +10318,7 @@
           <p:cNvPr id="2" name="">
             <a:extLst xmlns:a="http://schemas.openxmlformats.org/drawingml/2006/main">
               <a:ext uri="{FF2B5EF4-FFF2-40B4-BE49-F238E27FC236}">
-                <a16:creationId xmlns:a16="http://schemas.microsoft.com/office/drawing/2014/main" id="{6B9AA0EA-2D18-469D-B9C8-F698A460CE42}"/>
+                <a16:creationId xmlns:a16="http://schemas.microsoft.com/office/drawing/2014/main" id="{57A2E0FD-9AAE-4876-A3D6-48AB4A92C2A3}"/>
               </a:ext>
             </a:extLst>
           </p:cNvPr>
@@ -10353,7 +10353,7 @@
           <p:cNvPr id="3" name="">
             <a:extLst xmlns:a="http://schemas.openxmlformats.org/drawingml/2006/main">
               <a:ext uri="{FF2B5EF4-FFF2-40B4-BE49-F238E27FC236}">
-                <a16:creationId xmlns:a16="http://schemas.microsoft.com/office/drawing/2014/main" id="{27AFD9D4-7615-4823-87D5-915B77D6CDDF}"/>
+                <a16:creationId xmlns:a16="http://schemas.microsoft.com/office/drawing/2014/main" id="{0D8F9801-7DAA-4C01-90C5-1047F60028F7}"/>
               </a:ext>
             </a:extLst>
           </p:cNvPr>
@@ -10417,7 +10417,7 @@
           <p:cNvPr id="4" name="">
             <a:extLst xmlns:a="http://schemas.openxmlformats.org/drawingml/2006/main">
               <a:ext uri="{FF2B5EF4-FFF2-40B4-BE49-F238E27FC236}">
-                <a16:creationId xmlns:a16="http://schemas.microsoft.com/office/drawing/2014/main" id="{36EDD469-CF70-415E-B920-2F299D728CA1}"/>
+                <a16:creationId xmlns:a16="http://schemas.microsoft.com/office/drawing/2014/main" id="{776FBD1F-7E3B-4781-8695-10D2769EC803}"/>
               </a:ext>
             </a:extLst>
           </p:cNvPr>
@@ -10481,7 +10481,7 @@
           <p:cNvPr id="5" name="">
             <a:extLst xmlns:a="http://schemas.openxmlformats.org/drawingml/2006/main">
               <a:ext uri="{FF2B5EF4-FFF2-40B4-BE49-F238E27FC236}">
-                <a16:creationId xmlns:a16="http://schemas.microsoft.com/office/drawing/2014/main" id="{B090679A-83C5-40B7-8348-4F6E76873051}"/>
+                <a16:creationId xmlns:a16="http://schemas.microsoft.com/office/drawing/2014/main" id="{9627FAB4-E89F-438A-B44F-0DF5B28FEEBF}"/>
               </a:ext>
             </a:extLst>
           </p:cNvPr>
@@ -10514,7 +10514,7 @@
           <p:cNvPr id="6" name="">
             <a:extLst xmlns:a="http://schemas.openxmlformats.org/drawingml/2006/main">
               <a:ext uri="{FF2B5EF4-FFF2-40B4-BE49-F238E27FC236}">
-                <a16:creationId xmlns:a16="http://schemas.microsoft.com/office/drawing/2014/main" id="{8DCAF701-47C8-4513-890D-577F9DAD3721}"/>
+                <a16:creationId xmlns:a16="http://schemas.microsoft.com/office/drawing/2014/main" id="{0F22DD84-9B39-4A1F-B16C-C4F970BEC0FF}"/>
               </a:ext>
             </a:extLst>
           </p:cNvPr>
@@ -10578,7 +10578,7 @@
           <p:cNvPr id="7" name="">
             <a:extLst xmlns:a="http://schemas.openxmlformats.org/drawingml/2006/main">
               <a:ext uri="{FF2B5EF4-FFF2-40B4-BE49-F238E27FC236}">
-                <a16:creationId xmlns:a16="http://schemas.microsoft.com/office/drawing/2014/main" id="{5DE05C13-3038-4B0F-9685-C640F876C71B}"/>
+                <a16:creationId xmlns:a16="http://schemas.microsoft.com/office/drawing/2014/main" id="{1F15ED5B-B32E-4201-80CF-A68044554285}"/>
               </a:ext>
             </a:extLst>
           </p:cNvPr>
@@ -10611,7 +10611,7 @@
           <p:cNvPr id="8" name="">
             <a:extLst xmlns:a="http://schemas.openxmlformats.org/drawingml/2006/main">
               <a:ext uri="{FF2B5EF4-FFF2-40B4-BE49-F238E27FC236}">
-                <a16:creationId xmlns:a16="http://schemas.microsoft.com/office/drawing/2014/main" id="{87EE1B51-DBE8-41A7-A975-C9CD871E49F3}"/>
+                <a16:creationId xmlns:a16="http://schemas.microsoft.com/office/drawing/2014/main" id="{D76A0E1A-6C34-45BF-99D5-2172D6F10402}"/>
               </a:ext>
             </a:extLst>
           </p:cNvPr>
@@ -10675,7 +10675,7 @@
           <p:cNvPr id="9" name="">
             <a:extLst xmlns:a="http://schemas.openxmlformats.org/drawingml/2006/main">
               <a:ext uri="{FF2B5EF4-FFF2-40B4-BE49-F238E27FC236}">
-                <a16:creationId xmlns:a16="http://schemas.microsoft.com/office/drawing/2014/main" id="{33414F64-AE06-4261-A908-86A48562E74E}"/>
+                <a16:creationId xmlns:a16="http://schemas.microsoft.com/office/drawing/2014/main" id="{CF15B2FF-A3E5-4D21-B876-60F09CBE5261}"/>
               </a:ext>
             </a:extLst>
           </p:cNvPr>
@@ -10708,7 +10708,7 @@
           <p:cNvPr id="10" name="">
             <a:extLst xmlns:a="http://schemas.openxmlformats.org/drawingml/2006/main">
               <a:ext uri="{FF2B5EF4-FFF2-40B4-BE49-F238E27FC236}">
-                <a16:creationId xmlns:a16="http://schemas.microsoft.com/office/drawing/2014/main" id="{11479D50-6D7B-4D62-AA27-C5AE0BAD4D13}"/>
+                <a16:creationId xmlns:a16="http://schemas.microsoft.com/office/drawing/2014/main" id="{997A9305-DDD4-43EE-9092-831249172888}"/>
               </a:ext>
             </a:extLst>
           </p:cNvPr>
@@ -10772,7 +10772,7 @@
           <p:cNvPr id="11" name="">
             <a:extLst xmlns:a="http://schemas.openxmlformats.org/drawingml/2006/main">
               <a:ext uri="{FF2B5EF4-FFF2-40B4-BE49-F238E27FC236}">
-                <a16:creationId xmlns:a16="http://schemas.microsoft.com/office/drawing/2014/main" id="{1680C962-D099-4C27-BF9F-53C8E38A962C}"/>
+                <a16:creationId xmlns:a16="http://schemas.microsoft.com/office/drawing/2014/main" id="{DE7F805F-ED28-41F2-80A2-AB5EF0863EAF}"/>
               </a:ext>
             </a:extLst>
           </p:cNvPr>
@@ -10805,7 +10805,7 @@
           <p:cNvPr id="12" name="">
             <a:extLst xmlns:a="http://schemas.openxmlformats.org/drawingml/2006/main">
               <a:ext uri="{FF2B5EF4-FFF2-40B4-BE49-F238E27FC236}">
-                <a16:creationId xmlns:a16="http://schemas.microsoft.com/office/drawing/2014/main" id="{834A4C67-3811-40F7-BF8B-A8CEBBE30291}"/>
+                <a16:creationId xmlns:a16="http://schemas.microsoft.com/office/drawing/2014/main" id="{5BAB0DB6-BC24-4C10-9EC1-E458310616EC}"/>
               </a:ext>
             </a:extLst>
           </p:cNvPr>
@@ -10869,7 +10869,7 @@
           <p:cNvPr id="13" name="">
             <a:extLst xmlns:a="http://schemas.openxmlformats.org/drawingml/2006/main">
               <a:ext uri="{FF2B5EF4-FFF2-40B4-BE49-F238E27FC236}">
-                <a16:creationId xmlns:a16="http://schemas.microsoft.com/office/drawing/2014/main" id="{09FE7BEB-5F29-42FD-BE72-C403A37C03CA}"/>
+                <a16:creationId xmlns:a16="http://schemas.microsoft.com/office/drawing/2014/main" id="{3227821E-A58D-47A1-80AA-702F6CB41DF4}"/>
               </a:ext>
             </a:extLst>
           </p:cNvPr>
@@ -10902,7 +10902,7 @@
           <p:cNvPr id="14" name="">
             <a:extLst xmlns:a="http://schemas.openxmlformats.org/drawingml/2006/main">
               <a:ext uri="{FF2B5EF4-FFF2-40B4-BE49-F238E27FC236}">
-                <a16:creationId xmlns:a16="http://schemas.microsoft.com/office/drawing/2014/main" id="{4A006A74-86CF-4455-9103-D968481EAB4F}"/>
+                <a16:creationId xmlns:a16="http://schemas.microsoft.com/office/drawing/2014/main" id="{6AC7FFBE-608C-40A8-812E-6E59BC691F6C}"/>
               </a:ext>
             </a:extLst>
           </p:cNvPr>
@@ -10966,7 +10966,7 @@
           <p:cNvPr id="15" name="">
             <a:extLst xmlns:a="http://schemas.openxmlformats.org/drawingml/2006/main">
               <a:ext uri="{FF2B5EF4-FFF2-40B4-BE49-F238E27FC236}">
-                <a16:creationId xmlns:a16="http://schemas.microsoft.com/office/drawing/2014/main" id="{74DEED79-4E29-4287-A548-20CE5B517AB2}"/>
+                <a16:creationId xmlns:a16="http://schemas.microsoft.com/office/drawing/2014/main" id="{0434B523-049D-4438-B89E-41DCE6BE8F53}"/>
               </a:ext>
             </a:extLst>
           </p:cNvPr>
@@ -10999,7 +10999,7 @@
           <p:cNvPr id="16" name="">
             <a:extLst xmlns:a="http://schemas.openxmlformats.org/drawingml/2006/main">
               <a:ext uri="{FF2B5EF4-FFF2-40B4-BE49-F238E27FC236}">
-                <a16:creationId xmlns:a16="http://schemas.microsoft.com/office/drawing/2014/main" id="{4F64F653-91C5-4295-A1A0-AFA2647717BA}"/>
+                <a16:creationId xmlns:a16="http://schemas.microsoft.com/office/drawing/2014/main" id="{1AF449B9-7746-4424-A053-2850FACF031B}"/>
               </a:ext>
             </a:extLst>
           </p:cNvPr>
@@ -11063,7 +11063,7 @@
           <p:cNvPr id="17" name="">
             <a:extLst xmlns:a="http://schemas.openxmlformats.org/drawingml/2006/main">
               <a:ext uri="{FF2B5EF4-FFF2-40B4-BE49-F238E27FC236}">
-                <a16:creationId xmlns:a16="http://schemas.microsoft.com/office/drawing/2014/main" id="{BB19F4D7-76AB-4D0E-BF05-B56B670C8BE4}"/>
+                <a16:creationId xmlns:a16="http://schemas.microsoft.com/office/drawing/2014/main" id="{FC4AF451-4C4C-44EB-96E2-10A87F7C9E86}"/>
               </a:ext>
             </a:extLst>
           </p:cNvPr>
@@ -11096,7 +11096,7 @@
           <p:cNvPr id="18" name="">
             <a:extLst xmlns:a="http://schemas.openxmlformats.org/drawingml/2006/main">
               <a:ext uri="{FF2B5EF4-FFF2-40B4-BE49-F238E27FC236}">
-                <a16:creationId xmlns:a16="http://schemas.microsoft.com/office/drawing/2014/main" id="{66A47D3C-6C99-4C37-927F-75946CF5D657}"/>
+                <a16:creationId xmlns:a16="http://schemas.microsoft.com/office/drawing/2014/main" id="{13A03431-F631-41A5-999A-FDE472F5B40D}"/>
               </a:ext>
             </a:extLst>
           </p:cNvPr>
@@ -11160,7 +11160,7 @@
           <p:cNvPr id="19" name="">
             <a:extLst xmlns:a="http://schemas.openxmlformats.org/drawingml/2006/main">
               <a:ext uri="{FF2B5EF4-FFF2-40B4-BE49-F238E27FC236}">
-                <a16:creationId xmlns:a16="http://schemas.microsoft.com/office/drawing/2014/main" id="{EF01FA0A-E97C-4720-8E20-2EFB37491CA6}"/>
+                <a16:creationId xmlns:a16="http://schemas.microsoft.com/office/drawing/2014/main" id="{4BC98EEA-E33C-444C-AA1B-D89146BD0737}"/>
               </a:ext>
             </a:extLst>
           </p:cNvPr>
@@ -11193,7 +11193,7 @@
           <p:cNvPr id="20" name="">
             <a:extLst xmlns:a="http://schemas.openxmlformats.org/drawingml/2006/main">
               <a:ext uri="{FF2B5EF4-FFF2-40B4-BE49-F238E27FC236}">
-                <a16:creationId xmlns:a16="http://schemas.microsoft.com/office/drawing/2014/main" id="{A7EB1BA3-692E-4F64-817A-2E62AE70B5AB}"/>
+                <a16:creationId xmlns:a16="http://schemas.microsoft.com/office/drawing/2014/main" id="{0B953AC1-7CAE-4A17-90E7-246E8F57EF86}"/>
               </a:ext>
             </a:extLst>
           </p:cNvPr>
@@ -11257,7 +11257,7 @@
           <p:cNvPr id="21" name="">
             <a:extLst xmlns:a="http://schemas.openxmlformats.org/drawingml/2006/main">
               <a:ext uri="{FF2B5EF4-FFF2-40B4-BE49-F238E27FC236}">
-                <a16:creationId xmlns:a16="http://schemas.microsoft.com/office/drawing/2014/main" id="{87141638-CD7B-4A9A-BEDE-B44551601100}"/>
+                <a16:creationId xmlns:a16="http://schemas.microsoft.com/office/drawing/2014/main" id="{9F64E225-ADDC-4783-BBDC-071AF666AE9F}"/>
               </a:ext>
             </a:extLst>
           </p:cNvPr>
@@ -11290,7 +11290,7 @@
           <p:cNvPr id="22" name="">
             <a:extLst xmlns:a="http://schemas.openxmlformats.org/drawingml/2006/main">
               <a:ext uri="{FF2B5EF4-FFF2-40B4-BE49-F238E27FC236}">
-                <a16:creationId xmlns:a16="http://schemas.microsoft.com/office/drawing/2014/main" id="{681D0022-7BD3-4BA7-ADA2-159209DC1C8B}"/>
+                <a16:creationId xmlns:a16="http://schemas.microsoft.com/office/drawing/2014/main" id="{8744FE0B-1BEB-4439-BBDD-4FA6D04658F9}"/>
               </a:ext>
             </a:extLst>
           </p:cNvPr>
@@ -11354,7 +11354,7 @@
           <p:cNvPr id="23" name="">
             <a:extLst xmlns:a="http://schemas.openxmlformats.org/drawingml/2006/main">
               <a:ext uri="{FF2B5EF4-FFF2-40B4-BE49-F238E27FC236}">
-                <a16:creationId xmlns:a16="http://schemas.microsoft.com/office/drawing/2014/main" id="{FD35B689-29B0-4FC3-A54D-AFEE2FE89DDD}"/>
+                <a16:creationId xmlns:a16="http://schemas.microsoft.com/office/drawing/2014/main" id="{F37600F8-D1B9-4DDD-AD2A-EAE733245CB4}"/>
               </a:ext>
             </a:extLst>
           </p:cNvPr>
@@ -11387,7 +11387,7 @@
           <p:cNvPr id="24" name="">
             <a:extLst xmlns:a="http://schemas.openxmlformats.org/drawingml/2006/main">
               <a:ext uri="{FF2B5EF4-FFF2-40B4-BE49-F238E27FC236}">
-                <a16:creationId xmlns:a16="http://schemas.microsoft.com/office/drawing/2014/main" id="{45CA7A90-8A9C-4F3A-8F81-BA7207B1E839}"/>
+                <a16:creationId xmlns:a16="http://schemas.microsoft.com/office/drawing/2014/main" id="{0789BCAE-E1D6-4120-B630-2E513EFFFC0C}"/>
               </a:ext>
             </a:extLst>
           </p:cNvPr>
@@ -11451,7 +11451,7 @@
           <p:cNvPr id="25" name="">
             <a:extLst xmlns:a="http://schemas.openxmlformats.org/drawingml/2006/main">
               <a:ext uri="{FF2B5EF4-FFF2-40B4-BE49-F238E27FC236}">
-                <a16:creationId xmlns:a16="http://schemas.microsoft.com/office/drawing/2014/main" id="{219DB42F-2B60-420D-A8DE-EFEC570FD74C}"/>
+                <a16:creationId xmlns:a16="http://schemas.microsoft.com/office/drawing/2014/main" id="{DE069388-0424-4524-B6B5-C82E4F49CA8F}"/>
               </a:ext>
             </a:extLst>
           </p:cNvPr>
@@ -11484,7 +11484,7 @@
           <p:cNvPr id="26" name="">
             <a:extLst xmlns:a="http://schemas.openxmlformats.org/drawingml/2006/main">
               <a:ext uri="{FF2B5EF4-FFF2-40B4-BE49-F238E27FC236}">
-                <a16:creationId xmlns:a16="http://schemas.microsoft.com/office/drawing/2014/main" id="{9B387C1F-327E-4658-9973-9BA1F872E6DB}"/>
+                <a16:creationId xmlns:a16="http://schemas.microsoft.com/office/drawing/2014/main" id="{295091AE-CC74-4ECE-B263-1278AAEDF257}"/>
               </a:ext>
             </a:extLst>
           </p:cNvPr>
@@ -11548,7 +11548,7 @@
           <p:cNvPr id="27" name="">
             <a:extLst xmlns:a="http://schemas.openxmlformats.org/drawingml/2006/main">
               <a:ext uri="{FF2B5EF4-FFF2-40B4-BE49-F238E27FC236}">
-                <a16:creationId xmlns:a16="http://schemas.microsoft.com/office/drawing/2014/main" id="{1F15958D-AF9D-4952-9839-B777AFB181F3}"/>
+                <a16:creationId xmlns:a16="http://schemas.microsoft.com/office/drawing/2014/main" id="{4118E134-697E-4712-A901-2A1550ECB9E7}"/>
               </a:ext>
             </a:extLst>
           </p:cNvPr>
@@ -11581,7 +11581,7 @@
           <p:cNvPr id="28" name="">
             <a:extLst xmlns:a="http://schemas.openxmlformats.org/drawingml/2006/main">
               <a:ext uri="{FF2B5EF4-FFF2-40B4-BE49-F238E27FC236}">
-                <a16:creationId xmlns:a16="http://schemas.microsoft.com/office/drawing/2014/main" id="{0339FC28-F03B-42E3-A335-82778CEAC4DA}"/>
+                <a16:creationId xmlns:a16="http://schemas.microsoft.com/office/drawing/2014/main" id="{7CECBABD-03BB-4ED3-8895-15E2D9EDCDF2}"/>
               </a:ext>
             </a:extLst>
           </p:cNvPr>
@@ -11645,7 +11645,7 @@
           <p:cNvPr id="29" name="">
             <a:extLst xmlns:a="http://schemas.openxmlformats.org/drawingml/2006/main">
               <a:ext uri="{FF2B5EF4-FFF2-40B4-BE49-F238E27FC236}">
-                <a16:creationId xmlns:a16="http://schemas.microsoft.com/office/drawing/2014/main" id="{DD96C893-5EBA-45AD-9316-4CBE98A789D4}"/>
+                <a16:creationId xmlns:a16="http://schemas.microsoft.com/office/drawing/2014/main" id="{130AA38F-CAA2-48AF-B95D-7996474639BD}"/>
               </a:ext>
             </a:extLst>
           </p:cNvPr>
@@ -11678,7 +11678,7 @@
           <p:cNvPr id="30" name="">
             <a:extLst xmlns:a="http://schemas.openxmlformats.org/drawingml/2006/main">
               <a:ext uri="{FF2B5EF4-FFF2-40B4-BE49-F238E27FC236}">
-                <a16:creationId xmlns:a16="http://schemas.microsoft.com/office/drawing/2014/main" id="{BCC00D36-1EB6-4D22-839F-17DEF8B3BAE5}"/>
+                <a16:creationId xmlns:a16="http://schemas.microsoft.com/office/drawing/2014/main" id="{F6849599-81F7-4E51-9B8B-AF684F6AFBD5}"/>
               </a:ext>
             </a:extLst>
           </p:cNvPr>
@@ -11742,7 +11742,7 @@
           <p:cNvPr id="31" name="">
             <a:extLst xmlns:a="http://schemas.openxmlformats.org/drawingml/2006/main">
               <a:ext uri="{FF2B5EF4-FFF2-40B4-BE49-F238E27FC236}">
-                <a16:creationId xmlns:a16="http://schemas.microsoft.com/office/drawing/2014/main" id="{B5B13F24-92AB-4384-8648-B191C1ED3506}"/>
+                <a16:creationId xmlns:a16="http://schemas.microsoft.com/office/drawing/2014/main" id="{5B3E3EC4-2324-469F-AE83-777478D9740B}"/>
               </a:ext>
             </a:extLst>
           </p:cNvPr>
@@ -11775,7 +11775,7 @@
           <p:cNvPr id="32" name="">
             <a:extLst xmlns:a="http://schemas.openxmlformats.org/drawingml/2006/main">
               <a:ext uri="{FF2B5EF4-FFF2-40B4-BE49-F238E27FC236}">
-                <a16:creationId xmlns:a16="http://schemas.microsoft.com/office/drawing/2014/main" id="{3B2EFC47-DF3C-4E31-9029-E64D0CF76952}"/>
+                <a16:creationId xmlns:a16="http://schemas.microsoft.com/office/drawing/2014/main" id="{573F75B3-9D7F-4969-8A20-C60EF4699C5D}"/>
               </a:ext>
             </a:extLst>
           </p:cNvPr>
@@ -11839,7 +11839,7 @@
           <p:cNvPr id="33" name="">
             <a:extLst xmlns:a="http://schemas.openxmlformats.org/drawingml/2006/main">
               <a:ext uri="{FF2B5EF4-FFF2-40B4-BE49-F238E27FC236}">
-                <a16:creationId xmlns:a16="http://schemas.microsoft.com/office/drawing/2014/main" id="{9B2345FB-494F-46E3-B5AF-8477A79CED6D}"/>
+                <a16:creationId xmlns:a16="http://schemas.microsoft.com/office/drawing/2014/main" id="{E63EB1B4-8946-44B5-9808-C9EA88C2ED88}"/>
               </a:ext>
             </a:extLst>
           </p:cNvPr>
@@ -11903,7 +11903,7 @@
           <p:cNvPr id="34" name="">
             <a:extLst xmlns:a="http://schemas.openxmlformats.org/drawingml/2006/main">
               <a:ext uri="{FF2B5EF4-FFF2-40B4-BE49-F238E27FC236}">
-                <a16:creationId xmlns:a16="http://schemas.microsoft.com/office/drawing/2014/main" id="{EA7DF262-91A3-429C-A58C-54F7ECA12B42}"/>
+                <a16:creationId xmlns:a16="http://schemas.microsoft.com/office/drawing/2014/main" id="{FEE5E61C-36DD-40D5-8F58-10F679DA5661}"/>
               </a:ext>
             </a:extLst>
           </p:cNvPr>
@@ -11967,7 +11967,7 @@
           <p:cNvPr id="35" name="">
             <a:extLst xmlns:a="http://schemas.openxmlformats.org/drawingml/2006/main">
               <a:ext uri="{FF2B5EF4-FFF2-40B4-BE49-F238E27FC236}">
-                <a16:creationId xmlns:a16="http://schemas.microsoft.com/office/drawing/2014/main" id="{A9D339E5-56BA-46E7-A930-C5C4AE527AE2}"/>
+                <a16:creationId xmlns:a16="http://schemas.microsoft.com/office/drawing/2014/main" id="{B529E838-EFB1-42EA-85F9-51D9402BBD54}"/>
               </a:ext>
             </a:extLst>
           </p:cNvPr>
@@ -12029,7 +12029,7 @@
     </p:spTree>
     <p:extLst>
       <p:ext uri="{BB962C8B-B14F-4D97-AF65-F5344CB8AC3E}">
-        <p14:creationId xmlns:p14="http://schemas.microsoft.com/office/powerpoint/2010/main" val="530088666"/>
+        <p14:creationId xmlns:p14="http://schemas.microsoft.com/office/powerpoint/2010/main" val="1223524062"/>
       </p:ext>
     </p:extLst>
   </p:cSld>
@@ -12053,7 +12053,7 @@
           <p:cNvPr id="1" name="">
             <a:extLst xmlns:a="http://schemas.openxmlformats.org/drawingml/2006/main">
               <a:ext uri="{FF2B5EF4-FFF2-40B4-BE49-F238E27FC236}">
-                <a16:creationId xmlns:a16="http://schemas.microsoft.com/office/drawing/2014/main" id="{100F1158-C88B-4E9E-8503-6C0934A420DE}"/>
+                <a16:creationId xmlns:a16="http://schemas.microsoft.com/office/drawing/2014/main" id="{5D98D6E7-9006-48CF-973B-9FE0E9BFA5B4}"/>
               </a:ext>
             </a:extLst>
           </p:cNvPr>
@@ -12088,7 +12088,7 @@
           <p:cNvPr id="2" name="">
             <a:extLst xmlns:a="http://schemas.openxmlformats.org/drawingml/2006/main">
               <a:ext uri="{FF2B5EF4-FFF2-40B4-BE49-F238E27FC236}">
-                <a16:creationId xmlns:a16="http://schemas.microsoft.com/office/drawing/2014/main" id="{26CA7FF2-AFB5-4822-A517-D1FD54B25156}"/>
+                <a16:creationId xmlns:a16="http://schemas.microsoft.com/office/drawing/2014/main" id="{9BDA11DB-33E3-4EF0-BE91-EF7B707362F5}"/>
               </a:ext>
             </a:extLst>
           </p:cNvPr>
@@ -12123,7 +12123,7 @@
           <p:cNvPr id="3" name="">
             <a:extLst xmlns:a="http://schemas.openxmlformats.org/drawingml/2006/main">
               <a:ext uri="{FF2B5EF4-FFF2-40B4-BE49-F238E27FC236}">
-                <a16:creationId xmlns:a16="http://schemas.microsoft.com/office/drawing/2014/main" id="{10AD1D6D-E132-4343-BB80-86B91F1B1FDF}"/>
+                <a16:creationId xmlns:a16="http://schemas.microsoft.com/office/drawing/2014/main" id="{458173A9-630F-49F6-A300-2542DCB51C5A}"/>
               </a:ext>
             </a:extLst>
           </p:cNvPr>
@@ -12187,7 +12187,7 @@
           <p:cNvPr id="4" name="">
             <a:extLst xmlns:a="http://schemas.openxmlformats.org/drawingml/2006/main">
               <a:ext uri="{FF2B5EF4-FFF2-40B4-BE49-F238E27FC236}">
-                <a16:creationId xmlns:a16="http://schemas.microsoft.com/office/drawing/2014/main" id="{8980EBFE-0CDC-4616-800B-B55A0C00A95E}"/>
+                <a16:creationId xmlns:a16="http://schemas.microsoft.com/office/drawing/2014/main" id="{0D1996F9-7BDB-45DF-8691-09D7525F202D}"/>
               </a:ext>
             </a:extLst>
           </p:cNvPr>
@@ -12251,7 +12251,7 @@
           <p:cNvPr id="5" name="">
             <a:extLst xmlns:a="http://schemas.openxmlformats.org/drawingml/2006/main">
               <a:ext uri="{FF2B5EF4-FFF2-40B4-BE49-F238E27FC236}">
-                <a16:creationId xmlns:a16="http://schemas.microsoft.com/office/drawing/2014/main" id="{77379638-F7CC-4E77-B335-369DFB0D59E4}"/>
+                <a16:creationId xmlns:a16="http://schemas.microsoft.com/office/drawing/2014/main" id="{6E78A080-3D61-40ED-AF00-F3A172B4B4DC}"/>
               </a:ext>
             </a:extLst>
           </p:cNvPr>
@@ -12315,7 +12315,7 @@
           <p:cNvPr id="6" name="">
             <a:extLst xmlns:a="http://schemas.openxmlformats.org/drawingml/2006/main">
               <a:ext uri="{FF2B5EF4-FFF2-40B4-BE49-F238E27FC236}">
-                <a16:creationId xmlns:a16="http://schemas.microsoft.com/office/drawing/2014/main" id="{4BF829A0-9354-4B7D-A105-F97B84B45978}"/>
+                <a16:creationId xmlns:a16="http://schemas.microsoft.com/office/drawing/2014/main" id="{97BE96D7-E60C-4E24-BA14-1B5B09A7182D}"/>
               </a:ext>
             </a:extLst>
           </p:cNvPr>
@@ -12348,7 +12348,7 @@
           <p:cNvPr id="7" name="">
             <a:extLst xmlns:a="http://schemas.openxmlformats.org/drawingml/2006/main">
               <a:ext uri="{FF2B5EF4-FFF2-40B4-BE49-F238E27FC236}">
-                <a16:creationId xmlns:a16="http://schemas.microsoft.com/office/drawing/2014/main" id="{F3F542C7-88F5-4EF8-80B6-16C8719C83A5}"/>
+                <a16:creationId xmlns:a16="http://schemas.microsoft.com/office/drawing/2014/main" id="{33BEFCBF-E204-432E-98E0-104721A39DD9}"/>
               </a:ext>
             </a:extLst>
           </p:cNvPr>
@@ -12381,7 +12381,7 @@
           <p:cNvPr id="8" name="">
             <a:extLst xmlns:a="http://schemas.openxmlformats.org/drawingml/2006/main">
               <a:ext uri="{FF2B5EF4-FFF2-40B4-BE49-F238E27FC236}">
-                <a16:creationId xmlns:a16="http://schemas.microsoft.com/office/drawing/2014/main" id="{5C92B8DE-25AC-493F-9FB6-B9562FE367C2}"/>
+                <a16:creationId xmlns:a16="http://schemas.microsoft.com/office/drawing/2014/main" id="{6D3CBF92-A05C-46F9-91E8-467AE8CBA739}"/>
               </a:ext>
             </a:extLst>
           </p:cNvPr>
@@ -12445,7 +12445,7 @@
           <p:cNvPr id="9" name="">
             <a:extLst xmlns:a="http://schemas.openxmlformats.org/drawingml/2006/main">
               <a:ext uri="{FF2B5EF4-FFF2-40B4-BE49-F238E27FC236}">
-                <a16:creationId xmlns:a16="http://schemas.microsoft.com/office/drawing/2014/main" id="{123B55C3-22B8-4934-B538-4A0E57231940}"/>
+                <a16:creationId xmlns:a16="http://schemas.microsoft.com/office/drawing/2014/main" id="{0C271B9A-2BAC-4E34-BEA0-AB99BD13EDEA}"/>
               </a:ext>
             </a:extLst>
           </p:cNvPr>
@@ -12509,7 +12509,7 @@
           <p:cNvPr id="10" name="">
             <a:extLst xmlns:a="http://schemas.openxmlformats.org/drawingml/2006/main">
               <a:ext uri="{FF2B5EF4-FFF2-40B4-BE49-F238E27FC236}">
-                <a16:creationId xmlns:a16="http://schemas.microsoft.com/office/drawing/2014/main" id="{517F995A-2CEF-4E01-8BFB-97C7989E269A}"/>
+                <a16:creationId xmlns:a16="http://schemas.microsoft.com/office/drawing/2014/main" id="{B9FE06C4-2CAB-4D60-92A3-2A751688C26C}"/>
               </a:ext>
             </a:extLst>
           </p:cNvPr>
@@ -12542,7 +12542,7 @@
           <p:cNvPr id="11" name="">
             <a:extLst xmlns:a="http://schemas.openxmlformats.org/drawingml/2006/main">
               <a:ext uri="{FF2B5EF4-FFF2-40B4-BE49-F238E27FC236}">
-                <a16:creationId xmlns:a16="http://schemas.microsoft.com/office/drawing/2014/main" id="{0D8C0FD5-E27F-4D34-9F3B-D9A23A845B6B}"/>
+                <a16:creationId xmlns:a16="http://schemas.microsoft.com/office/drawing/2014/main" id="{D6074369-07AC-498A-AA38-A2B3CB301BEC}"/>
               </a:ext>
             </a:extLst>
           </p:cNvPr>
@@ -12575,7 +12575,7 @@
           <p:cNvPr id="12" name="">
             <a:extLst xmlns:a="http://schemas.openxmlformats.org/drawingml/2006/main">
               <a:ext uri="{FF2B5EF4-FFF2-40B4-BE49-F238E27FC236}">
-                <a16:creationId xmlns:a16="http://schemas.microsoft.com/office/drawing/2014/main" id="{295E8FB3-4D82-484F-860C-14C5BDD74321}"/>
+                <a16:creationId xmlns:a16="http://schemas.microsoft.com/office/drawing/2014/main" id="{D4E98AD9-5190-4C68-8491-AD5DD67E5FA1}"/>
               </a:ext>
             </a:extLst>
           </p:cNvPr>
@@ -12639,7 +12639,7 @@
           <p:cNvPr id="13" name="">
             <a:extLst xmlns:a="http://schemas.openxmlformats.org/drawingml/2006/main">
               <a:ext uri="{FF2B5EF4-FFF2-40B4-BE49-F238E27FC236}">
-                <a16:creationId xmlns:a16="http://schemas.microsoft.com/office/drawing/2014/main" id="{32B0654C-0154-4F36-82AD-7A5445FB2044}"/>
+                <a16:creationId xmlns:a16="http://schemas.microsoft.com/office/drawing/2014/main" id="{11A51FCB-9589-4E3E-8E31-99F778DFEF07}"/>
               </a:ext>
             </a:extLst>
           </p:cNvPr>
@@ -12703,7 +12703,7 @@
           <p:cNvPr id="14" name="">
             <a:extLst xmlns:a="http://schemas.openxmlformats.org/drawingml/2006/main">
               <a:ext uri="{FF2B5EF4-FFF2-40B4-BE49-F238E27FC236}">
-                <a16:creationId xmlns:a16="http://schemas.microsoft.com/office/drawing/2014/main" id="{4371E159-7B2D-4207-9A6E-F0552A99BB38}"/>
+                <a16:creationId xmlns:a16="http://schemas.microsoft.com/office/drawing/2014/main" id="{C9BFA85A-D417-4DB1-8285-DE193D278989}"/>
               </a:ext>
             </a:extLst>
           </p:cNvPr>
@@ -12736,7 +12736,7 @@
           <p:cNvPr id="15" name="">
             <a:extLst xmlns:a="http://schemas.openxmlformats.org/drawingml/2006/main">
               <a:ext uri="{FF2B5EF4-FFF2-40B4-BE49-F238E27FC236}">
-                <a16:creationId xmlns:a16="http://schemas.microsoft.com/office/drawing/2014/main" id="{72BAC126-DF8A-42FA-8EFD-98093ED7D6C8}"/>
+                <a16:creationId xmlns:a16="http://schemas.microsoft.com/office/drawing/2014/main" id="{7838C871-1EDE-4837-8A32-FA88CE112500}"/>
               </a:ext>
             </a:extLst>
           </p:cNvPr>
@@ -12769,7 +12769,7 @@
           <p:cNvPr id="16" name="">
             <a:extLst xmlns:a="http://schemas.openxmlformats.org/drawingml/2006/main">
               <a:ext uri="{FF2B5EF4-FFF2-40B4-BE49-F238E27FC236}">
-                <a16:creationId xmlns:a16="http://schemas.microsoft.com/office/drawing/2014/main" id="{FA262A09-F16B-4251-95C4-BA7CD128A63F}"/>
+                <a16:creationId xmlns:a16="http://schemas.microsoft.com/office/drawing/2014/main" id="{5E129317-833F-46AA-98BA-85AB64339B2E}"/>
               </a:ext>
             </a:extLst>
           </p:cNvPr>
@@ -12833,7 +12833,7 @@
           <p:cNvPr id="17" name="">
             <a:extLst xmlns:a="http://schemas.openxmlformats.org/drawingml/2006/main">
               <a:ext uri="{FF2B5EF4-FFF2-40B4-BE49-F238E27FC236}">
-                <a16:creationId xmlns:a16="http://schemas.microsoft.com/office/drawing/2014/main" id="{0B131E68-CECA-4648-90F1-4C507C46437F}"/>
+                <a16:creationId xmlns:a16="http://schemas.microsoft.com/office/drawing/2014/main" id="{9C2C3FCA-B66B-4AFD-B61F-98F9F3A38846}"/>
               </a:ext>
             </a:extLst>
           </p:cNvPr>
@@ -12897,7 +12897,7 @@
           <p:cNvPr id="18" name="">
             <a:extLst xmlns:a="http://schemas.openxmlformats.org/drawingml/2006/main">
               <a:ext uri="{FF2B5EF4-FFF2-40B4-BE49-F238E27FC236}">
-                <a16:creationId xmlns:a16="http://schemas.microsoft.com/office/drawing/2014/main" id="{672E49DD-955F-4FAC-8EDB-969BC4A472A8}"/>
+                <a16:creationId xmlns:a16="http://schemas.microsoft.com/office/drawing/2014/main" id="{CDCB62CD-737C-4E06-AC90-2E75F1F418A2}"/>
               </a:ext>
             </a:extLst>
           </p:cNvPr>
@@ -12930,7 +12930,7 @@
           <p:cNvPr id="19" name="">
             <a:extLst xmlns:a="http://schemas.openxmlformats.org/drawingml/2006/main">
               <a:ext uri="{FF2B5EF4-FFF2-40B4-BE49-F238E27FC236}">
-                <a16:creationId xmlns:a16="http://schemas.microsoft.com/office/drawing/2014/main" id="{FDF21ABC-B0E4-45E3-9C99-C9C271CE8D78}"/>
+                <a16:creationId xmlns:a16="http://schemas.microsoft.com/office/drawing/2014/main" id="{4AD9EDA9-7B88-41C1-92F6-3FA48E4B17F0}"/>
               </a:ext>
             </a:extLst>
           </p:cNvPr>
@@ -12963,7 +12963,7 @@
           <p:cNvPr id="20" name="">
             <a:extLst xmlns:a="http://schemas.openxmlformats.org/drawingml/2006/main">
               <a:ext uri="{FF2B5EF4-FFF2-40B4-BE49-F238E27FC236}">
-                <a16:creationId xmlns:a16="http://schemas.microsoft.com/office/drawing/2014/main" id="{722B7917-6B0F-464B-9701-B3CEE3D18745}"/>
+                <a16:creationId xmlns:a16="http://schemas.microsoft.com/office/drawing/2014/main" id="{73AC6906-9570-42F6-B718-C77AA1028096}"/>
               </a:ext>
             </a:extLst>
           </p:cNvPr>
@@ -13027,7 +13027,7 @@
           <p:cNvPr id="21" name="">
             <a:extLst xmlns:a="http://schemas.openxmlformats.org/drawingml/2006/main">
               <a:ext uri="{FF2B5EF4-FFF2-40B4-BE49-F238E27FC236}">
-                <a16:creationId xmlns:a16="http://schemas.microsoft.com/office/drawing/2014/main" id="{12E53A11-2E9C-43BA-9EBE-6272BB4C8026}"/>
+                <a16:creationId xmlns:a16="http://schemas.microsoft.com/office/drawing/2014/main" id="{C3C77B9E-C9B6-416B-B1A8-77C326C711D1}"/>
               </a:ext>
             </a:extLst>
           </p:cNvPr>
@@ -13091,7 +13091,7 @@
           <p:cNvPr id="22" name="">
             <a:extLst xmlns:a="http://schemas.openxmlformats.org/drawingml/2006/main">
               <a:ext uri="{FF2B5EF4-FFF2-40B4-BE49-F238E27FC236}">
-                <a16:creationId xmlns:a16="http://schemas.microsoft.com/office/drawing/2014/main" id="{30C6E531-7695-4840-8A5A-A70F09E49B59}"/>
+                <a16:creationId xmlns:a16="http://schemas.microsoft.com/office/drawing/2014/main" id="{0ABAC1EE-26B2-40D8-9BE3-691779B4FAF4}"/>
               </a:ext>
             </a:extLst>
           </p:cNvPr>
@@ -13124,7 +13124,7 @@
           <p:cNvPr id="23" name="">
             <a:extLst xmlns:a="http://schemas.openxmlformats.org/drawingml/2006/main">
               <a:ext uri="{FF2B5EF4-FFF2-40B4-BE49-F238E27FC236}">
-                <a16:creationId xmlns:a16="http://schemas.microsoft.com/office/drawing/2014/main" id="{765AEE78-C30F-4195-A48E-5AA4D75EAB01}"/>
+                <a16:creationId xmlns:a16="http://schemas.microsoft.com/office/drawing/2014/main" id="{6EA5D837-F7DC-4093-B0FB-7875372190E8}"/>
               </a:ext>
             </a:extLst>
           </p:cNvPr>
@@ -13157,7 +13157,7 @@
           <p:cNvPr id="24" name="">
             <a:extLst xmlns:a="http://schemas.openxmlformats.org/drawingml/2006/main">
               <a:ext uri="{FF2B5EF4-FFF2-40B4-BE49-F238E27FC236}">
-                <a16:creationId xmlns:a16="http://schemas.microsoft.com/office/drawing/2014/main" id="{E8AC148B-4C59-4EFE-AA8E-34F9918E6807}"/>
+                <a16:creationId xmlns:a16="http://schemas.microsoft.com/office/drawing/2014/main" id="{4F8DB8AB-51B5-4331-A115-90B15B5B8939}"/>
               </a:ext>
             </a:extLst>
           </p:cNvPr>
@@ -13221,7 +13221,7 @@
           <p:cNvPr id="25" name="">
             <a:extLst xmlns:a="http://schemas.openxmlformats.org/drawingml/2006/main">
               <a:ext uri="{FF2B5EF4-FFF2-40B4-BE49-F238E27FC236}">
-                <a16:creationId xmlns:a16="http://schemas.microsoft.com/office/drawing/2014/main" id="{18F841FE-1831-44AF-9EA9-D6238B3CE2F1}"/>
+                <a16:creationId xmlns:a16="http://schemas.microsoft.com/office/drawing/2014/main" id="{F06496FE-77FF-42B3-BDF4-37CFA791DDA4}"/>
               </a:ext>
             </a:extLst>
           </p:cNvPr>
@@ -13285,7 +13285,7 @@
           <p:cNvPr id="26" name="">
             <a:extLst xmlns:a="http://schemas.openxmlformats.org/drawingml/2006/main">
               <a:ext uri="{FF2B5EF4-FFF2-40B4-BE49-F238E27FC236}">
-                <a16:creationId xmlns:a16="http://schemas.microsoft.com/office/drawing/2014/main" id="{48D9263A-853B-4E30-A143-68329997AEF3}"/>
+                <a16:creationId xmlns:a16="http://schemas.microsoft.com/office/drawing/2014/main" id="{7DE4FE33-C1C5-4589-913C-2EB791B1278D}"/>
               </a:ext>
             </a:extLst>
           </p:cNvPr>
@@ -13318,7 +13318,7 @@
           <p:cNvPr id="27" name="">
             <a:extLst xmlns:a="http://schemas.openxmlformats.org/drawingml/2006/main">
               <a:ext uri="{FF2B5EF4-FFF2-40B4-BE49-F238E27FC236}">
-                <a16:creationId xmlns:a16="http://schemas.microsoft.com/office/drawing/2014/main" id="{EADB574D-EEB5-4BB3-AD07-42DA42D997D5}"/>
+                <a16:creationId xmlns:a16="http://schemas.microsoft.com/office/drawing/2014/main" id="{B6214E16-2EFC-4FFF-B0C6-724B5B2D73A9}"/>
               </a:ext>
             </a:extLst>
           </p:cNvPr>
@@ -13351,7 +13351,7 @@
           <p:cNvPr id="28" name="">
             <a:extLst xmlns:a="http://schemas.openxmlformats.org/drawingml/2006/main">
               <a:ext uri="{FF2B5EF4-FFF2-40B4-BE49-F238E27FC236}">
-                <a16:creationId xmlns:a16="http://schemas.microsoft.com/office/drawing/2014/main" id="{A9690B1D-F14B-4B2F-B246-9742E0B1223B}"/>
+                <a16:creationId xmlns:a16="http://schemas.microsoft.com/office/drawing/2014/main" id="{C2CB8FD4-CD7E-4D90-8661-FC27D2DA8FA9}"/>
               </a:ext>
             </a:extLst>
           </p:cNvPr>
@@ -13415,7 +13415,7 @@
           <p:cNvPr id="29" name="">
             <a:extLst xmlns:a="http://schemas.openxmlformats.org/drawingml/2006/main">
               <a:ext uri="{FF2B5EF4-FFF2-40B4-BE49-F238E27FC236}">
-                <a16:creationId xmlns:a16="http://schemas.microsoft.com/office/drawing/2014/main" id="{D3FBBCBB-BBC4-4E81-9781-2B9FB9A5F9E4}"/>
+                <a16:creationId xmlns:a16="http://schemas.microsoft.com/office/drawing/2014/main" id="{CE80C3FD-AD13-43BA-8023-3898332937F6}"/>
               </a:ext>
             </a:extLst>
           </p:cNvPr>
@@ -13479,7 +13479,7 @@
           <p:cNvPr id="30" name="">
             <a:extLst xmlns:a="http://schemas.openxmlformats.org/drawingml/2006/main">
               <a:ext uri="{FF2B5EF4-FFF2-40B4-BE49-F238E27FC236}">
-                <a16:creationId xmlns:a16="http://schemas.microsoft.com/office/drawing/2014/main" id="{CD9F55B6-AB63-4622-ABB4-288D43F0CB61}"/>
+                <a16:creationId xmlns:a16="http://schemas.microsoft.com/office/drawing/2014/main" id="{71ABB646-A740-4916-B5CD-001E6B93AF09}"/>
               </a:ext>
             </a:extLst>
           </p:cNvPr>
@@ -13512,7 +13512,7 @@
           <p:cNvPr id="31" name="">
             <a:extLst xmlns:a="http://schemas.openxmlformats.org/drawingml/2006/main">
               <a:ext uri="{FF2B5EF4-FFF2-40B4-BE49-F238E27FC236}">
-                <a16:creationId xmlns:a16="http://schemas.microsoft.com/office/drawing/2014/main" id="{0BBDA6D2-F380-4585-A070-F7CE8A0BC96B}"/>
+                <a16:creationId xmlns:a16="http://schemas.microsoft.com/office/drawing/2014/main" id="{1CBD32C4-A649-4DB1-95BB-D828821D4587}"/>
               </a:ext>
             </a:extLst>
           </p:cNvPr>
@@ -13545,7 +13545,7 @@
           <p:cNvPr id="32" name="">
             <a:extLst xmlns:a="http://schemas.openxmlformats.org/drawingml/2006/main">
               <a:ext uri="{FF2B5EF4-FFF2-40B4-BE49-F238E27FC236}">
-                <a16:creationId xmlns:a16="http://schemas.microsoft.com/office/drawing/2014/main" id="{8ED3B327-344D-49B4-A185-26290613D656}"/>
+                <a16:creationId xmlns:a16="http://schemas.microsoft.com/office/drawing/2014/main" id="{F1FFDA96-3A31-461F-9667-FBB94DCA896C}"/>
               </a:ext>
             </a:extLst>
           </p:cNvPr>
@@ -13609,7 +13609,7 @@
           <p:cNvPr id="33" name="">
             <a:extLst xmlns:a="http://schemas.openxmlformats.org/drawingml/2006/main">
               <a:ext uri="{FF2B5EF4-FFF2-40B4-BE49-F238E27FC236}">
-                <a16:creationId xmlns:a16="http://schemas.microsoft.com/office/drawing/2014/main" id="{2595C598-C17C-4DE5-A2DB-292E60AE69D0}"/>
+                <a16:creationId xmlns:a16="http://schemas.microsoft.com/office/drawing/2014/main" id="{D0654687-4620-4A87-901B-7F781BE7C975}"/>
               </a:ext>
             </a:extLst>
           </p:cNvPr>
@@ -13673,7 +13673,7 @@
           <p:cNvPr id="34" name="">
             <a:extLst xmlns:a="http://schemas.openxmlformats.org/drawingml/2006/main">
               <a:ext uri="{FF2B5EF4-FFF2-40B4-BE49-F238E27FC236}">
-                <a16:creationId xmlns:a16="http://schemas.microsoft.com/office/drawing/2014/main" id="{8408CAD0-DBD9-4C88-87B8-8EC73AAF871E}"/>
+                <a16:creationId xmlns:a16="http://schemas.microsoft.com/office/drawing/2014/main" id="{F287B360-870F-47E8-996E-CC25BF194C01}"/>
               </a:ext>
             </a:extLst>
           </p:cNvPr>
@@ -13706,7 +13706,7 @@
           <p:cNvPr id="35" name="">
             <a:extLst xmlns:a="http://schemas.openxmlformats.org/drawingml/2006/main">
               <a:ext uri="{FF2B5EF4-FFF2-40B4-BE49-F238E27FC236}">
-                <a16:creationId xmlns:a16="http://schemas.microsoft.com/office/drawing/2014/main" id="{50716869-C7DA-49EF-BD43-2925389C9A70}"/>
+                <a16:creationId xmlns:a16="http://schemas.microsoft.com/office/drawing/2014/main" id="{C4CBB557-FFFC-4E3C-94A2-30121B5BDED0}"/>
               </a:ext>
             </a:extLst>
           </p:cNvPr>
@@ -13739,7 +13739,7 @@
           <p:cNvPr id="36" name="">
             <a:extLst xmlns:a="http://schemas.openxmlformats.org/drawingml/2006/main">
               <a:ext uri="{FF2B5EF4-FFF2-40B4-BE49-F238E27FC236}">
-                <a16:creationId xmlns:a16="http://schemas.microsoft.com/office/drawing/2014/main" id="{27A11827-051D-4A6E-BF99-827BCC20058A}"/>
+                <a16:creationId xmlns:a16="http://schemas.microsoft.com/office/drawing/2014/main" id="{E09A7D32-285E-4734-A646-BE10FA6BC85A}"/>
               </a:ext>
             </a:extLst>
           </p:cNvPr>
@@ -13803,7 +13803,7 @@
           <p:cNvPr id="37" name="">
             <a:extLst xmlns:a="http://schemas.openxmlformats.org/drawingml/2006/main">
               <a:ext uri="{FF2B5EF4-FFF2-40B4-BE49-F238E27FC236}">
-                <a16:creationId xmlns:a16="http://schemas.microsoft.com/office/drawing/2014/main" id="{0D394BE5-6E0C-40CE-B68F-1ED188EA6D22}"/>
+                <a16:creationId xmlns:a16="http://schemas.microsoft.com/office/drawing/2014/main" id="{883430BB-AD40-4F40-84EA-39534140750F}"/>
               </a:ext>
             </a:extLst>
           </p:cNvPr>
@@ -13867,7 +13867,7 @@
           <p:cNvPr id="38" name="">
             <a:extLst xmlns:a="http://schemas.openxmlformats.org/drawingml/2006/main">
               <a:ext uri="{FF2B5EF4-FFF2-40B4-BE49-F238E27FC236}">
-                <a16:creationId xmlns:a16="http://schemas.microsoft.com/office/drawing/2014/main" id="{31EAADED-6812-48C6-8DED-07C4A137D5E3}"/>
+                <a16:creationId xmlns:a16="http://schemas.microsoft.com/office/drawing/2014/main" id="{F11A8ED0-6222-46A8-B1B3-57EFE40CB218}"/>
               </a:ext>
             </a:extLst>
           </p:cNvPr>
@@ -13900,7 +13900,7 @@
           <p:cNvPr id="39" name="">
             <a:extLst xmlns:a="http://schemas.openxmlformats.org/drawingml/2006/main">
               <a:ext uri="{FF2B5EF4-FFF2-40B4-BE49-F238E27FC236}">
-                <a16:creationId xmlns:a16="http://schemas.microsoft.com/office/drawing/2014/main" id="{3A6B0B07-0462-4369-93C1-FB80793C2F38}"/>
+                <a16:creationId xmlns:a16="http://schemas.microsoft.com/office/drawing/2014/main" id="{6C53CD2B-8B50-4227-BB5D-FDA860DFF12B}"/>
               </a:ext>
             </a:extLst>
           </p:cNvPr>
@@ -13933,7 +13933,7 @@
           <p:cNvPr id="40" name="">
             <a:extLst xmlns:a="http://schemas.openxmlformats.org/drawingml/2006/main">
               <a:ext uri="{FF2B5EF4-FFF2-40B4-BE49-F238E27FC236}">
-                <a16:creationId xmlns:a16="http://schemas.microsoft.com/office/drawing/2014/main" id="{FDBE8B46-CB97-431B-B2FF-9786F99A2387}"/>
+                <a16:creationId xmlns:a16="http://schemas.microsoft.com/office/drawing/2014/main" id="{D0DCB78F-E95B-4555-8147-34F3089F9FB8}"/>
               </a:ext>
             </a:extLst>
           </p:cNvPr>
@@ -13997,7 +13997,7 @@
           <p:cNvPr id="41" name="">
             <a:extLst xmlns:a="http://schemas.openxmlformats.org/drawingml/2006/main">
               <a:ext uri="{FF2B5EF4-FFF2-40B4-BE49-F238E27FC236}">
-                <a16:creationId xmlns:a16="http://schemas.microsoft.com/office/drawing/2014/main" id="{68B99E6C-DDD6-44C9-B965-D9BFFE813D2F}"/>
+                <a16:creationId xmlns:a16="http://schemas.microsoft.com/office/drawing/2014/main" id="{D1CF081C-BEDC-44EB-8220-DB3854D0934B}"/>
               </a:ext>
             </a:extLst>
           </p:cNvPr>
@@ -14061,7 +14061,7 @@
           <p:cNvPr id="42" name="">
             <a:extLst xmlns:a="http://schemas.openxmlformats.org/drawingml/2006/main">
               <a:ext uri="{FF2B5EF4-FFF2-40B4-BE49-F238E27FC236}">
-                <a16:creationId xmlns:a16="http://schemas.microsoft.com/office/drawing/2014/main" id="{6EA4011B-A4C7-4155-902C-13A7FA94A766}"/>
+                <a16:creationId xmlns:a16="http://schemas.microsoft.com/office/drawing/2014/main" id="{7DDD33B5-5029-4099-8058-B6085B938DF2}"/>
               </a:ext>
             </a:extLst>
           </p:cNvPr>
@@ -14125,7 +14125,7 @@
           <p:cNvPr id="43" name="">
             <a:extLst xmlns:a="http://schemas.openxmlformats.org/drawingml/2006/main">
               <a:ext uri="{FF2B5EF4-FFF2-40B4-BE49-F238E27FC236}">
-                <a16:creationId xmlns:a16="http://schemas.microsoft.com/office/drawing/2014/main" id="{44086B2C-3C37-4EBB-A356-9C81FB345442}"/>
+                <a16:creationId xmlns:a16="http://schemas.microsoft.com/office/drawing/2014/main" id="{C12415D6-DAC3-479C-B94C-143F75784B3E}"/>
               </a:ext>
             </a:extLst>
           </p:cNvPr>
@@ -14187,7 +14187,7 @@
     </p:spTree>
     <p:extLst>
       <p:ext uri="{BB962C8B-B14F-4D97-AF65-F5344CB8AC3E}">
-        <p14:creationId xmlns:p14="http://schemas.microsoft.com/office/powerpoint/2010/main" val="710159144"/>
+        <p14:creationId xmlns:p14="http://schemas.microsoft.com/office/powerpoint/2010/main" val="1194673959"/>
       </p:ext>
     </p:extLst>
   </p:cSld>
@@ -14211,7 +14211,7 @@
           <p:cNvPr id="1" name="">
             <a:extLst xmlns:a="http://schemas.openxmlformats.org/drawingml/2006/main">
               <a:ext uri="{FF2B5EF4-FFF2-40B4-BE49-F238E27FC236}">
-                <a16:creationId xmlns:a16="http://schemas.microsoft.com/office/drawing/2014/main" id="{6921BA2D-8B05-431B-8455-A7A5E65DCB08}"/>
+                <a16:creationId xmlns:a16="http://schemas.microsoft.com/office/drawing/2014/main" id="{3B9EEC84-6899-4F06-B29F-800A60D5C1E1}"/>
               </a:ext>
             </a:extLst>
           </p:cNvPr>
@@ -14246,7 +14246,7 @@
           <p:cNvPr id="2" name="">
             <a:extLst xmlns:a="http://schemas.openxmlformats.org/drawingml/2006/main">
               <a:ext uri="{FF2B5EF4-FFF2-40B4-BE49-F238E27FC236}">
-                <a16:creationId xmlns:a16="http://schemas.microsoft.com/office/drawing/2014/main" id="{3FF17EB1-24EF-40B7-A3B5-A6FCB399859E}"/>
+                <a16:creationId xmlns:a16="http://schemas.microsoft.com/office/drawing/2014/main" id="{9043D73B-F0C8-404A-A7D6-0877AA29640E}"/>
               </a:ext>
             </a:extLst>
           </p:cNvPr>
@@ -14281,7 +14281,7 @@
           <p:cNvPr id="3" name="">
             <a:extLst xmlns:a="http://schemas.openxmlformats.org/drawingml/2006/main">
               <a:ext uri="{FF2B5EF4-FFF2-40B4-BE49-F238E27FC236}">
-                <a16:creationId xmlns:a16="http://schemas.microsoft.com/office/drawing/2014/main" id="{E66F99AF-70AA-4DFE-9717-296850A3C62A}"/>
+                <a16:creationId xmlns:a16="http://schemas.microsoft.com/office/drawing/2014/main" id="{FD4C512B-9903-497A-886A-76185649002B}"/>
               </a:ext>
             </a:extLst>
           </p:cNvPr>
@@ -14345,7 +14345,7 @@
           <p:cNvPr id="4" name="">
             <a:extLst xmlns:a="http://schemas.openxmlformats.org/drawingml/2006/main">
               <a:ext uri="{FF2B5EF4-FFF2-40B4-BE49-F238E27FC236}">
-                <a16:creationId xmlns:a16="http://schemas.microsoft.com/office/drawing/2014/main" id="{83661563-424F-4935-A2F2-D99A2F736266}"/>
+                <a16:creationId xmlns:a16="http://schemas.microsoft.com/office/drawing/2014/main" id="{F45989B7-EE3D-4812-8CC7-BA3365DABDCA}"/>
               </a:ext>
             </a:extLst>
           </p:cNvPr>
@@ -14409,7 +14409,7 @@
           <p:cNvPr id="5" name="">
             <a:extLst xmlns:a="http://schemas.openxmlformats.org/drawingml/2006/main">
               <a:ext uri="{FF2B5EF4-FFF2-40B4-BE49-F238E27FC236}">
-                <a16:creationId xmlns:a16="http://schemas.microsoft.com/office/drawing/2014/main" id="{55AC71AC-16DE-4FCE-8057-78AB739365E6}"/>
+                <a16:creationId xmlns:a16="http://schemas.microsoft.com/office/drawing/2014/main" id="{FE859A76-9F43-4D86-8979-B0A90E4DD3FF}"/>
               </a:ext>
             </a:extLst>
           </p:cNvPr>
@@ -14442,7 +14442,7 @@
           <p:cNvPr id="6" name="">
             <a:extLst xmlns:a="http://schemas.openxmlformats.org/drawingml/2006/main">
               <a:ext uri="{FF2B5EF4-FFF2-40B4-BE49-F238E27FC236}">
-                <a16:creationId xmlns:a16="http://schemas.microsoft.com/office/drawing/2014/main" id="{6764391D-C7F1-4A4A-AC81-3AAA8898B838}"/>
+                <a16:creationId xmlns:a16="http://schemas.microsoft.com/office/drawing/2014/main" id="{6C6B4A7E-2692-4946-8278-B31D8DA611DA}"/>
               </a:ext>
             </a:extLst>
           </p:cNvPr>
@@ -14477,7 +14477,7 @@
           <p:cNvPr id="7" name="">
             <a:extLst xmlns:a="http://schemas.openxmlformats.org/drawingml/2006/main">
               <a:ext uri="{FF2B5EF4-FFF2-40B4-BE49-F238E27FC236}">
-                <a16:creationId xmlns:a16="http://schemas.microsoft.com/office/drawing/2014/main" id="{B6443B33-8E7D-49AA-8495-ACCEC3E73506}"/>
+                <a16:creationId xmlns:a16="http://schemas.microsoft.com/office/drawing/2014/main" id="{143AE597-D2C5-48B7-8916-BA21A3A0FD0B}"/>
               </a:ext>
             </a:extLst>
           </p:cNvPr>
@@ -14541,7 +14541,7 @@
           <p:cNvPr id="8" name="">
             <a:extLst xmlns:a="http://schemas.openxmlformats.org/drawingml/2006/main">
               <a:ext uri="{FF2B5EF4-FFF2-40B4-BE49-F238E27FC236}">
-                <a16:creationId xmlns:a16="http://schemas.microsoft.com/office/drawing/2014/main" id="{113876DA-7590-49BE-9243-EA902F787421}"/>
+                <a16:creationId xmlns:a16="http://schemas.microsoft.com/office/drawing/2014/main" id="{1624B61A-CD8F-4336-B4CC-D3F261CAFAB9}"/>
               </a:ext>
             </a:extLst>
           </p:cNvPr>
@@ -14605,7 +14605,7 @@
           <p:cNvPr id="9" name="">
             <a:extLst xmlns:a="http://schemas.openxmlformats.org/drawingml/2006/main">
               <a:ext uri="{FF2B5EF4-FFF2-40B4-BE49-F238E27FC236}">
-                <a16:creationId xmlns:a16="http://schemas.microsoft.com/office/drawing/2014/main" id="{CFE2165A-D952-4795-AC5B-190268229373}"/>
+                <a16:creationId xmlns:a16="http://schemas.microsoft.com/office/drawing/2014/main" id="{DA2842AB-14A8-4639-B8AD-87DC34A0E84E}"/>
               </a:ext>
             </a:extLst>
           </p:cNvPr>
@@ -14638,7 +14638,7 @@
           <p:cNvPr id="10" name="">
             <a:extLst xmlns:a="http://schemas.openxmlformats.org/drawingml/2006/main">
               <a:ext uri="{FF2B5EF4-FFF2-40B4-BE49-F238E27FC236}">
-                <a16:creationId xmlns:a16="http://schemas.microsoft.com/office/drawing/2014/main" id="{1BE834E4-D888-45B5-AF88-9ACFBD5E57DD}"/>
+                <a16:creationId xmlns:a16="http://schemas.microsoft.com/office/drawing/2014/main" id="{3A4DEAFD-7F6C-4798-8BD8-2E69459F33BE}"/>
               </a:ext>
             </a:extLst>
           </p:cNvPr>
@@ -14673,7 +14673,7 @@
           <p:cNvPr id="11" name="">
             <a:extLst xmlns:a="http://schemas.openxmlformats.org/drawingml/2006/main">
               <a:ext uri="{FF2B5EF4-FFF2-40B4-BE49-F238E27FC236}">
-                <a16:creationId xmlns:a16="http://schemas.microsoft.com/office/drawing/2014/main" id="{D1707048-FC2B-4A3F-B3F2-4349EC9CE67B}"/>
+                <a16:creationId xmlns:a16="http://schemas.microsoft.com/office/drawing/2014/main" id="{79881049-9A4E-431D-92D8-097F6CBA9A33}"/>
               </a:ext>
             </a:extLst>
           </p:cNvPr>
@@ -14737,7 +14737,7 @@
           <p:cNvPr id="12" name="">
             <a:extLst xmlns:a="http://schemas.openxmlformats.org/drawingml/2006/main">
               <a:ext uri="{FF2B5EF4-FFF2-40B4-BE49-F238E27FC236}">
-                <a16:creationId xmlns:a16="http://schemas.microsoft.com/office/drawing/2014/main" id="{6268B08C-E545-44FF-A075-BE9D1D6E55AA}"/>
+                <a16:creationId xmlns:a16="http://schemas.microsoft.com/office/drawing/2014/main" id="{FDA9D888-E65E-426F-9C95-617C39401A21}"/>
               </a:ext>
             </a:extLst>
           </p:cNvPr>
@@ -14801,7 +14801,7 @@
           <p:cNvPr id="13" name="">
             <a:extLst xmlns:a="http://schemas.openxmlformats.org/drawingml/2006/main">
               <a:ext uri="{FF2B5EF4-FFF2-40B4-BE49-F238E27FC236}">
-                <a16:creationId xmlns:a16="http://schemas.microsoft.com/office/drawing/2014/main" id="{6FC2045C-278B-4D74-AD67-BA516081B5AB}"/>
+                <a16:creationId xmlns:a16="http://schemas.microsoft.com/office/drawing/2014/main" id="{D8A576DC-3FE7-4E0E-A681-11F1578E24FB}"/>
               </a:ext>
             </a:extLst>
           </p:cNvPr>
@@ -14834,7 +14834,7 @@
           <p:cNvPr id="14" name="">
             <a:extLst xmlns:a="http://schemas.openxmlformats.org/drawingml/2006/main">
               <a:ext uri="{FF2B5EF4-FFF2-40B4-BE49-F238E27FC236}">
-                <a16:creationId xmlns:a16="http://schemas.microsoft.com/office/drawing/2014/main" id="{ADC3A880-E5FD-4ADB-A032-60D923D89130}"/>
+                <a16:creationId xmlns:a16="http://schemas.microsoft.com/office/drawing/2014/main" id="{5980579B-2250-4304-A7EC-A912BCF1FFFD}"/>
               </a:ext>
             </a:extLst>
           </p:cNvPr>
@@ -14869,7 +14869,7 @@
           <p:cNvPr id="15" name="">
             <a:extLst xmlns:a="http://schemas.openxmlformats.org/drawingml/2006/main">
               <a:ext uri="{FF2B5EF4-FFF2-40B4-BE49-F238E27FC236}">
-                <a16:creationId xmlns:a16="http://schemas.microsoft.com/office/drawing/2014/main" id="{0505E520-2F73-4D4B-9553-71E75DA1B581}"/>
+                <a16:creationId xmlns:a16="http://schemas.microsoft.com/office/drawing/2014/main" id="{6FB93B91-10AF-4186-B430-AE167F659B54}"/>
               </a:ext>
             </a:extLst>
           </p:cNvPr>
@@ -14933,7 +14933,7 @@
           <p:cNvPr id="16" name="">
             <a:extLst xmlns:a="http://schemas.openxmlformats.org/drawingml/2006/main">
               <a:ext uri="{FF2B5EF4-FFF2-40B4-BE49-F238E27FC236}">
-                <a16:creationId xmlns:a16="http://schemas.microsoft.com/office/drawing/2014/main" id="{4231B40C-56F9-4761-BD90-11CD2D1D719A}"/>
+                <a16:creationId xmlns:a16="http://schemas.microsoft.com/office/drawing/2014/main" id="{91F665FA-1E40-48EF-9CF8-96B67F9E2714}"/>
               </a:ext>
             </a:extLst>
           </p:cNvPr>
@@ -14997,7 +14997,7 @@
           <p:cNvPr id="17" name="">
             <a:extLst xmlns:a="http://schemas.openxmlformats.org/drawingml/2006/main">
               <a:ext uri="{FF2B5EF4-FFF2-40B4-BE49-F238E27FC236}">
-                <a16:creationId xmlns:a16="http://schemas.microsoft.com/office/drawing/2014/main" id="{1FF33409-DE06-4C48-AE56-3F866D2A5487}"/>
+                <a16:creationId xmlns:a16="http://schemas.microsoft.com/office/drawing/2014/main" id="{DD6BBB4D-D971-4D2E-A94B-B2BCDE2CE154}"/>
               </a:ext>
             </a:extLst>
           </p:cNvPr>
@@ -15030,7 +15030,7 @@
           <p:cNvPr id="18" name="">
             <a:extLst xmlns:a="http://schemas.openxmlformats.org/drawingml/2006/main">
               <a:ext uri="{FF2B5EF4-FFF2-40B4-BE49-F238E27FC236}">
-                <a16:creationId xmlns:a16="http://schemas.microsoft.com/office/drawing/2014/main" id="{6C242373-C520-48A4-B320-9DB2CA3E63D4}"/>
+                <a16:creationId xmlns:a16="http://schemas.microsoft.com/office/drawing/2014/main" id="{0351DC43-FBC1-46E8-8D12-1AD645C75A66}"/>
               </a:ext>
             </a:extLst>
           </p:cNvPr>
@@ -15065,7 +15065,7 @@
           <p:cNvPr id="19" name="">
             <a:extLst xmlns:a="http://schemas.openxmlformats.org/drawingml/2006/main">
               <a:ext uri="{FF2B5EF4-FFF2-40B4-BE49-F238E27FC236}">
-                <a16:creationId xmlns:a16="http://schemas.microsoft.com/office/drawing/2014/main" id="{5895A6D2-9E46-4A84-B62C-8BBD094B8C1A}"/>
+                <a16:creationId xmlns:a16="http://schemas.microsoft.com/office/drawing/2014/main" id="{255ABD91-8BDB-41B4-970E-E20146EDC224}"/>
               </a:ext>
             </a:extLst>
           </p:cNvPr>
@@ -15129,7 +15129,7 @@
           <p:cNvPr id="20" name="">
             <a:extLst xmlns:a="http://schemas.openxmlformats.org/drawingml/2006/main">
               <a:ext uri="{FF2B5EF4-FFF2-40B4-BE49-F238E27FC236}">
-                <a16:creationId xmlns:a16="http://schemas.microsoft.com/office/drawing/2014/main" id="{F58322DC-E1B3-4374-A9EE-6B6100CD04C5}"/>
+                <a16:creationId xmlns:a16="http://schemas.microsoft.com/office/drawing/2014/main" id="{176FC265-13FB-4CE9-B0DF-D4C6F2D1BD99}"/>
               </a:ext>
             </a:extLst>
           </p:cNvPr>
@@ -15193,7 +15193,7 @@
           <p:cNvPr id="21" name="">
             <a:extLst xmlns:a="http://schemas.openxmlformats.org/drawingml/2006/main">
               <a:ext uri="{FF2B5EF4-FFF2-40B4-BE49-F238E27FC236}">
-                <a16:creationId xmlns:a16="http://schemas.microsoft.com/office/drawing/2014/main" id="{8EF5EDDE-5527-4B99-BEE7-42C34BD011D4}"/>
+                <a16:creationId xmlns:a16="http://schemas.microsoft.com/office/drawing/2014/main" id="{17B458BC-E87C-4EB1-90B0-A5288C71E984}"/>
               </a:ext>
             </a:extLst>
           </p:cNvPr>
@@ -15257,7 +15257,7 @@
           <p:cNvPr id="22" name="">
             <a:extLst xmlns:a="http://schemas.openxmlformats.org/drawingml/2006/main">
               <a:ext uri="{FF2B5EF4-FFF2-40B4-BE49-F238E27FC236}">
-                <a16:creationId xmlns:a16="http://schemas.microsoft.com/office/drawing/2014/main" id="{B6DEFC59-F6D5-41F8-9471-A001EF51C959}"/>
+                <a16:creationId xmlns:a16="http://schemas.microsoft.com/office/drawing/2014/main" id="{7BDE7F62-21B2-4527-8A19-C93A950331A7}"/>
               </a:ext>
             </a:extLst>
           </p:cNvPr>
@@ -15290,7 +15290,7 @@
           <p:cNvPr id="23" name="">
             <a:extLst xmlns:a="http://schemas.openxmlformats.org/drawingml/2006/main">
               <a:ext uri="{FF2B5EF4-FFF2-40B4-BE49-F238E27FC236}">
-                <a16:creationId xmlns:a16="http://schemas.microsoft.com/office/drawing/2014/main" id="{03AD742E-FCC6-4EB3-B6C1-AB8BDE89D8FE}"/>
+                <a16:creationId xmlns:a16="http://schemas.microsoft.com/office/drawing/2014/main" id="{1F00FCC6-5B8C-44E4-BE03-BDF0755A22A1}"/>
               </a:ext>
             </a:extLst>
           </p:cNvPr>
@@ -15354,7 +15354,7 @@
           <p:cNvPr id="24" name="">
             <a:extLst xmlns:a="http://schemas.openxmlformats.org/drawingml/2006/main">
               <a:ext uri="{FF2B5EF4-FFF2-40B4-BE49-F238E27FC236}">
-                <a16:creationId xmlns:a16="http://schemas.microsoft.com/office/drawing/2014/main" id="{1E725E02-2309-4708-9375-153B4F98F6D9}"/>
+                <a16:creationId xmlns:a16="http://schemas.microsoft.com/office/drawing/2014/main" id="{D9D67AB2-F0A0-4AE3-AA21-8D9E7E479500}"/>
               </a:ext>
             </a:extLst>
           </p:cNvPr>
@@ -15387,7 +15387,7 @@
           <p:cNvPr id="25" name="">
             <a:extLst xmlns:a="http://schemas.openxmlformats.org/drawingml/2006/main">
               <a:ext uri="{FF2B5EF4-FFF2-40B4-BE49-F238E27FC236}">
-                <a16:creationId xmlns:a16="http://schemas.microsoft.com/office/drawing/2014/main" id="{8E54C54D-348F-44E6-B58F-B4581BB989FA}"/>
+                <a16:creationId xmlns:a16="http://schemas.microsoft.com/office/drawing/2014/main" id="{E77141F8-5AF9-4F03-BEE1-753E589E9EFA}"/>
               </a:ext>
             </a:extLst>
           </p:cNvPr>
@@ -15451,7 +15451,7 @@
           <p:cNvPr id="26" name="">
             <a:extLst xmlns:a="http://schemas.openxmlformats.org/drawingml/2006/main">
               <a:ext uri="{FF2B5EF4-FFF2-40B4-BE49-F238E27FC236}">
-                <a16:creationId xmlns:a16="http://schemas.microsoft.com/office/drawing/2014/main" id="{6E083747-80BA-4D46-B356-FF338633C403}"/>
+                <a16:creationId xmlns:a16="http://schemas.microsoft.com/office/drawing/2014/main" id="{99F884CE-72CD-4249-B813-A224F7C6E698}"/>
               </a:ext>
             </a:extLst>
           </p:cNvPr>
@@ -15484,7 +15484,7 @@
           <p:cNvPr id="27" name="">
             <a:extLst xmlns:a="http://schemas.openxmlformats.org/drawingml/2006/main">
               <a:ext uri="{FF2B5EF4-FFF2-40B4-BE49-F238E27FC236}">
-                <a16:creationId xmlns:a16="http://schemas.microsoft.com/office/drawing/2014/main" id="{49F6EA5E-3955-4C98-9394-2AE4B822E84E}"/>
+                <a16:creationId xmlns:a16="http://schemas.microsoft.com/office/drawing/2014/main" id="{3A108379-54A1-47E8-9974-25549309D035}"/>
               </a:ext>
             </a:extLst>
           </p:cNvPr>
@@ -15548,7 +15548,7 @@
           <p:cNvPr id="28" name="">
             <a:extLst xmlns:a="http://schemas.openxmlformats.org/drawingml/2006/main">
               <a:ext uri="{FF2B5EF4-FFF2-40B4-BE49-F238E27FC236}">
-                <a16:creationId xmlns:a16="http://schemas.microsoft.com/office/drawing/2014/main" id="{9BDFAFDE-9C9E-4444-BBE5-DECC0A4721D0}"/>
+                <a16:creationId xmlns:a16="http://schemas.microsoft.com/office/drawing/2014/main" id="{67CB9ADB-172A-4D34-B2E6-E6EA80FAAA91}"/>
               </a:ext>
             </a:extLst>
           </p:cNvPr>
@@ -15581,7 +15581,7 @@
           <p:cNvPr id="29" name="">
             <a:extLst xmlns:a="http://schemas.openxmlformats.org/drawingml/2006/main">
               <a:ext uri="{FF2B5EF4-FFF2-40B4-BE49-F238E27FC236}">
-                <a16:creationId xmlns:a16="http://schemas.microsoft.com/office/drawing/2014/main" id="{211D85F4-4FD6-4524-813A-83EB336AE0E7}"/>
+                <a16:creationId xmlns:a16="http://schemas.microsoft.com/office/drawing/2014/main" id="{87F96566-8AFB-4401-A168-4CA95AD44ED6}"/>
               </a:ext>
             </a:extLst>
           </p:cNvPr>
@@ -15645,7 +15645,7 @@
           <p:cNvPr id="30" name="">
             <a:extLst xmlns:a="http://schemas.openxmlformats.org/drawingml/2006/main">
               <a:ext uri="{FF2B5EF4-FFF2-40B4-BE49-F238E27FC236}">
-                <a16:creationId xmlns:a16="http://schemas.microsoft.com/office/drawing/2014/main" id="{33A5450C-AAEB-44AB-80AD-217E21E6DA56}"/>
+                <a16:creationId xmlns:a16="http://schemas.microsoft.com/office/drawing/2014/main" id="{7FDF0B25-B979-4E8A-B6E8-09CBCF7B1F64}"/>
               </a:ext>
             </a:extLst>
           </p:cNvPr>
@@ -15678,7 +15678,7 @@
           <p:cNvPr id="31" name="">
             <a:extLst xmlns:a="http://schemas.openxmlformats.org/drawingml/2006/main">
               <a:ext uri="{FF2B5EF4-FFF2-40B4-BE49-F238E27FC236}">
-                <a16:creationId xmlns:a16="http://schemas.microsoft.com/office/drawing/2014/main" id="{4657699D-1326-4AB7-8317-B897155440E3}"/>
+                <a16:creationId xmlns:a16="http://schemas.microsoft.com/office/drawing/2014/main" id="{A9CC0199-9D22-4168-803C-81643468F557}"/>
               </a:ext>
             </a:extLst>
           </p:cNvPr>
@@ -15742,7 +15742,7 @@
           <p:cNvPr id="32" name="">
             <a:extLst xmlns:a="http://schemas.openxmlformats.org/drawingml/2006/main">
               <a:ext uri="{FF2B5EF4-FFF2-40B4-BE49-F238E27FC236}">
-                <a16:creationId xmlns:a16="http://schemas.microsoft.com/office/drawing/2014/main" id="{17A77980-2FC3-46F5-9FDA-F433AF160790}"/>
+                <a16:creationId xmlns:a16="http://schemas.microsoft.com/office/drawing/2014/main" id="{44EF309A-5D72-4954-8A6D-40B319D9F457}"/>
               </a:ext>
             </a:extLst>
           </p:cNvPr>
@@ -15775,7 +15775,7 @@
           <p:cNvPr id="33" name="">
             <a:extLst xmlns:a="http://schemas.openxmlformats.org/drawingml/2006/main">
               <a:ext uri="{FF2B5EF4-FFF2-40B4-BE49-F238E27FC236}">
-                <a16:creationId xmlns:a16="http://schemas.microsoft.com/office/drawing/2014/main" id="{96216935-8594-4AF7-8F69-DFA04F82DC9B}"/>
+                <a16:creationId xmlns:a16="http://schemas.microsoft.com/office/drawing/2014/main" id="{A60E26C3-6DC9-4408-80A7-B906C0186F51}"/>
               </a:ext>
             </a:extLst>
           </p:cNvPr>
@@ -15839,7 +15839,7 @@
           <p:cNvPr id="34" name="">
             <a:extLst xmlns:a="http://schemas.openxmlformats.org/drawingml/2006/main">
               <a:ext uri="{FF2B5EF4-FFF2-40B4-BE49-F238E27FC236}">
-                <a16:creationId xmlns:a16="http://schemas.microsoft.com/office/drawing/2014/main" id="{A51B4C69-286E-4675-940F-92A592582CE8}"/>
+                <a16:creationId xmlns:a16="http://schemas.microsoft.com/office/drawing/2014/main" id="{5270BE4B-092B-464D-A4AF-A3367069A0E8}"/>
               </a:ext>
             </a:extLst>
           </p:cNvPr>
@@ -15872,7 +15872,7 @@
           <p:cNvPr id="35" name="">
             <a:extLst xmlns:a="http://schemas.openxmlformats.org/drawingml/2006/main">
               <a:ext uri="{FF2B5EF4-FFF2-40B4-BE49-F238E27FC236}">
-                <a16:creationId xmlns:a16="http://schemas.microsoft.com/office/drawing/2014/main" id="{F0D64847-0A19-41CC-89AE-73B79BA261F3}"/>
+                <a16:creationId xmlns:a16="http://schemas.microsoft.com/office/drawing/2014/main" id="{4D0DFC95-47C5-46C9-B5F9-3A0BB30559D9}"/>
               </a:ext>
             </a:extLst>
           </p:cNvPr>
@@ -15936,7 +15936,7 @@
           <p:cNvPr id="36" name="">
             <a:extLst xmlns:a="http://schemas.openxmlformats.org/drawingml/2006/main">
               <a:ext uri="{FF2B5EF4-FFF2-40B4-BE49-F238E27FC236}">
-                <a16:creationId xmlns:a16="http://schemas.microsoft.com/office/drawing/2014/main" id="{B4EDB47C-76FE-457C-849B-5FB7E4B7E480}"/>
+                <a16:creationId xmlns:a16="http://schemas.microsoft.com/office/drawing/2014/main" id="{4D3B801E-7860-4B12-9F63-7965A0EBF722}"/>
               </a:ext>
             </a:extLst>
           </p:cNvPr>
@@ -15969,7 +15969,7 @@
           <p:cNvPr id="37" name="">
             <a:extLst xmlns:a="http://schemas.openxmlformats.org/drawingml/2006/main">
               <a:ext uri="{FF2B5EF4-FFF2-40B4-BE49-F238E27FC236}">
-                <a16:creationId xmlns:a16="http://schemas.microsoft.com/office/drawing/2014/main" id="{303D8CD7-F7BF-4769-A888-C024FAA87E4F}"/>
+                <a16:creationId xmlns:a16="http://schemas.microsoft.com/office/drawing/2014/main" id="{919B40FC-A226-427A-BE80-7E04B567F929}"/>
               </a:ext>
             </a:extLst>
           </p:cNvPr>
@@ -16033,7 +16033,7 @@
           <p:cNvPr id="38" name="">
             <a:extLst xmlns:a="http://schemas.openxmlformats.org/drawingml/2006/main">
               <a:ext uri="{FF2B5EF4-FFF2-40B4-BE49-F238E27FC236}">
-                <a16:creationId xmlns:a16="http://schemas.microsoft.com/office/drawing/2014/main" id="{6B53A1A8-4DD6-4970-8CCB-D7897068C8D7}"/>
+                <a16:creationId xmlns:a16="http://schemas.microsoft.com/office/drawing/2014/main" id="{13BD7EA2-5675-47CB-B0AB-C7401F739D3A}"/>
               </a:ext>
             </a:extLst>
           </p:cNvPr>
@@ -16066,7 +16066,7 @@
           <p:cNvPr id="39" name="">
             <a:extLst xmlns:a="http://schemas.openxmlformats.org/drawingml/2006/main">
               <a:ext uri="{FF2B5EF4-FFF2-40B4-BE49-F238E27FC236}">
-                <a16:creationId xmlns:a16="http://schemas.microsoft.com/office/drawing/2014/main" id="{9BD06511-380E-4F2E-9DB6-E66920573AE6}"/>
+                <a16:creationId xmlns:a16="http://schemas.microsoft.com/office/drawing/2014/main" id="{E3F98EE6-04F3-41EB-A872-39430862F16D}"/>
               </a:ext>
             </a:extLst>
           </p:cNvPr>
@@ -16130,7 +16130,7 @@
           <p:cNvPr id="40" name="">
             <a:extLst xmlns:a="http://schemas.openxmlformats.org/drawingml/2006/main">
               <a:ext uri="{FF2B5EF4-FFF2-40B4-BE49-F238E27FC236}">
-                <a16:creationId xmlns:a16="http://schemas.microsoft.com/office/drawing/2014/main" id="{F06F49D1-3E69-4E04-A440-178FE2E4C2D2}"/>
+                <a16:creationId xmlns:a16="http://schemas.microsoft.com/office/drawing/2014/main" id="{78F1A4D1-6AB7-4BB5-B45C-6310D7C0E668}"/>
               </a:ext>
             </a:extLst>
           </p:cNvPr>
@@ -16194,7 +16194,7 @@
           <p:cNvPr id="41" name="">
             <a:extLst xmlns:a="http://schemas.openxmlformats.org/drawingml/2006/main">
               <a:ext uri="{FF2B5EF4-FFF2-40B4-BE49-F238E27FC236}">
-                <a16:creationId xmlns:a16="http://schemas.microsoft.com/office/drawing/2014/main" id="{E2CA5067-0424-4A9E-8C8B-525140928B89}"/>
+                <a16:creationId xmlns:a16="http://schemas.microsoft.com/office/drawing/2014/main" id="{1626B9F7-331E-4129-9954-8A6B4E774C76}"/>
               </a:ext>
             </a:extLst>
           </p:cNvPr>
@@ -16258,7 +16258,7 @@
           <p:cNvPr id="42" name="">
             <a:extLst xmlns:a="http://schemas.openxmlformats.org/drawingml/2006/main">
               <a:ext uri="{FF2B5EF4-FFF2-40B4-BE49-F238E27FC236}">
-                <a16:creationId xmlns:a16="http://schemas.microsoft.com/office/drawing/2014/main" id="{1423184E-5EDB-4403-A339-BBB82554DB17}"/>
+                <a16:creationId xmlns:a16="http://schemas.microsoft.com/office/drawing/2014/main" id="{8540967A-3824-4D8A-B258-E19FB4849A2A}"/>
               </a:ext>
             </a:extLst>
           </p:cNvPr>
@@ -16320,7 +16320,7 @@
     </p:spTree>
     <p:extLst>
       <p:ext uri="{BB962C8B-B14F-4D97-AF65-F5344CB8AC3E}">
-        <p14:creationId xmlns:p14="http://schemas.microsoft.com/office/powerpoint/2010/main" val="1753788857"/>
+        <p14:creationId xmlns:p14="http://schemas.microsoft.com/office/powerpoint/2010/main" val="1098169756"/>
       </p:ext>
     </p:extLst>
   </p:cSld>
@@ -16344,7 +16344,7 @@
           <p:cNvPr id="1" name="">
             <a:extLst xmlns:a="http://schemas.openxmlformats.org/drawingml/2006/main">
               <a:ext uri="{FF2B5EF4-FFF2-40B4-BE49-F238E27FC236}">
-                <a16:creationId xmlns:a16="http://schemas.microsoft.com/office/drawing/2014/main" id="{3C6A2DB2-D97C-4DFB-BE08-5E75F95C775C}"/>
+                <a16:creationId xmlns:a16="http://schemas.microsoft.com/office/drawing/2014/main" id="{87E82AFE-7E26-4C49-9402-72F3B9DE63DB}"/>
               </a:ext>
             </a:extLst>
           </p:cNvPr>
@@ -16379,7 +16379,7 @@
           <p:cNvPr id="2" name="">
             <a:extLst xmlns:a="http://schemas.openxmlformats.org/drawingml/2006/main">
               <a:ext uri="{FF2B5EF4-FFF2-40B4-BE49-F238E27FC236}">
-                <a16:creationId xmlns:a16="http://schemas.microsoft.com/office/drawing/2014/main" id="{033B4208-B85F-48F1-920F-6E153EA67F42}"/>
+                <a16:creationId xmlns:a16="http://schemas.microsoft.com/office/drawing/2014/main" id="{BF619C6C-1685-4D02-A003-2234F14CBDAF}"/>
               </a:ext>
             </a:extLst>
           </p:cNvPr>
@@ -16414,7 +16414,7 @@
           <p:cNvPr id="3" name="">
             <a:extLst xmlns:a="http://schemas.openxmlformats.org/drawingml/2006/main">
               <a:ext uri="{FF2B5EF4-FFF2-40B4-BE49-F238E27FC236}">
-                <a16:creationId xmlns:a16="http://schemas.microsoft.com/office/drawing/2014/main" id="{540C3802-F3AC-412D-9E8C-5AA085A570E7}"/>
+                <a16:creationId xmlns:a16="http://schemas.microsoft.com/office/drawing/2014/main" id="{AF19671C-F86E-4F26-960F-0E1260550242}"/>
               </a:ext>
             </a:extLst>
           </p:cNvPr>
@@ -16478,7 +16478,7 @@
           <p:cNvPr id="4" name="">
             <a:extLst xmlns:a="http://schemas.openxmlformats.org/drawingml/2006/main">
               <a:ext uri="{FF2B5EF4-FFF2-40B4-BE49-F238E27FC236}">
-                <a16:creationId xmlns:a16="http://schemas.microsoft.com/office/drawing/2014/main" id="{07C311AF-F40A-4E8E-A60A-7439F681C5C7}"/>
+                <a16:creationId xmlns:a16="http://schemas.microsoft.com/office/drawing/2014/main" id="{09D43C3D-3533-41E4-AD8A-1B5992630675}"/>
               </a:ext>
             </a:extLst>
           </p:cNvPr>
@@ -16542,7 +16542,7 @@
           <p:cNvPr id="5" name="">
             <a:extLst xmlns:a="http://schemas.openxmlformats.org/drawingml/2006/main">
               <a:ext uri="{FF2B5EF4-FFF2-40B4-BE49-F238E27FC236}">
-                <a16:creationId xmlns:a16="http://schemas.microsoft.com/office/drawing/2014/main" id="{126F20C9-0A97-4F74-BED8-A3078323261D}"/>
+                <a16:creationId xmlns:a16="http://schemas.microsoft.com/office/drawing/2014/main" id="{0AD7A500-57F0-4D39-B18F-D6EBB05409C8}"/>
               </a:ext>
             </a:extLst>
           </p:cNvPr>
@@ -16575,7 +16575,7 @@
           <p:cNvPr id="6" name="">
             <a:extLst xmlns:a="http://schemas.openxmlformats.org/drawingml/2006/main">
               <a:ext uri="{FF2B5EF4-FFF2-40B4-BE49-F238E27FC236}">
-                <a16:creationId xmlns:a16="http://schemas.microsoft.com/office/drawing/2014/main" id="{09E5451B-3AF9-4533-8287-57FB5E118D46}"/>
+                <a16:creationId xmlns:a16="http://schemas.microsoft.com/office/drawing/2014/main" id="{806BA1EA-23BC-49AF-8F4E-C1722BDD3E69}"/>
               </a:ext>
             </a:extLst>
           </p:cNvPr>
@@ -16639,7 +16639,7 @@
           <p:cNvPr id="7" name="">
             <a:extLst xmlns:a="http://schemas.openxmlformats.org/drawingml/2006/main">
               <a:ext uri="{FF2B5EF4-FFF2-40B4-BE49-F238E27FC236}">
-                <a16:creationId xmlns:a16="http://schemas.microsoft.com/office/drawing/2014/main" id="{1F6C7428-9757-47C6-A3BA-C61204542011}"/>
+                <a16:creationId xmlns:a16="http://schemas.microsoft.com/office/drawing/2014/main" id="{37B21210-2BF4-4073-BBB5-9AA0CA51B7AF}"/>
               </a:ext>
             </a:extLst>
           </p:cNvPr>
@@ -16672,7 +16672,7 @@
           <p:cNvPr id="8" name="">
             <a:extLst xmlns:a="http://schemas.openxmlformats.org/drawingml/2006/main">
               <a:ext uri="{FF2B5EF4-FFF2-40B4-BE49-F238E27FC236}">
-                <a16:creationId xmlns:a16="http://schemas.microsoft.com/office/drawing/2014/main" id="{35539A04-6B87-461D-92EC-C4758336E48E}"/>
+                <a16:creationId xmlns:a16="http://schemas.microsoft.com/office/drawing/2014/main" id="{EAEDE7ED-32B8-4C05-9E3F-6A091EB8599C}"/>
               </a:ext>
             </a:extLst>
           </p:cNvPr>
@@ -16736,7 +16736,7 @@
           <p:cNvPr id="9" name="">
             <a:extLst xmlns:a="http://schemas.openxmlformats.org/drawingml/2006/main">
               <a:ext uri="{FF2B5EF4-FFF2-40B4-BE49-F238E27FC236}">
-                <a16:creationId xmlns:a16="http://schemas.microsoft.com/office/drawing/2014/main" id="{23A18BFB-3702-4441-B83A-0A4122178034}"/>
+                <a16:creationId xmlns:a16="http://schemas.microsoft.com/office/drawing/2014/main" id="{2C51EDF9-F1DD-4450-BDC5-DE358E9A613F}"/>
               </a:ext>
             </a:extLst>
           </p:cNvPr>
@@ -16769,7 +16769,7 @@
           <p:cNvPr id="10" name="">
             <a:extLst xmlns:a="http://schemas.openxmlformats.org/drawingml/2006/main">
               <a:ext uri="{FF2B5EF4-FFF2-40B4-BE49-F238E27FC236}">
-                <a16:creationId xmlns:a16="http://schemas.microsoft.com/office/drawing/2014/main" id="{D0AEDD69-ADC7-4A85-ADD2-12552E752C6A}"/>
+                <a16:creationId xmlns:a16="http://schemas.microsoft.com/office/drawing/2014/main" id="{DA06FC51-D34C-4B20-9370-BE7B9C349151}"/>
               </a:ext>
             </a:extLst>
           </p:cNvPr>
@@ -16833,7 +16833,7 @@
           <p:cNvPr id="11" name="">
             <a:extLst xmlns:a="http://schemas.openxmlformats.org/drawingml/2006/main">
               <a:ext uri="{FF2B5EF4-FFF2-40B4-BE49-F238E27FC236}">
-                <a16:creationId xmlns:a16="http://schemas.microsoft.com/office/drawing/2014/main" id="{CA02D1A8-A91F-4AD0-A6BC-3D0F3F1A5E55}"/>
+                <a16:creationId xmlns:a16="http://schemas.microsoft.com/office/drawing/2014/main" id="{97DB9BB9-A27D-402E-9974-58F24385A0B5}"/>
               </a:ext>
             </a:extLst>
           </p:cNvPr>
@@ -16866,7 +16866,7 @@
           <p:cNvPr id="12" name="">
             <a:extLst xmlns:a="http://schemas.openxmlformats.org/drawingml/2006/main">
               <a:ext uri="{FF2B5EF4-FFF2-40B4-BE49-F238E27FC236}">
-                <a16:creationId xmlns:a16="http://schemas.microsoft.com/office/drawing/2014/main" id="{A51938D2-1B26-4C7F-A324-65DD1A7B3F97}"/>
+                <a16:creationId xmlns:a16="http://schemas.microsoft.com/office/drawing/2014/main" id="{B70650CD-E15E-45BD-BD6E-C2D491AE49BC}"/>
               </a:ext>
             </a:extLst>
           </p:cNvPr>
@@ -16930,7 +16930,7 @@
           <p:cNvPr id="13" name="">
             <a:extLst xmlns:a="http://schemas.openxmlformats.org/drawingml/2006/main">
               <a:ext uri="{FF2B5EF4-FFF2-40B4-BE49-F238E27FC236}">
-                <a16:creationId xmlns:a16="http://schemas.microsoft.com/office/drawing/2014/main" id="{BE240E0E-0BE5-48DF-BE16-35073F81AD1C}"/>
+                <a16:creationId xmlns:a16="http://schemas.microsoft.com/office/drawing/2014/main" id="{978561EE-1FBC-4477-A4D9-02195C9E466E}"/>
               </a:ext>
             </a:extLst>
           </p:cNvPr>
@@ -16963,7 +16963,7 @@
           <p:cNvPr id="14" name="">
             <a:extLst xmlns:a="http://schemas.openxmlformats.org/drawingml/2006/main">
               <a:ext uri="{FF2B5EF4-FFF2-40B4-BE49-F238E27FC236}">
-                <a16:creationId xmlns:a16="http://schemas.microsoft.com/office/drawing/2014/main" id="{ECEA9789-E799-4EEB-B76E-F0B4645A24D3}"/>
+                <a16:creationId xmlns:a16="http://schemas.microsoft.com/office/drawing/2014/main" id="{D32FC7DD-1B8B-4444-BD6D-9606218AFB52}"/>
               </a:ext>
             </a:extLst>
           </p:cNvPr>
@@ -17027,7 +17027,7 @@
           <p:cNvPr id="15" name="">
             <a:extLst xmlns:a="http://schemas.openxmlformats.org/drawingml/2006/main">
               <a:ext uri="{FF2B5EF4-FFF2-40B4-BE49-F238E27FC236}">
-                <a16:creationId xmlns:a16="http://schemas.microsoft.com/office/drawing/2014/main" id="{66B91CC2-C5CB-4559-9D78-0B1C82E2CEA1}"/>
+                <a16:creationId xmlns:a16="http://schemas.microsoft.com/office/drawing/2014/main" id="{A90C0BB4-027E-4D64-9797-17FCF117AF2D}"/>
               </a:ext>
             </a:extLst>
           </p:cNvPr>
@@ -17060,7 +17060,7 @@
           <p:cNvPr id="16" name="">
             <a:extLst xmlns:a="http://schemas.openxmlformats.org/drawingml/2006/main">
               <a:ext uri="{FF2B5EF4-FFF2-40B4-BE49-F238E27FC236}">
-                <a16:creationId xmlns:a16="http://schemas.microsoft.com/office/drawing/2014/main" id="{59217D33-0386-457C-8015-2F1430007550}"/>
+                <a16:creationId xmlns:a16="http://schemas.microsoft.com/office/drawing/2014/main" id="{D1E3D7F8-E16E-499A-B5E2-B825A48A7638}"/>
               </a:ext>
             </a:extLst>
           </p:cNvPr>
@@ -17124,7 +17124,7 @@
           <p:cNvPr id="17" name="">
             <a:extLst xmlns:a="http://schemas.openxmlformats.org/drawingml/2006/main">
               <a:ext uri="{FF2B5EF4-FFF2-40B4-BE49-F238E27FC236}">
-                <a16:creationId xmlns:a16="http://schemas.microsoft.com/office/drawing/2014/main" id="{5BE57F26-5AA9-4AF4-9D5E-0A87BD414B50}"/>
+                <a16:creationId xmlns:a16="http://schemas.microsoft.com/office/drawing/2014/main" id="{368F6E47-F016-4F2A-A9F6-F097D77E6F28}"/>
               </a:ext>
             </a:extLst>
           </p:cNvPr>
@@ -17157,7 +17157,7 @@
           <p:cNvPr id="18" name="">
             <a:extLst xmlns:a="http://schemas.openxmlformats.org/drawingml/2006/main">
               <a:ext uri="{FF2B5EF4-FFF2-40B4-BE49-F238E27FC236}">
-                <a16:creationId xmlns:a16="http://schemas.microsoft.com/office/drawing/2014/main" id="{430D5C3F-FD6E-4B73-B911-AAADA2B6B370}"/>
+                <a16:creationId xmlns:a16="http://schemas.microsoft.com/office/drawing/2014/main" id="{0F024F83-69DD-407E-AC96-F163965E4CCD}"/>
               </a:ext>
             </a:extLst>
           </p:cNvPr>
@@ -17221,7 +17221,7 @@
           <p:cNvPr id="19" name="">
             <a:extLst xmlns:a="http://schemas.openxmlformats.org/drawingml/2006/main">
               <a:ext uri="{FF2B5EF4-FFF2-40B4-BE49-F238E27FC236}">
-                <a16:creationId xmlns:a16="http://schemas.microsoft.com/office/drawing/2014/main" id="{A764FCF5-F2BB-4AD0-9058-60B13B1E2797}"/>
+                <a16:creationId xmlns:a16="http://schemas.microsoft.com/office/drawing/2014/main" id="{4AB05223-6D0A-4DFE-A2AF-6EFFC2681844}"/>
               </a:ext>
             </a:extLst>
           </p:cNvPr>
@@ -17254,7 +17254,7 @@
           <p:cNvPr id="20" name="">
             <a:extLst xmlns:a="http://schemas.openxmlformats.org/drawingml/2006/main">
               <a:ext uri="{FF2B5EF4-FFF2-40B4-BE49-F238E27FC236}">
-                <a16:creationId xmlns:a16="http://schemas.microsoft.com/office/drawing/2014/main" id="{8771DF03-B317-4C73-9CC4-59D39D7D91CA}"/>
+                <a16:creationId xmlns:a16="http://schemas.microsoft.com/office/drawing/2014/main" id="{66E72FCF-8EF5-4169-93DE-C3D5D6A05BED}"/>
               </a:ext>
             </a:extLst>
           </p:cNvPr>
@@ -17318,7 +17318,7 @@
           <p:cNvPr id="21" name="">
             <a:extLst xmlns:a="http://schemas.openxmlformats.org/drawingml/2006/main">
               <a:ext uri="{FF2B5EF4-FFF2-40B4-BE49-F238E27FC236}">
-                <a16:creationId xmlns:a16="http://schemas.microsoft.com/office/drawing/2014/main" id="{79CA280B-1F08-4E49-9A4B-2125755E52DF}"/>
+                <a16:creationId xmlns:a16="http://schemas.microsoft.com/office/drawing/2014/main" id="{E8FF033B-28F0-4E73-9CF1-FCC0119DB3E1}"/>
               </a:ext>
             </a:extLst>
           </p:cNvPr>
@@ -17351,7 +17351,7 @@
           <p:cNvPr id="22" name="">
             <a:extLst xmlns:a="http://schemas.openxmlformats.org/drawingml/2006/main">
               <a:ext uri="{FF2B5EF4-FFF2-40B4-BE49-F238E27FC236}">
-                <a16:creationId xmlns:a16="http://schemas.microsoft.com/office/drawing/2014/main" id="{6426794F-D725-40F8-9924-6CCD905DDDE7}"/>
+                <a16:creationId xmlns:a16="http://schemas.microsoft.com/office/drawing/2014/main" id="{EBB09E00-970D-483C-9EE5-BCF3DE155E15}"/>
               </a:ext>
             </a:extLst>
           </p:cNvPr>
@@ -17415,7 +17415,7 @@
           <p:cNvPr id="23" name="">
             <a:extLst xmlns:a="http://schemas.openxmlformats.org/drawingml/2006/main">
               <a:ext uri="{FF2B5EF4-FFF2-40B4-BE49-F238E27FC236}">
-                <a16:creationId xmlns:a16="http://schemas.microsoft.com/office/drawing/2014/main" id="{6153E3D2-0D78-4433-B056-2DC954952D6F}"/>
+                <a16:creationId xmlns:a16="http://schemas.microsoft.com/office/drawing/2014/main" id="{DAA9C9CF-848A-4810-B832-CAD562A8C718}"/>
               </a:ext>
             </a:extLst>
           </p:cNvPr>
@@ -17448,7 +17448,7 @@
           <p:cNvPr id="24" name="">
             <a:extLst xmlns:a="http://schemas.openxmlformats.org/drawingml/2006/main">
               <a:ext uri="{FF2B5EF4-FFF2-40B4-BE49-F238E27FC236}">
-                <a16:creationId xmlns:a16="http://schemas.microsoft.com/office/drawing/2014/main" id="{8F4D1ECD-42CD-4C76-B0D0-9669D6F825DA}"/>
+                <a16:creationId xmlns:a16="http://schemas.microsoft.com/office/drawing/2014/main" id="{949845D0-6A24-4D4A-BC08-43B9BFF1FE6D}"/>
               </a:ext>
             </a:extLst>
           </p:cNvPr>
@@ -17512,7 +17512,7 @@
           <p:cNvPr id="25" name="">
             <a:extLst xmlns:a="http://schemas.openxmlformats.org/drawingml/2006/main">
               <a:ext uri="{FF2B5EF4-FFF2-40B4-BE49-F238E27FC236}">
-                <a16:creationId xmlns:a16="http://schemas.microsoft.com/office/drawing/2014/main" id="{3F9C1606-98BE-43A7-9E72-A7C662482B8F}"/>
+                <a16:creationId xmlns:a16="http://schemas.microsoft.com/office/drawing/2014/main" id="{871FC3C4-9476-4316-9AB3-153B5E474815}"/>
               </a:ext>
             </a:extLst>
           </p:cNvPr>
@@ -17545,7 +17545,7 @@
           <p:cNvPr id="26" name="">
             <a:extLst xmlns:a="http://schemas.openxmlformats.org/drawingml/2006/main">
               <a:ext uri="{FF2B5EF4-FFF2-40B4-BE49-F238E27FC236}">
-                <a16:creationId xmlns:a16="http://schemas.microsoft.com/office/drawing/2014/main" id="{946BD396-3CE8-4454-B5AC-E7C80D9A7E8D}"/>
+                <a16:creationId xmlns:a16="http://schemas.microsoft.com/office/drawing/2014/main" id="{B2698E53-967C-4D26-B9FC-6FE0F61D1482}"/>
               </a:ext>
             </a:extLst>
           </p:cNvPr>
@@ -17609,7 +17609,7 @@
           <p:cNvPr id="27" name="">
             <a:extLst xmlns:a="http://schemas.openxmlformats.org/drawingml/2006/main">
               <a:ext uri="{FF2B5EF4-FFF2-40B4-BE49-F238E27FC236}">
-                <a16:creationId xmlns:a16="http://schemas.microsoft.com/office/drawing/2014/main" id="{42B85F2C-F908-4E57-88EF-721EBD69F076}"/>
+                <a16:creationId xmlns:a16="http://schemas.microsoft.com/office/drawing/2014/main" id="{2CB1723C-5964-4D8D-8B0E-8E3682E1954B}"/>
               </a:ext>
             </a:extLst>
           </p:cNvPr>
@@ -17642,7 +17642,7 @@
           <p:cNvPr id="28" name="">
             <a:extLst xmlns:a="http://schemas.openxmlformats.org/drawingml/2006/main">
               <a:ext uri="{FF2B5EF4-FFF2-40B4-BE49-F238E27FC236}">
-                <a16:creationId xmlns:a16="http://schemas.microsoft.com/office/drawing/2014/main" id="{E41A94DB-0389-4A3C-BE73-7C36AE044250}"/>
+                <a16:creationId xmlns:a16="http://schemas.microsoft.com/office/drawing/2014/main" id="{6CF2BC09-978B-4B6A-9783-7594E7C1525C}"/>
               </a:ext>
             </a:extLst>
           </p:cNvPr>
@@ -17706,7 +17706,7 @@
           <p:cNvPr id="29" name="">
             <a:extLst xmlns:a="http://schemas.openxmlformats.org/drawingml/2006/main">
               <a:ext uri="{FF2B5EF4-FFF2-40B4-BE49-F238E27FC236}">
-                <a16:creationId xmlns:a16="http://schemas.microsoft.com/office/drawing/2014/main" id="{FED4EE9A-5A2F-47F3-A661-5D6A8ECC2DB8}"/>
+                <a16:creationId xmlns:a16="http://schemas.microsoft.com/office/drawing/2014/main" id="{2D1BF0ED-646F-4C38-951E-401F1D0D47C7}"/>
               </a:ext>
             </a:extLst>
           </p:cNvPr>
@@ -17739,7 +17739,7 @@
           <p:cNvPr id="30" name="">
             <a:extLst xmlns:a="http://schemas.openxmlformats.org/drawingml/2006/main">
               <a:ext uri="{FF2B5EF4-FFF2-40B4-BE49-F238E27FC236}">
-                <a16:creationId xmlns:a16="http://schemas.microsoft.com/office/drawing/2014/main" id="{534CE330-51AA-4FC3-8C76-00AD9935EE99}"/>
+                <a16:creationId xmlns:a16="http://schemas.microsoft.com/office/drawing/2014/main" id="{1686FFED-C8A8-4488-BDE8-CEC6D653218B}"/>
               </a:ext>
             </a:extLst>
           </p:cNvPr>
@@ -17803,7 +17803,7 @@
           <p:cNvPr id="31" name="">
             <a:extLst xmlns:a="http://schemas.openxmlformats.org/drawingml/2006/main">
               <a:ext uri="{FF2B5EF4-FFF2-40B4-BE49-F238E27FC236}">
-                <a16:creationId xmlns:a16="http://schemas.microsoft.com/office/drawing/2014/main" id="{B08291F5-ECBC-4E69-92F4-0D7CA579CC18}"/>
+                <a16:creationId xmlns:a16="http://schemas.microsoft.com/office/drawing/2014/main" id="{57BCB2E5-EC47-467C-B03B-C0ECA645A133}"/>
               </a:ext>
             </a:extLst>
           </p:cNvPr>
@@ -17836,7 +17836,7 @@
           <p:cNvPr id="32" name="">
             <a:extLst xmlns:a="http://schemas.openxmlformats.org/drawingml/2006/main">
               <a:ext uri="{FF2B5EF4-FFF2-40B4-BE49-F238E27FC236}">
-                <a16:creationId xmlns:a16="http://schemas.microsoft.com/office/drawing/2014/main" id="{B4DC43FB-3917-419F-9E70-4A583760CC9E}"/>
+                <a16:creationId xmlns:a16="http://schemas.microsoft.com/office/drawing/2014/main" id="{1DB403A3-8F5B-4ED5-810C-F53B0BA3A87A}"/>
               </a:ext>
             </a:extLst>
           </p:cNvPr>
@@ -17900,7 +17900,7 @@
           <p:cNvPr id="33" name="">
             <a:extLst xmlns:a="http://schemas.openxmlformats.org/drawingml/2006/main">
               <a:ext uri="{FF2B5EF4-FFF2-40B4-BE49-F238E27FC236}">
-                <a16:creationId xmlns:a16="http://schemas.microsoft.com/office/drawing/2014/main" id="{B9CF9646-E357-4024-BE2E-F684E04368BE}"/>
+                <a16:creationId xmlns:a16="http://schemas.microsoft.com/office/drawing/2014/main" id="{371188ED-D95C-46E2-8B04-71E8648BED2C}"/>
               </a:ext>
             </a:extLst>
           </p:cNvPr>
@@ -17933,7 +17933,7 @@
           <p:cNvPr id="34" name="">
             <a:extLst xmlns:a="http://schemas.openxmlformats.org/drawingml/2006/main">
               <a:ext uri="{FF2B5EF4-FFF2-40B4-BE49-F238E27FC236}">
-                <a16:creationId xmlns:a16="http://schemas.microsoft.com/office/drawing/2014/main" id="{4AF82808-5BA5-4FD1-96B1-90B4B08A2724}"/>
+                <a16:creationId xmlns:a16="http://schemas.microsoft.com/office/drawing/2014/main" id="{4E7AE24E-2DA5-4690-8569-2DB4F847CF27}"/>
               </a:ext>
             </a:extLst>
           </p:cNvPr>
@@ -17997,7 +17997,7 @@
           <p:cNvPr id="35" name="">
             <a:extLst xmlns:a="http://schemas.openxmlformats.org/drawingml/2006/main">
               <a:ext uri="{FF2B5EF4-FFF2-40B4-BE49-F238E27FC236}">
-                <a16:creationId xmlns:a16="http://schemas.microsoft.com/office/drawing/2014/main" id="{EE75C495-FA91-4026-B37B-61BFC6AF81AC}"/>
+                <a16:creationId xmlns:a16="http://schemas.microsoft.com/office/drawing/2014/main" id="{CDE1695F-C9C6-408C-8547-E26C932E47AB}"/>
               </a:ext>
             </a:extLst>
           </p:cNvPr>
@@ -18030,7 +18030,7 @@
           <p:cNvPr id="36" name="">
             <a:extLst xmlns:a="http://schemas.openxmlformats.org/drawingml/2006/main">
               <a:ext uri="{FF2B5EF4-FFF2-40B4-BE49-F238E27FC236}">
-                <a16:creationId xmlns:a16="http://schemas.microsoft.com/office/drawing/2014/main" id="{E6EDE677-07E9-4EDF-BEE5-64E45BEAECE7}"/>
+                <a16:creationId xmlns:a16="http://schemas.microsoft.com/office/drawing/2014/main" id="{28132DEB-B114-4D38-838A-AAC48D499108}"/>
               </a:ext>
             </a:extLst>
           </p:cNvPr>
@@ -18094,7 +18094,7 @@
           <p:cNvPr id="37" name="">
             <a:extLst xmlns:a="http://schemas.openxmlformats.org/drawingml/2006/main">
               <a:ext uri="{FF2B5EF4-FFF2-40B4-BE49-F238E27FC236}">
-                <a16:creationId xmlns:a16="http://schemas.microsoft.com/office/drawing/2014/main" id="{269B1455-3371-4708-87CA-A470A9DB52EA}"/>
+                <a16:creationId xmlns:a16="http://schemas.microsoft.com/office/drawing/2014/main" id="{DD2EF486-DDF8-4E44-8B66-53B30D79A1E6}"/>
               </a:ext>
             </a:extLst>
           </p:cNvPr>
@@ -18127,7 +18127,7 @@
           <p:cNvPr id="38" name="">
             <a:extLst xmlns:a="http://schemas.openxmlformats.org/drawingml/2006/main">
               <a:ext uri="{FF2B5EF4-FFF2-40B4-BE49-F238E27FC236}">
-                <a16:creationId xmlns:a16="http://schemas.microsoft.com/office/drawing/2014/main" id="{D9491C73-0CE8-46A1-BFB3-36E039C8F9D0}"/>
+                <a16:creationId xmlns:a16="http://schemas.microsoft.com/office/drawing/2014/main" id="{2E1CE91B-F938-4B42-8144-9A76C64D6E06}"/>
               </a:ext>
             </a:extLst>
           </p:cNvPr>
@@ -18191,7 +18191,7 @@
           <p:cNvPr id="39" name="">
             <a:extLst xmlns:a="http://schemas.openxmlformats.org/drawingml/2006/main">
               <a:ext uri="{FF2B5EF4-FFF2-40B4-BE49-F238E27FC236}">
-                <a16:creationId xmlns:a16="http://schemas.microsoft.com/office/drawing/2014/main" id="{E4F60081-5539-4AFD-A674-99D98943A7F7}"/>
+                <a16:creationId xmlns:a16="http://schemas.microsoft.com/office/drawing/2014/main" id="{7B2E678D-3413-422C-BE06-5279C7EDCD4D}"/>
               </a:ext>
             </a:extLst>
           </p:cNvPr>
@@ -18224,7 +18224,7 @@
           <p:cNvPr id="40" name="">
             <a:extLst xmlns:a="http://schemas.openxmlformats.org/drawingml/2006/main">
               <a:ext uri="{FF2B5EF4-FFF2-40B4-BE49-F238E27FC236}">
-                <a16:creationId xmlns:a16="http://schemas.microsoft.com/office/drawing/2014/main" id="{00176546-C07C-4648-B114-C785173233F8}"/>
+                <a16:creationId xmlns:a16="http://schemas.microsoft.com/office/drawing/2014/main" id="{C1ABB065-7CA8-48FE-82BF-94B1AC6C8480}"/>
               </a:ext>
             </a:extLst>
           </p:cNvPr>
@@ -18288,7 +18288,7 @@
           <p:cNvPr id="41" name="">
             <a:extLst xmlns:a="http://schemas.openxmlformats.org/drawingml/2006/main">
               <a:ext uri="{FF2B5EF4-FFF2-40B4-BE49-F238E27FC236}">
-                <a16:creationId xmlns:a16="http://schemas.microsoft.com/office/drawing/2014/main" id="{8010B484-8332-4961-B079-56F515C6A19D}"/>
+                <a16:creationId xmlns:a16="http://schemas.microsoft.com/office/drawing/2014/main" id="{8C0A7F14-2EB4-417E-8029-89C958021188}"/>
               </a:ext>
             </a:extLst>
           </p:cNvPr>
@@ -18321,7 +18321,7 @@
           <p:cNvPr id="42" name="">
             <a:extLst xmlns:a="http://schemas.openxmlformats.org/drawingml/2006/main">
               <a:ext uri="{FF2B5EF4-FFF2-40B4-BE49-F238E27FC236}">
-                <a16:creationId xmlns:a16="http://schemas.microsoft.com/office/drawing/2014/main" id="{8D9D0CB9-C2CC-4880-8D6E-808A1760C586}"/>
+                <a16:creationId xmlns:a16="http://schemas.microsoft.com/office/drawing/2014/main" id="{AF2952AD-8AE2-46E0-88F7-36F216F59C33}"/>
               </a:ext>
             </a:extLst>
           </p:cNvPr>
@@ -18385,7 +18385,7 @@
           <p:cNvPr id="43" name="">
             <a:extLst xmlns:a="http://schemas.openxmlformats.org/drawingml/2006/main">
               <a:ext uri="{FF2B5EF4-FFF2-40B4-BE49-F238E27FC236}">
-                <a16:creationId xmlns:a16="http://schemas.microsoft.com/office/drawing/2014/main" id="{2AFC1E7E-0F33-4E76-96D4-27AED6F8133C}"/>
+                <a16:creationId xmlns:a16="http://schemas.microsoft.com/office/drawing/2014/main" id="{C398D6C6-5CC2-4EB3-BAEE-C9F2B3C53111}"/>
               </a:ext>
             </a:extLst>
           </p:cNvPr>
@@ -18449,7 +18449,7 @@
           <p:cNvPr id="44" name="">
             <a:extLst xmlns:a="http://schemas.openxmlformats.org/drawingml/2006/main">
               <a:ext uri="{FF2B5EF4-FFF2-40B4-BE49-F238E27FC236}">
-                <a16:creationId xmlns:a16="http://schemas.microsoft.com/office/drawing/2014/main" id="{FEC0280E-1F99-4664-9CBC-4CA9A3A3023F}"/>
+                <a16:creationId xmlns:a16="http://schemas.microsoft.com/office/drawing/2014/main" id="{788A9C2F-3F7D-4F0E-A559-96B15F13E0E6}"/>
               </a:ext>
             </a:extLst>
           </p:cNvPr>
@@ -18513,7 +18513,7 @@
           <p:cNvPr id="45" name="">
             <a:extLst xmlns:a="http://schemas.openxmlformats.org/drawingml/2006/main">
               <a:ext uri="{FF2B5EF4-FFF2-40B4-BE49-F238E27FC236}">
-                <a16:creationId xmlns:a16="http://schemas.microsoft.com/office/drawing/2014/main" id="{1CD2217F-CFA0-431C-8B6B-2E1747096B80}"/>
+                <a16:creationId xmlns:a16="http://schemas.microsoft.com/office/drawing/2014/main" id="{E875B6CF-E28A-4D7E-8148-6FCA46FA9544}"/>
               </a:ext>
             </a:extLst>
           </p:cNvPr>
@@ -18575,7 +18575,7 @@
     </p:spTree>
     <p:extLst>
       <p:ext uri="{BB962C8B-B14F-4D97-AF65-F5344CB8AC3E}">
-        <p14:creationId xmlns:p14="http://schemas.microsoft.com/office/powerpoint/2010/main" val="1743401545"/>
+        <p14:creationId xmlns:p14="http://schemas.microsoft.com/office/powerpoint/2010/main" val="2094323444"/>
       </p:ext>
     </p:extLst>
   </p:cSld>

</xml_diff>

<commit_message>
Add broad RandomizedSearchCV coverage
</commit_message>
<xml_diff>
--- a/presentation/analiza_sentimenta_recenzija.pptx
+++ b/presentation/analiza_sentimenta_recenzija.pptx
@@ -2,24 +2,24 @@
 <file path=ppt/presentation.xml><?xml version="1.0" encoding="utf-8"?>
 <p:presentation xmlns:p="http://schemas.openxmlformats.org/presentationml/2006/main">
   <p:sldMasterIdLst>
-    <p:sldMasterId xmlns:r="http://schemas.openxmlformats.org/officeDocument/2006/relationships" id="2147483648" r:id="Reeb38266d4954036"/>
+    <p:sldMasterId xmlns:r="http://schemas.openxmlformats.org/officeDocument/2006/relationships" id="2147483648" r:id="Rc218d9e9dee44f40"/>
   </p:sldMasterIdLst>
   <p:notesMasterIdLst>
-    <p:notesMasterId xmlns:r="http://schemas.openxmlformats.org/officeDocument/2006/relationships" r:id="Rad94ac0cca034dd4"/>
+    <p:notesMasterId xmlns:r="http://schemas.openxmlformats.org/officeDocument/2006/relationships" r:id="R4e3ffc26b56647f9"/>
   </p:notesMasterIdLst>
   <p:sldIdLst>
-    <p:sldId xmlns:r="http://schemas.openxmlformats.org/officeDocument/2006/relationships" id="256" r:id="R86da204419e14b15"/>
-    <p:sldId xmlns:r="http://schemas.openxmlformats.org/officeDocument/2006/relationships" id="257" r:id="Rb680987929d7456c"/>
-    <p:sldId xmlns:r="http://schemas.openxmlformats.org/officeDocument/2006/relationships" id="258" r:id="R03d30a45c8114c1f"/>
-    <p:sldId xmlns:r="http://schemas.openxmlformats.org/officeDocument/2006/relationships" id="259" r:id="R0ccb4e035e3740b9"/>
-    <p:sldId xmlns:r="http://schemas.openxmlformats.org/officeDocument/2006/relationships" id="260" r:id="R6185d6bd3d2f4571"/>
-    <p:sldId xmlns:r="http://schemas.openxmlformats.org/officeDocument/2006/relationships" id="261" r:id="Rc20913d43d30461f"/>
-    <p:sldId xmlns:r="http://schemas.openxmlformats.org/officeDocument/2006/relationships" id="262" r:id="R8dfe103e99ea4519"/>
-    <p:sldId xmlns:r="http://schemas.openxmlformats.org/officeDocument/2006/relationships" id="263" r:id="R642fef8db1a642b1"/>
-    <p:sldId xmlns:r="http://schemas.openxmlformats.org/officeDocument/2006/relationships" id="264" r:id="R6b5390efd5c44976"/>
-    <p:sldId xmlns:r="http://schemas.openxmlformats.org/officeDocument/2006/relationships" id="265" r:id="R992a3ec36ba84895"/>
-    <p:sldId xmlns:r="http://schemas.openxmlformats.org/officeDocument/2006/relationships" id="266" r:id="R947bb07e0cbc4362"/>
-    <p:sldId xmlns:r="http://schemas.openxmlformats.org/officeDocument/2006/relationships" id="267" r:id="R6d707e2886724476"/>
+    <p:sldId xmlns:r="http://schemas.openxmlformats.org/officeDocument/2006/relationships" id="256" r:id="Rd476c1c1078a4eb4"/>
+    <p:sldId xmlns:r="http://schemas.openxmlformats.org/officeDocument/2006/relationships" id="257" r:id="R33844ecbf2004b01"/>
+    <p:sldId xmlns:r="http://schemas.openxmlformats.org/officeDocument/2006/relationships" id="258" r:id="R0e8fdd0697f14b4d"/>
+    <p:sldId xmlns:r="http://schemas.openxmlformats.org/officeDocument/2006/relationships" id="259" r:id="R384ee12cd560472d"/>
+    <p:sldId xmlns:r="http://schemas.openxmlformats.org/officeDocument/2006/relationships" id="260" r:id="Rf8ab1c6523d04187"/>
+    <p:sldId xmlns:r="http://schemas.openxmlformats.org/officeDocument/2006/relationships" id="261" r:id="R1f3bf363e728419b"/>
+    <p:sldId xmlns:r="http://schemas.openxmlformats.org/officeDocument/2006/relationships" id="262" r:id="R6e533c589ad54772"/>
+    <p:sldId xmlns:r="http://schemas.openxmlformats.org/officeDocument/2006/relationships" id="263" r:id="R8f24de3bae7b4777"/>
+    <p:sldId xmlns:r="http://schemas.openxmlformats.org/officeDocument/2006/relationships" id="264" r:id="R4dd80e01f0cb499b"/>
+    <p:sldId xmlns:r="http://schemas.openxmlformats.org/officeDocument/2006/relationships" id="265" r:id="Rabf546b5f3ac4b83"/>
+    <p:sldId xmlns:r="http://schemas.openxmlformats.org/officeDocument/2006/relationships" id="266" r:id="R63aa5f31921e4747"/>
+    <p:sldId xmlns:r="http://schemas.openxmlformats.org/officeDocument/2006/relationships" id="267" r:id="Rce6a207268cc4bc4"/>
   </p:sldIdLst>
   <p:sldSz cx="12192000" cy="6858000"/>
   <p:notesSz cx="6858000" cy="9144000"/>
@@ -1292,7 +1292,7 @@
   </p:cSld>
   <p:clrMap bg1="lt1" tx1="dk1" bg2="lt2" tx2="dk2" accent1="accent1" accent2="accent2" accent3="accent3" accent4="accent4" accent5="accent5" accent6="accent6" hlink="hlink" folHlink="folHlink"/>
   <p:sldLayoutIdLst>
-    <p:sldLayoutId xmlns:r="http://schemas.openxmlformats.org/officeDocument/2006/relationships" id="2147483649" r:id="Rc81ec75663704953"/>
+    <p:sldLayoutId xmlns:r="http://schemas.openxmlformats.org/officeDocument/2006/relationships" id="2147483649" r:id="R2697e999290142d7"/>
   </p:sldLayoutIdLst>
   <p:txStyles>
     <p:titleStyle>
@@ -1907,6 +1907,7 @@
           <a:lstStyle xmlns:a="http://schemas.openxmlformats.org/drawingml/2006/main"/>
           <a:p xmlns:a="http://schemas.openxmlformats.org/drawingml/2006/main">
             <a:pPr algn="l">
+              <a:buNone/>
               <a:defRPr sz="3150" b="1">
                 <a:solidFill>
                   <a:srgbClr val="FFFFFF"/>
@@ -1971,6 +1972,7 @@
           <a:lstStyle xmlns:a="http://schemas.openxmlformats.org/drawingml/2006/main"/>
           <a:p xmlns:a="http://schemas.openxmlformats.org/drawingml/2006/main">
             <a:pPr algn="l">
+              <a:buNone/>
               <a:defRPr sz="1500" b="0">
                 <a:solidFill>
                   <a:srgbClr val="DDE7F5"/>
@@ -2103,6 +2105,7 @@
           <a:lstStyle xmlns:a="http://schemas.openxmlformats.org/drawingml/2006/main"/>
           <a:p xmlns:a="http://schemas.openxmlformats.org/drawingml/2006/main">
             <a:pPr algn="l">
+              <a:buNone/>
               <a:defRPr sz="975" b="1">
                 <a:solidFill>
                   <a:srgbClr val="5B6472"/>
@@ -2167,6 +2170,7 @@
           <a:lstStyle xmlns:a="http://schemas.openxmlformats.org/drawingml/2006/main"/>
           <a:p xmlns:a="http://schemas.openxmlformats.org/drawingml/2006/main">
             <a:pPr algn="l">
+              <a:buNone/>
               <a:defRPr sz="1725" b="1">
                 <a:solidFill>
                   <a:srgbClr val="111827"/>
@@ -2299,6 +2303,7 @@
           <a:lstStyle xmlns:a="http://schemas.openxmlformats.org/drawingml/2006/main"/>
           <a:p xmlns:a="http://schemas.openxmlformats.org/drawingml/2006/main">
             <a:pPr algn="l">
+              <a:buNone/>
               <a:defRPr sz="975" b="1">
                 <a:solidFill>
                   <a:srgbClr val="5B6472"/>
@@ -2363,6 +2368,7 @@
           <a:lstStyle xmlns:a="http://schemas.openxmlformats.org/drawingml/2006/main"/>
           <a:p xmlns:a="http://schemas.openxmlformats.org/drawingml/2006/main">
             <a:pPr algn="l">
+              <a:buNone/>
               <a:defRPr sz="1725" b="1">
                 <a:solidFill>
                   <a:srgbClr val="111827"/>
@@ -2495,6 +2501,7 @@
           <a:lstStyle xmlns:a="http://schemas.openxmlformats.org/drawingml/2006/main"/>
           <a:p xmlns:a="http://schemas.openxmlformats.org/drawingml/2006/main">
             <a:pPr algn="l">
+              <a:buNone/>
               <a:defRPr sz="975" b="1">
                 <a:solidFill>
                   <a:srgbClr val="5B6472"/>
@@ -2559,6 +2566,7 @@
           <a:lstStyle xmlns:a="http://schemas.openxmlformats.org/drawingml/2006/main"/>
           <a:p xmlns:a="http://schemas.openxmlformats.org/drawingml/2006/main">
             <a:pPr algn="l">
+              <a:buNone/>
               <a:defRPr sz="1725" b="1">
                 <a:solidFill>
                   <a:srgbClr val="111827"/>
@@ -2623,6 +2631,7 @@
           <a:lstStyle xmlns:a="http://schemas.openxmlformats.org/drawingml/2006/main"/>
           <a:p xmlns:a="http://schemas.openxmlformats.org/drawingml/2006/main">
             <a:pPr algn="l">
+              <a:buNone/>
               <a:defRPr sz="1200" b="0">
                 <a:solidFill>
                   <a:srgbClr val="CBD5E1"/>
@@ -2779,6 +2788,7 @@
           <a:lstStyle xmlns:a="http://schemas.openxmlformats.org/drawingml/2006/main"/>
           <a:p xmlns:a="http://schemas.openxmlformats.org/drawingml/2006/main">
             <a:pPr algn="l">
+              <a:buNone/>
               <a:defRPr sz="2025" b="1">
                 <a:solidFill>
                   <a:srgbClr val="FFFFFF"/>
@@ -2843,6 +2853,7 @@
           <a:lstStyle xmlns:a="http://schemas.openxmlformats.org/drawingml/2006/main"/>
           <a:p xmlns:a="http://schemas.openxmlformats.org/drawingml/2006/main">
             <a:pPr algn="r">
+              <a:buNone/>
               <a:defRPr sz="675" b="0">
                 <a:solidFill>
                   <a:srgbClr val="CBD5E1"/>
@@ -2875,7 +2886,7 @@
           <p:nvPr/>
         </p:nvPicPr>
         <p:blipFill>
-          <a:blip xmlns:r="http://schemas.openxmlformats.org/officeDocument/2006/relationships" xmlns:a="http://schemas.openxmlformats.org/drawingml/2006/main" r:embed="R5d9ae9662e174349"/>
+          <a:blip xmlns:r="http://schemas.openxmlformats.org/officeDocument/2006/relationships" xmlns:a="http://schemas.openxmlformats.org/drawingml/2006/main" r:embed="Rf37433721fb841db"/>
           <a:stretch xmlns:a="http://schemas.openxmlformats.org/drawingml/2006/main"/>
         </p:blipFill>
         <p:spPr>
@@ -2929,6 +2940,7 @@
           <a:lstStyle xmlns:a="http://schemas.openxmlformats.org/drawingml/2006/main"/>
           <a:p xmlns:a="http://schemas.openxmlformats.org/drawingml/2006/main">
             <a:pPr algn="l">
+              <a:buNone/>
               <a:defRPr sz="1050" b="1">
                 <a:solidFill>
                   <a:srgbClr val="111827"/>
@@ -3059,6 +3071,7 @@
           <a:lstStyle xmlns:a="http://schemas.openxmlformats.org/drawingml/2006/main"/>
           <a:p xmlns:a="http://schemas.openxmlformats.org/drawingml/2006/main">
             <a:pPr algn="r">
+              <a:buNone/>
               <a:defRPr sz="1050" b="1">
                 <a:solidFill>
                   <a:srgbClr val="111827"/>
@@ -3123,6 +3136,7 @@
           <a:lstStyle xmlns:a="http://schemas.openxmlformats.org/drawingml/2006/main"/>
           <a:p xmlns:a="http://schemas.openxmlformats.org/drawingml/2006/main">
             <a:pPr algn="l">
+              <a:buNone/>
               <a:defRPr sz="1050" b="1">
                 <a:solidFill>
                   <a:srgbClr val="111827"/>
@@ -3253,6 +3267,7 @@
           <a:lstStyle xmlns:a="http://schemas.openxmlformats.org/drawingml/2006/main"/>
           <a:p xmlns:a="http://schemas.openxmlformats.org/drawingml/2006/main">
             <a:pPr algn="r">
+              <a:buNone/>
               <a:defRPr sz="1050" b="1">
                 <a:solidFill>
                   <a:srgbClr val="111827"/>
@@ -3317,6 +3332,7 @@
           <a:lstStyle xmlns:a="http://schemas.openxmlformats.org/drawingml/2006/main"/>
           <a:p xmlns:a="http://schemas.openxmlformats.org/drawingml/2006/main">
             <a:pPr algn="l">
+              <a:buNone/>
               <a:defRPr sz="1050" b="1">
                 <a:solidFill>
                   <a:srgbClr val="111827"/>
@@ -3447,6 +3463,7 @@
           <a:lstStyle xmlns:a="http://schemas.openxmlformats.org/drawingml/2006/main"/>
           <a:p xmlns:a="http://schemas.openxmlformats.org/drawingml/2006/main">
             <a:pPr algn="r">
+              <a:buNone/>
               <a:defRPr sz="1050" b="1">
                 <a:solidFill>
                   <a:srgbClr val="111827"/>
@@ -3511,6 +3528,7 @@
           <a:lstStyle xmlns:a="http://schemas.openxmlformats.org/drawingml/2006/main"/>
           <a:p xmlns:a="http://schemas.openxmlformats.org/drawingml/2006/main">
             <a:pPr algn="l">
+              <a:buNone/>
               <a:defRPr sz="1050" b="1">
                 <a:solidFill>
                   <a:srgbClr val="111827"/>
@@ -3641,6 +3659,7 @@
           <a:lstStyle xmlns:a="http://schemas.openxmlformats.org/drawingml/2006/main"/>
           <a:p xmlns:a="http://schemas.openxmlformats.org/drawingml/2006/main">
             <a:pPr algn="r">
+              <a:buNone/>
               <a:defRPr sz="1050" b="1">
                 <a:solidFill>
                   <a:srgbClr val="111827"/>
@@ -3705,6 +3724,7 @@
           <a:lstStyle xmlns:a="http://schemas.openxmlformats.org/drawingml/2006/main"/>
           <a:p xmlns:a="http://schemas.openxmlformats.org/drawingml/2006/main">
             <a:pPr algn="ctr">
+              <a:buNone/>
               <a:defRPr sz="1800" b="1">
                 <a:solidFill>
                   <a:srgbClr val="334155"/>
@@ -3769,6 +3789,7 @@
           <a:lstStyle xmlns:a="http://schemas.openxmlformats.org/drawingml/2006/main"/>
           <a:p xmlns:a="http://schemas.openxmlformats.org/drawingml/2006/main">
             <a:pPr algn="l">
+              <a:buNone/>
               <a:defRPr sz="825" b="0">
                 <a:solidFill>
                   <a:srgbClr val="64748B"/>
@@ -3833,6 +3854,7 @@
           <a:lstStyle xmlns:a="http://schemas.openxmlformats.org/drawingml/2006/main"/>
           <a:p xmlns:a="http://schemas.openxmlformats.org/drawingml/2006/main">
             <a:pPr algn="r">
+              <a:buNone/>
               <a:defRPr sz="825" b="0">
                 <a:solidFill>
                   <a:srgbClr val="64748B"/>
@@ -3989,6 +4011,7 @@
           <a:lstStyle xmlns:a="http://schemas.openxmlformats.org/drawingml/2006/main"/>
           <a:p xmlns:a="http://schemas.openxmlformats.org/drawingml/2006/main">
             <a:pPr algn="l">
+              <a:buNone/>
               <a:defRPr sz="2025" b="1">
                 <a:solidFill>
                   <a:srgbClr val="FFFFFF"/>
@@ -4053,6 +4076,7 @@
           <a:lstStyle xmlns:a="http://schemas.openxmlformats.org/drawingml/2006/main"/>
           <a:p xmlns:a="http://schemas.openxmlformats.org/drawingml/2006/main">
             <a:pPr algn="r">
+              <a:buNone/>
               <a:defRPr sz="675" b="0">
                 <a:solidFill>
                   <a:srgbClr val="CBD5E1"/>
@@ -4150,6 +4174,7 @@
           <a:lstStyle xmlns:a="http://schemas.openxmlformats.org/drawingml/2006/main"/>
           <a:p xmlns:a="http://schemas.openxmlformats.org/drawingml/2006/main">
             <a:pPr algn="l">
+              <a:buNone/>
               <a:defRPr sz="1350" b="0">
                 <a:solidFill>
                   <a:srgbClr val="111827"/>
@@ -4247,6 +4272,7 @@
           <a:lstStyle xmlns:a="http://schemas.openxmlformats.org/drawingml/2006/main"/>
           <a:p xmlns:a="http://schemas.openxmlformats.org/drawingml/2006/main">
             <a:pPr algn="l">
+              <a:buNone/>
               <a:defRPr sz="1350" b="0">
                 <a:solidFill>
                   <a:srgbClr val="111827"/>
@@ -4344,6 +4370,97 @@
           <a:lstStyle xmlns:a="http://schemas.openxmlformats.org/drawingml/2006/main"/>
           <a:p xmlns:a="http://schemas.openxmlformats.org/drawingml/2006/main">
             <a:pPr algn="l">
+              <a:buNone/>
+              <a:defRPr sz="1350" b="0">
+                <a:solidFill>
+                  <a:srgbClr val="111827"/>
+                </a:solidFill>
+                <a:latin typeface="Aptos"/>
+                <a:ea typeface="Aptos"/>
+                <a:cs typeface="Aptos"/>
+              </a:defRPr>
+            </a:pPr>
+            <a:r>
+              <a:t>RandomizedSearchCV je pokrenut za svih 10 modela; linearni modeli su i dalje najjaci.</a:t>
+            </a:r>
+          </a:p>
+        </p:txBody>
+      </p:sp>
+      <p:sp>
+        <p:nvSpPr>
+          <p:cNvPr id="11" name="">
+            <a:extLst xmlns:a="http://schemas.openxmlformats.org/drawingml/2006/main">
+              <a:ext uri="{FF2B5EF4-FFF2-40B4-BE49-F238E27FC236}">
+                <a16:creationId xmlns:a16="http://schemas.microsoft.com/office/drawing/2014/main" id="{2260DAB6-808D-46EE-BDA3-8C693FC2346E}"/>
+              </a:ext>
+            </a:extLst>
+          </p:cNvPr>
+          <p:cNvSpPr>
+            <a:spLocks xmlns:a="http://schemas.openxmlformats.org/drawingml/2006/main" noGrp="1"/>
+          </p:cNvSpPr>
+          <p:nvPr/>
+        </p:nvSpPr>
+        <p:spPr>
+          <a:xfrm xmlns:a="http://schemas.openxmlformats.org/drawingml/2006/main">
+            <a:off x="1047750" y="3171825"/>
+            <a:ext cx="76200" cy="76200"/>
+          </a:xfrm>
+          <a:prstGeom xmlns:a="http://schemas.openxmlformats.org/drawingml/2006/main" prst="ellipse">
+            <a:avLst/>
+          </a:prstGeom>
+          <a:solidFill xmlns:a="http://schemas.openxmlformats.org/drawingml/2006/main">
+            <a:srgbClr val="2563EB"/>
+          </a:solidFill>
+          <a:ln xmlns:a="http://schemas.openxmlformats.org/drawingml/2006/main" w="0">
+            <a:solidFill>
+              <a:srgbClr val="2563EB"/>
+            </a:solidFill>
+            <a:prstDash val="solid"/>
+          </a:ln>
+        </p:spPr>
+      </p:sp>
+      <p:sp>
+        <p:nvSpPr>
+          <p:cNvPr id="12" name="">
+            <a:extLst xmlns:a="http://schemas.openxmlformats.org/drawingml/2006/main">
+              <a:ext uri="{FF2B5EF4-FFF2-40B4-BE49-F238E27FC236}">
+                <a16:creationId xmlns:a16="http://schemas.microsoft.com/office/drawing/2014/main" id="{F0240ED1-601A-48E7-A3A4-B0FCD52A3DA4}"/>
+              </a:ext>
+            </a:extLst>
+          </p:cNvPr>
+          <p:cNvSpPr>
+            <a:spLocks xmlns:a="http://schemas.openxmlformats.org/drawingml/2006/main" noGrp="1"/>
+          </p:cNvSpPr>
+          <p:nvPr/>
+        </p:nvSpPr>
+        <p:spPr>
+          <a:xfrm xmlns:a="http://schemas.openxmlformats.org/drawingml/2006/main">
+            <a:off x="1257300" y="3095625"/>
+            <a:ext cx="8667750" cy="323850"/>
+          </a:xfrm>
+          <a:prstGeom xmlns:a="http://schemas.openxmlformats.org/drawingml/2006/main" prst="rect">
+            <a:avLst/>
+          </a:prstGeom>
+          <a:solidFill xmlns:a="http://schemas.openxmlformats.org/drawingml/2006/main">
+            <a:srgbClr val="000000">
+              <a:alpha val="0"/>
+            </a:srgbClr>
+          </a:solidFill>
+          <a:ln xmlns:a="http://schemas.openxmlformats.org/drawingml/2006/main" w="0">
+            <a:solidFill>
+              <a:srgbClr val="000000">
+                <a:alpha val="0"/>
+              </a:srgbClr>
+            </a:solidFill>
+            <a:prstDash val="solid"/>
+          </a:ln>
+        </p:spPr>
+        <p:txBody>
+          <a:bodyPr xmlns:a="http://schemas.openxmlformats.org/drawingml/2006/main" lIns="0" tIns="0" rIns="0" bIns="0" anchor="t"/>
+          <a:lstStyle xmlns:a="http://schemas.openxmlformats.org/drawingml/2006/main"/>
+          <a:p xmlns:a="http://schemas.openxmlformats.org/drawingml/2006/main">
+            <a:pPr algn="l">
+              <a:buNone/>
               <a:defRPr sz="1350" b="0">
                 <a:solidFill>
                   <a:srgbClr val="111827"/>
@@ -4362,28 +4479,28 @@
                 <a:ea typeface="Aptos"/>
                 <a:cs typeface="Aptos"/>
               </a:rPr>
-              <a:t>RandomizedSearchCV je poboljsao Naive Bayes, ali izbor klase modela je vazniji.</a:t>
+              <a:t>Voting/Stacking je implementiran, ali ne nadmasuje najbolji pojedinacni model.</a:t>
             </a:r>
           </a:p>
         </p:txBody>
       </p:sp>
       <p:sp>
         <p:nvSpPr>
-          <p:cNvPr id="11" name="">
-            <a:extLst xmlns:a="http://schemas.openxmlformats.org/drawingml/2006/main">
-              <a:ext uri="{FF2B5EF4-FFF2-40B4-BE49-F238E27FC236}">
-                <a16:creationId xmlns:a16="http://schemas.microsoft.com/office/drawing/2014/main" id="{2260DAB6-808D-46EE-BDA3-8C693FC2346E}"/>
-              </a:ext>
-            </a:extLst>
-          </p:cNvPr>
-          <p:cNvSpPr>
-            <a:spLocks xmlns:a="http://schemas.openxmlformats.org/drawingml/2006/main" noGrp="1"/>
-          </p:cNvSpPr>
-          <p:nvPr/>
-        </p:nvSpPr>
-        <p:spPr>
-          <a:xfrm xmlns:a="http://schemas.openxmlformats.org/drawingml/2006/main">
-            <a:off x="1047750" y="3171825"/>
+          <p:cNvPr id="13" name="">
+            <a:extLst xmlns:a="http://schemas.openxmlformats.org/drawingml/2006/main">
+              <a:ext uri="{FF2B5EF4-FFF2-40B4-BE49-F238E27FC236}">
+                <a16:creationId xmlns:a16="http://schemas.microsoft.com/office/drawing/2014/main" id="{7669E6A1-D618-4170-99F8-C2D85A8DD488}"/>
+              </a:ext>
+            </a:extLst>
+          </p:cNvPr>
+          <p:cNvSpPr>
+            <a:spLocks xmlns:a="http://schemas.openxmlformats.org/drawingml/2006/main" noGrp="1"/>
+          </p:cNvSpPr>
+          <p:nvPr/>
+        </p:nvSpPr>
+        <p:spPr>
+          <a:xfrm xmlns:a="http://schemas.openxmlformats.org/drawingml/2006/main">
+            <a:off x="1047750" y="3743325"/>
             <a:ext cx="76200" cy="76200"/>
           </a:xfrm>
           <a:prstGeom xmlns:a="http://schemas.openxmlformats.org/drawingml/2006/main" prst="ellipse">
@@ -4402,21 +4519,21 @@
       </p:sp>
       <p:sp>
         <p:nvSpPr>
-          <p:cNvPr id="12" name="">
-            <a:extLst xmlns:a="http://schemas.openxmlformats.org/drawingml/2006/main">
-              <a:ext uri="{FF2B5EF4-FFF2-40B4-BE49-F238E27FC236}">
-                <a16:creationId xmlns:a16="http://schemas.microsoft.com/office/drawing/2014/main" id="{F0240ED1-601A-48E7-A3A4-B0FCD52A3DA4}"/>
-              </a:ext>
-            </a:extLst>
-          </p:cNvPr>
-          <p:cNvSpPr>
-            <a:spLocks xmlns:a="http://schemas.openxmlformats.org/drawingml/2006/main" noGrp="1"/>
-          </p:cNvSpPr>
-          <p:nvPr/>
-        </p:nvSpPr>
-        <p:spPr>
-          <a:xfrm xmlns:a="http://schemas.openxmlformats.org/drawingml/2006/main">
-            <a:off x="1257300" y="3095625"/>
+          <p:cNvPr id="14" name="">
+            <a:extLst xmlns:a="http://schemas.openxmlformats.org/drawingml/2006/main">
+              <a:ext uri="{FF2B5EF4-FFF2-40B4-BE49-F238E27FC236}">
+                <a16:creationId xmlns:a16="http://schemas.microsoft.com/office/drawing/2014/main" id="{5E5B1EF3-B5A8-4506-AC88-1081D13743AE}"/>
+              </a:ext>
+            </a:extLst>
+          </p:cNvPr>
+          <p:cNvSpPr>
+            <a:spLocks xmlns:a="http://schemas.openxmlformats.org/drawingml/2006/main" noGrp="1"/>
+          </p:cNvSpPr>
+          <p:nvPr/>
+        </p:nvSpPr>
+        <p:spPr>
+          <a:xfrm xmlns:a="http://schemas.openxmlformats.org/drawingml/2006/main">
+            <a:off x="1257300" y="3667125"/>
             <a:ext cx="8667750" cy="323850"/>
           </a:xfrm>
           <a:prstGeom xmlns:a="http://schemas.openxmlformats.org/drawingml/2006/main" prst="rect">
@@ -4441,6 +4558,7 @@
           <a:lstStyle xmlns:a="http://schemas.openxmlformats.org/drawingml/2006/main"/>
           <a:p xmlns:a="http://schemas.openxmlformats.org/drawingml/2006/main">
             <a:pPr algn="l">
+              <a:buNone/>
               <a:defRPr sz="1350" b="0">
                 <a:solidFill>
                   <a:srgbClr val="111827"/>
@@ -4459,62 +4577,29 @@
                 <a:ea typeface="Aptos"/>
                 <a:cs typeface="Aptos"/>
               </a:rPr>
-              <a:t>Voting/Stacking je implementiran, ali ne nadmasuje najbolji pojedinacni model.</a:t>
+              <a:t>Predtrenirani transformer daje najbolji ukupni rezultat, ali je dodatak, ne zamjena za zadatak.</a:t>
             </a:r>
           </a:p>
         </p:txBody>
       </p:sp>
       <p:sp>
         <p:nvSpPr>
-          <p:cNvPr id="13" name="">
-            <a:extLst xmlns:a="http://schemas.openxmlformats.org/drawingml/2006/main">
-              <a:ext uri="{FF2B5EF4-FFF2-40B4-BE49-F238E27FC236}">
-                <a16:creationId xmlns:a16="http://schemas.microsoft.com/office/drawing/2014/main" id="{7669E6A1-D618-4170-99F8-C2D85A8DD488}"/>
-              </a:ext>
-            </a:extLst>
-          </p:cNvPr>
-          <p:cNvSpPr>
-            <a:spLocks xmlns:a="http://schemas.openxmlformats.org/drawingml/2006/main" noGrp="1"/>
-          </p:cNvSpPr>
-          <p:nvPr/>
-        </p:nvSpPr>
-        <p:spPr>
-          <a:xfrm xmlns:a="http://schemas.openxmlformats.org/drawingml/2006/main">
-            <a:off x="1047750" y="3743325"/>
-            <a:ext cx="76200" cy="76200"/>
-          </a:xfrm>
-          <a:prstGeom xmlns:a="http://schemas.openxmlformats.org/drawingml/2006/main" prst="ellipse">
-            <a:avLst/>
-          </a:prstGeom>
-          <a:solidFill xmlns:a="http://schemas.openxmlformats.org/drawingml/2006/main">
-            <a:srgbClr val="2563EB"/>
-          </a:solidFill>
-          <a:ln xmlns:a="http://schemas.openxmlformats.org/drawingml/2006/main" w="0">
-            <a:solidFill>
-              <a:srgbClr val="2563EB"/>
-            </a:solidFill>
-            <a:prstDash val="solid"/>
-          </a:ln>
-        </p:spPr>
-      </p:sp>
-      <p:sp>
-        <p:nvSpPr>
-          <p:cNvPr id="14" name="">
-            <a:extLst xmlns:a="http://schemas.openxmlformats.org/drawingml/2006/main">
-              <a:ext uri="{FF2B5EF4-FFF2-40B4-BE49-F238E27FC236}">
-                <a16:creationId xmlns:a16="http://schemas.microsoft.com/office/drawing/2014/main" id="{5E5B1EF3-B5A8-4506-AC88-1081D13743AE}"/>
-              </a:ext>
-            </a:extLst>
-          </p:cNvPr>
-          <p:cNvSpPr>
-            <a:spLocks xmlns:a="http://schemas.openxmlformats.org/drawingml/2006/main" noGrp="1"/>
-          </p:cNvSpPr>
-          <p:nvPr/>
-        </p:nvSpPr>
-        <p:spPr>
-          <a:xfrm xmlns:a="http://schemas.openxmlformats.org/drawingml/2006/main">
-            <a:off x="1257300" y="3667125"/>
-            <a:ext cx="8667750" cy="323850"/>
+          <p:cNvPr id="15" name="">
+            <a:extLst xmlns:a="http://schemas.openxmlformats.org/drawingml/2006/main">
+              <a:ext uri="{FF2B5EF4-FFF2-40B4-BE49-F238E27FC236}">
+                <a16:creationId xmlns:a16="http://schemas.microsoft.com/office/drawing/2014/main" id="{8A82D2A0-8153-462B-B9C4-032A01ABB830}"/>
+              </a:ext>
+            </a:extLst>
+          </p:cNvPr>
+          <p:cNvSpPr>
+            <a:spLocks xmlns:a="http://schemas.openxmlformats.org/drawingml/2006/main" noGrp="1"/>
+          </p:cNvSpPr>
+          <p:nvPr/>
+        </p:nvSpPr>
+        <p:spPr>
+          <a:xfrm xmlns:a="http://schemas.openxmlformats.org/drawingml/2006/main">
+            <a:off x="1047750" y="5067300"/>
+            <a:ext cx="9144000" cy="685800"/>
           </a:xfrm>
           <a:prstGeom xmlns:a="http://schemas.openxmlformats.org/drawingml/2006/main" prst="rect">
             <a:avLst/>
@@ -4538,70 +4623,7 @@
           <a:lstStyle xmlns:a="http://schemas.openxmlformats.org/drawingml/2006/main"/>
           <a:p xmlns:a="http://schemas.openxmlformats.org/drawingml/2006/main">
             <a:pPr algn="l">
-              <a:defRPr sz="1350" b="0">
-                <a:solidFill>
-                  <a:srgbClr val="111827"/>
-                </a:solidFill>
-                <a:latin typeface="Aptos"/>
-                <a:ea typeface="Aptos"/>
-                <a:cs typeface="Aptos"/>
-              </a:defRPr>
-            </a:pPr>
-            <a:r>
-              <a:rPr sz="1350" b="0">
-                <a:solidFill>
-                  <a:srgbClr val="111827"/>
-                </a:solidFill>
-                <a:latin typeface="Aptos"/>
-                <a:ea typeface="Aptos"/>
-                <a:cs typeface="Aptos"/>
-              </a:rPr>
-              <a:t>Predtrenirani transformer daje najbolji ukupni rezultat, ali je dodatak, ne zamjena za zadatak.</a:t>
-            </a:r>
-          </a:p>
-        </p:txBody>
-      </p:sp>
-      <p:sp>
-        <p:nvSpPr>
-          <p:cNvPr id="15" name="">
-            <a:extLst xmlns:a="http://schemas.openxmlformats.org/drawingml/2006/main">
-              <a:ext uri="{FF2B5EF4-FFF2-40B4-BE49-F238E27FC236}">
-                <a16:creationId xmlns:a16="http://schemas.microsoft.com/office/drawing/2014/main" id="{8A82D2A0-8153-462B-B9C4-032A01ABB830}"/>
-              </a:ext>
-            </a:extLst>
-          </p:cNvPr>
-          <p:cNvSpPr>
-            <a:spLocks xmlns:a="http://schemas.openxmlformats.org/drawingml/2006/main" noGrp="1"/>
-          </p:cNvSpPr>
-          <p:nvPr/>
-        </p:nvSpPr>
-        <p:spPr>
-          <a:xfrm xmlns:a="http://schemas.openxmlformats.org/drawingml/2006/main">
-            <a:off x="1047750" y="5067300"/>
-            <a:ext cx="9144000" cy="685800"/>
-          </a:xfrm>
-          <a:prstGeom xmlns:a="http://schemas.openxmlformats.org/drawingml/2006/main" prst="rect">
-            <a:avLst/>
-          </a:prstGeom>
-          <a:solidFill xmlns:a="http://schemas.openxmlformats.org/drawingml/2006/main">
-            <a:srgbClr val="000000">
-              <a:alpha val="0"/>
-            </a:srgbClr>
-          </a:solidFill>
-          <a:ln xmlns:a="http://schemas.openxmlformats.org/drawingml/2006/main" w="0">
-            <a:solidFill>
-              <a:srgbClr val="000000">
-                <a:alpha val="0"/>
-              </a:srgbClr>
-            </a:solidFill>
-            <a:prstDash val="solid"/>
-          </a:ln>
-        </p:spPr>
-        <p:txBody>
-          <a:bodyPr xmlns:a="http://schemas.openxmlformats.org/drawingml/2006/main" lIns="0" tIns="0" rIns="0" bIns="0" anchor="t"/>
-          <a:lstStyle xmlns:a="http://schemas.openxmlformats.org/drawingml/2006/main"/>
-          <a:p xmlns:a="http://schemas.openxmlformats.org/drawingml/2006/main">
-            <a:pPr algn="l">
+              <a:buNone/>
               <a:defRPr sz="1650" b="1">
                 <a:solidFill>
                   <a:srgbClr val="2563EB"/>
@@ -4666,6 +4688,7 @@
           <a:lstStyle xmlns:a="http://schemas.openxmlformats.org/drawingml/2006/main"/>
           <a:p xmlns:a="http://schemas.openxmlformats.org/drawingml/2006/main">
             <a:pPr algn="l">
+              <a:buNone/>
               <a:defRPr sz="825" b="0">
                 <a:solidFill>
                   <a:srgbClr val="64748B"/>
@@ -4730,6 +4753,7 @@
           <a:lstStyle xmlns:a="http://schemas.openxmlformats.org/drawingml/2006/main"/>
           <a:p xmlns:a="http://schemas.openxmlformats.org/drawingml/2006/main">
             <a:pPr algn="r">
+              <a:buNone/>
               <a:defRPr sz="825" b="0">
                 <a:solidFill>
                   <a:srgbClr val="64748B"/>
@@ -4886,6 +4910,7 @@
           <a:lstStyle xmlns:a="http://schemas.openxmlformats.org/drawingml/2006/main"/>
           <a:p xmlns:a="http://schemas.openxmlformats.org/drawingml/2006/main">
             <a:pPr algn="l">
+              <a:buNone/>
               <a:defRPr sz="2025" b="1">
                 <a:solidFill>
                   <a:srgbClr val="FFFFFF"/>
@@ -4950,6 +4975,7 @@
           <a:lstStyle xmlns:a="http://schemas.openxmlformats.org/drawingml/2006/main"/>
           <a:p xmlns:a="http://schemas.openxmlformats.org/drawingml/2006/main">
             <a:pPr algn="r">
+              <a:buNone/>
               <a:defRPr sz="675" b="0">
                 <a:solidFill>
                   <a:srgbClr val="CBD5E1"/>
@@ -5047,6 +5073,7 @@
           <a:lstStyle xmlns:a="http://schemas.openxmlformats.org/drawingml/2006/main"/>
           <a:p xmlns:a="http://schemas.openxmlformats.org/drawingml/2006/main">
             <a:pPr algn="l">
+              <a:buNone/>
               <a:defRPr sz="975" b="1">
                 <a:solidFill>
                   <a:srgbClr val="334155"/>
@@ -5144,6 +5171,7 @@
           <a:lstStyle xmlns:a="http://schemas.openxmlformats.org/drawingml/2006/main"/>
           <a:p xmlns:a="http://schemas.openxmlformats.org/drawingml/2006/main">
             <a:pPr algn="l">
+              <a:buNone/>
               <a:defRPr sz="975" b="1">
                 <a:solidFill>
                   <a:srgbClr val="334155"/>
@@ -5241,6 +5269,7 @@
           <a:lstStyle xmlns:a="http://schemas.openxmlformats.org/drawingml/2006/main"/>
           <a:p xmlns:a="http://schemas.openxmlformats.org/drawingml/2006/main">
             <a:pPr algn="l">
+              <a:buNone/>
               <a:defRPr sz="975" b="0">
                 <a:solidFill>
                   <a:srgbClr val="111827"/>
@@ -5338,6 +5367,7 @@
           <a:lstStyle xmlns:a="http://schemas.openxmlformats.org/drawingml/2006/main"/>
           <a:p xmlns:a="http://schemas.openxmlformats.org/drawingml/2006/main">
             <a:pPr algn="r">
+              <a:buNone/>
               <a:defRPr sz="975" b="0">
                 <a:solidFill>
                   <a:srgbClr val="111827"/>
@@ -5435,6 +5465,7 @@
           <a:lstStyle xmlns:a="http://schemas.openxmlformats.org/drawingml/2006/main"/>
           <a:p xmlns:a="http://schemas.openxmlformats.org/drawingml/2006/main">
             <a:pPr algn="l">
+              <a:buNone/>
               <a:defRPr sz="975" b="0">
                 <a:solidFill>
                   <a:srgbClr val="111827"/>
@@ -5532,6 +5563,7 @@
           <a:lstStyle xmlns:a="http://schemas.openxmlformats.org/drawingml/2006/main"/>
           <a:p xmlns:a="http://schemas.openxmlformats.org/drawingml/2006/main">
             <a:pPr algn="r">
+              <a:buNone/>
               <a:defRPr sz="975" b="0">
                 <a:solidFill>
                   <a:srgbClr val="111827"/>
@@ -5629,6 +5661,7 @@
           <a:lstStyle xmlns:a="http://schemas.openxmlformats.org/drawingml/2006/main"/>
           <a:p xmlns:a="http://schemas.openxmlformats.org/drawingml/2006/main">
             <a:pPr algn="l">
+              <a:buNone/>
               <a:defRPr sz="975" b="0">
                 <a:solidFill>
                   <a:srgbClr val="111827"/>
@@ -5726,6 +5759,7 @@
           <a:lstStyle xmlns:a="http://schemas.openxmlformats.org/drawingml/2006/main"/>
           <a:p xmlns:a="http://schemas.openxmlformats.org/drawingml/2006/main">
             <a:pPr algn="r">
+              <a:buNone/>
               <a:defRPr sz="975" b="0">
                 <a:solidFill>
                   <a:srgbClr val="111827"/>
@@ -5823,6 +5857,7 @@
           <a:lstStyle xmlns:a="http://schemas.openxmlformats.org/drawingml/2006/main"/>
           <a:p xmlns:a="http://schemas.openxmlformats.org/drawingml/2006/main">
             <a:pPr algn="l">
+              <a:buNone/>
               <a:defRPr sz="975" b="0">
                 <a:solidFill>
                   <a:srgbClr val="111827"/>
@@ -5920,6 +5955,7 @@
           <a:lstStyle xmlns:a="http://schemas.openxmlformats.org/drawingml/2006/main"/>
           <a:p xmlns:a="http://schemas.openxmlformats.org/drawingml/2006/main">
             <a:pPr algn="r">
+              <a:buNone/>
               <a:defRPr sz="975" b="0">
                 <a:solidFill>
                   <a:srgbClr val="111827"/>
@@ -6017,6 +6053,7 @@
           <a:lstStyle xmlns:a="http://schemas.openxmlformats.org/drawingml/2006/main"/>
           <a:p xmlns:a="http://schemas.openxmlformats.org/drawingml/2006/main">
             <a:pPr algn="l">
+              <a:buNone/>
               <a:defRPr sz="975" b="0">
                 <a:solidFill>
                   <a:srgbClr val="111827"/>
@@ -6114,6 +6151,7 @@
           <a:lstStyle xmlns:a="http://schemas.openxmlformats.org/drawingml/2006/main"/>
           <a:p xmlns:a="http://schemas.openxmlformats.org/drawingml/2006/main">
             <a:pPr algn="r">
+              <a:buNone/>
               <a:defRPr sz="975" b="0">
                 <a:solidFill>
                   <a:srgbClr val="111827"/>
@@ -6178,6 +6216,7 @@
           <a:lstStyle xmlns:a="http://schemas.openxmlformats.org/drawingml/2006/main"/>
           <a:p xmlns:a="http://schemas.openxmlformats.org/drawingml/2006/main">
             <a:pPr algn="l">
+              <a:buNone/>
               <a:defRPr sz="1650" b="1">
                 <a:solidFill>
                   <a:srgbClr val="111827"/>
@@ -6275,6 +6314,7 @@
           <a:lstStyle xmlns:a="http://schemas.openxmlformats.org/drawingml/2006/main"/>
           <a:p xmlns:a="http://schemas.openxmlformats.org/drawingml/2006/main">
             <a:pPr algn="l">
+              <a:buNone/>
               <a:defRPr sz="1350" b="0">
                 <a:solidFill>
                   <a:srgbClr val="E2E8F0"/>
@@ -6339,6 +6379,7 @@
           <a:lstStyle xmlns:a="http://schemas.openxmlformats.org/drawingml/2006/main"/>
           <a:p xmlns:a="http://schemas.openxmlformats.org/drawingml/2006/main">
             <a:pPr algn="l">
+              <a:buNone/>
               <a:defRPr sz="1575" b="1">
                 <a:solidFill>
                   <a:srgbClr val="059669"/>
@@ -6403,6 +6444,7 @@
           <a:lstStyle xmlns:a="http://schemas.openxmlformats.org/drawingml/2006/main"/>
           <a:p xmlns:a="http://schemas.openxmlformats.org/drawingml/2006/main">
             <a:pPr algn="l">
+              <a:buNone/>
               <a:defRPr sz="825" b="0">
                 <a:solidFill>
                   <a:srgbClr val="64748B"/>
@@ -6467,6 +6509,7 @@
           <a:lstStyle xmlns:a="http://schemas.openxmlformats.org/drawingml/2006/main"/>
           <a:p xmlns:a="http://schemas.openxmlformats.org/drawingml/2006/main">
             <a:pPr algn="r">
+              <a:buNone/>
               <a:defRPr sz="825" b="0">
                 <a:solidFill>
                   <a:srgbClr val="64748B"/>
@@ -6623,6 +6666,7 @@
           <a:lstStyle xmlns:a="http://schemas.openxmlformats.org/drawingml/2006/main"/>
           <a:p xmlns:a="http://schemas.openxmlformats.org/drawingml/2006/main">
             <a:pPr algn="l">
+              <a:buNone/>
               <a:defRPr sz="2025" b="1">
                 <a:solidFill>
                   <a:srgbClr val="FFFFFF"/>
@@ -6687,6 +6731,7 @@
           <a:lstStyle xmlns:a="http://schemas.openxmlformats.org/drawingml/2006/main"/>
           <a:p xmlns:a="http://schemas.openxmlformats.org/drawingml/2006/main">
             <a:pPr algn="r">
+              <a:buNone/>
               <a:defRPr sz="675" b="0">
                 <a:solidFill>
                   <a:srgbClr val="CBD5E1"/>
@@ -6784,6 +6829,7 @@
           <a:lstStyle xmlns:a="http://schemas.openxmlformats.org/drawingml/2006/main"/>
           <a:p xmlns:a="http://schemas.openxmlformats.org/drawingml/2006/main">
             <a:pPr algn="l">
+              <a:buNone/>
               <a:defRPr sz="1200" b="1">
                 <a:solidFill>
                   <a:srgbClr val="2563EB"/>
@@ -6848,6 +6894,7 @@
           <a:lstStyle xmlns:a="http://schemas.openxmlformats.org/drawingml/2006/main"/>
           <a:p xmlns:a="http://schemas.openxmlformats.org/drawingml/2006/main">
             <a:pPr algn="l">
+              <a:buNone/>
               <a:defRPr sz="1425" b="0">
                 <a:solidFill>
                   <a:srgbClr val="111827"/>
@@ -6945,6 +6992,7 @@
           <a:lstStyle xmlns:a="http://schemas.openxmlformats.org/drawingml/2006/main"/>
           <a:p xmlns:a="http://schemas.openxmlformats.org/drawingml/2006/main">
             <a:pPr algn="l">
+              <a:buNone/>
               <a:defRPr sz="1200" b="1">
                 <a:solidFill>
                   <a:srgbClr val="2563EB"/>
@@ -7009,6 +7057,7 @@
           <a:lstStyle xmlns:a="http://schemas.openxmlformats.org/drawingml/2006/main"/>
           <a:p xmlns:a="http://schemas.openxmlformats.org/drawingml/2006/main">
             <a:pPr algn="l">
+              <a:buNone/>
               <a:defRPr sz="1425" b="0">
                 <a:solidFill>
                   <a:srgbClr val="111827"/>
@@ -7106,6 +7155,7 @@
           <a:lstStyle xmlns:a="http://schemas.openxmlformats.org/drawingml/2006/main"/>
           <a:p xmlns:a="http://schemas.openxmlformats.org/drawingml/2006/main">
             <a:pPr algn="l">
+              <a:buNone/>
               <a:defRPr sz="1200" b="1">
                 <a:solidFill>
                   <a:srgbClr val="2563EB"/>
@@ -7170,6 +7220,7 @@
           <a:lstStyle xmlns:a="http://schemas.openxmlformats.org/drawingml/2006/main"/>
           <a:p xmlns:a="http://schemas.openxmlformats.org/drawingml/2006/main">
             <a:pPr algn="l">
+              <a:buNone/>
               <a:defRPr sz="1425" b="0">
                 <a:solidFill>
                   <a:srgbClr val="111827"/>
@@ -7267,6 +7318,7 @@
           <a:lstStyle xmlns:a="http://schemas.openxmlformats.org/drawingml/2006/main"/>
           <a:p xmlns:a="http://schemas.openxmlformats.org/drawingml/2006/main">
             <a:pPr algn="l">
+              <a:buNone/>
               <a:defRPr sz="1200" b="1">
                 <a:solidFill>
                   <a:srgbClr val="2563EB"/>
@@ -7331,6 +7383,7 @@
           <a:lstStyle xmlns:a="http://schemas.openxmlformats.org/drawingml/2006/main"/>
           <a:p xmlns:a="http://schemas.openxmlformats.org/drawingml/2006/main">
             <a:pPr algn="l">
+              <a:buNone/>
               <a:defRPr sz="1425" b="0">
                 <a:solidFill>
                   <a:srgbClr val="111827"/>
@@ -7428,6 +7481,7 @@
           <a:lstStyle xmlns:a="http://schemas.openxmlformats.org/drawingml/2006/main"/>
           <a:p xmlns:a="http://schemas.openxmlformats.org/drawingml/2006/main">
             <a:pPr algn="l">
+              <a:buNone/>
               <a:defRPr sz="1200" b="1">
                 <a:solidFill>
                   <a:srgbClr val="2563EB"/>
@@ -7492,6 +7546,7 @@
           <a:lstStyle xmlns:a="http://schemas.openxmlformats.org/drawingml/2006/main"/>
           <a:p xmlns:a="http://schemas.openxmlformats.org/drawingml/2006/main">
             <a:pPr algn="l">
+              <a:buNone/>
               <a:defRPr sz="1425" b="0">
                 <a:solidFill>
                   <a:srgbClr val="111827"/>
@@ -7589,6 +7644,7 @@
           <a:lstStyle xmlns:a="http://schemas.openxmlformats.org/drawingml/2006/main"/>
           <a:p xmlns:a="http://schemas.openxmlformats.org/drawingml/2006/main">
             <a:pPr algn="l">
+              <a:buNone/>
               <a:defRPr sz="1200" b="1">
                 <a:solidFill>
                   <a:srgbClr val="2563EB"/>
@@ -7653,6 +7709,7 @@
           <a:lstStyle xmlns:a="http://schemas.openxmlformats.org/drawingml/2006/main"/>
           <a:p xmlns:a="http://schemas.openxmlformats.org/drawingml/2006/main">
             <a:pPr algn="l">
+              <a:buNone/>
               <a:defRPr sz="1425" b="0">
                 <a:solidFill>
                   <a:srgbClr val="111827"/>
@@ -7717,6 +7774,7 @@
           <a:lstStyle xmlns:a="http://schemas.openxmlformats.org/drawingml/2006/main"/>
           <a:p xmlns:a="http://schemas.openxmlformats.org/drawingml/2006/main">
             <a:pPr algn="l">
+              <a:buNone/>
               <a:defRPr sz="1425" b="1">
                 <a:solidFill>
                   <a:srgbClr val="334155"/>
@@ -7781,6 +7839,7 @@
           <a:lstStyle xmlns:a="http://schemas.openxmlformats.org/drawingml/2006/main"/>
           <a:p xmlns:a="http://schemas.openxmlformats.org/drawingml/2006/main">
             <a:pPr algn="l">
+              <a:buNone/>
               <a:defRPr sz="825" b="0">
                 <a:solidFill>
                   <a:srgbClr val="64748B"/>
@@ -7845,6 +7904,7 @@
           <a:lstStyle xmlns:a="http://schemas.openxmlformats.org/drawingml/2006/main"/>
           <a:p xmlns:a="http://schemas.openxmlformats.org/drawingml/2006/main">
             <a:pPr algn="r">
+              <a:buNone/>
               <a:defRPr sz="825" b="0">
                 <a:solidFill>
                   <a:srgbClr val="64748B"/>
@@ -8001,6 +8061,7 @@
           <a:lstStyle xmlns:a="http://schemas.openxmlformats.org/drawingml/2006/main"/>
           <a:p xmlns:a="http://schemas.openxmlformats.org/drawingml/2006/main">
             <a:pPr algn="l">
+              <a:buNone/>
               <a:defRPr sz="2025" b="1">
                 <a:solidFill>
                   <a:srgbClr val="FFFFFF"/>
@@ -8065,6 +8126,7 @@
           <a:lstStyle xmlns:a="http://schemas.openxmlformats.org/drawingml/2006/main"/>
           <a:p xmlns:a="http://schemas.openxmlformats.org/drawingml/2006/main">
             <a:pPr algn="r">
+              <a:buNone/>
               <a:defRPr sz="675" b="0">
                 <a:solidFill>
                   <a:srgbClr val="CBD5E1"/>
@@ -8197,6 +8259,7 @@
           <a:lstStyle xmlns:a="http://schemas.openxmlformats.org/drawingml/2006/main"/>
           <a:p xmlns:a="http://schemas.openxmlformats.org/drawingml/2006/main">
             <a:pPr algn="l">
+              <a:buNone/>
               <a:defRPr sz="975" b="1">
                 <a:solidFill>
                   <a:srgbClr val="5B6472"/>
@@ -8261,6 +8324,7 @@
           <a:lstStyle xmlns:a="http://schemas.openxmlformats.org/drawingml/2006/main"/>
           <a:p xmlns:a="http://schemas.openxmlformats.org/drawingml/2006/main">
             <a:pPr algn="l">
+              <a:buNone/>
               <a:defRPr sz="1725" b="1">
                 <a:solidFill>
                   <a:srgbClr val="111827"/>
@@ -8393,6 +8457,7 @@
           <a:lstStyle xmlns:a="http://schemas.openxmlformats.org/drawingml/2006/main"/>
           <a:p xmlns:a="http://schemas.openxmlformats.org/drawingml/2006/main">
             <a:pPr algn="l">
+              <a:buNone/>
               <a:defRPr sz="975" b="1">
                 <a:solidFill>
                   <a:srgbClr val="5B6472"/>
@@ -8457,6 +8522,7 @@
           <a:lstStyle xmlns:a="http://schemas.openxmlformats.org/drawingml/2006/main"/>
           <a:p xmlns:a="http://schemas.openxmlformats.org/drawingml/2006/main">
             <a:pPr algn="l">
+              <a:buNone/>
               <a:defRPr sz="1725" b="1">
                 <a:solidFill>
                   <a:srgbClr val="111827"/>
@@ -8589,6 +8655,7 @@
           <a:lstStyle xmlns:a="http://schemas.openxmlformats.org/drawingml/2006/main"/>
           <a:p xmlns:a="http://schemas.openxmlformats.org/drawingml/2006/main">
             <a:pPr algn="l">
+              <a:buNone/>
               <a:defRPr sz="975" b="1">
                 <a:solidFill>
                   <a:srgbClr val="5B6472"/>
@@ -8653,6 +8720,7 @@
           <a:lstStyle xmlns:a="http://schemas.openxmlformats.org/drawingml/2006/main"/>
           <a:p xmlns:a="http://schemas.openxmlformats.org/drawingml/2006/main">
             <a:pPr algn="l">
+              <a:buNone/>
               <a:defRPr sz="1725" b="1">
                 <a:solidFill>
                   <a:srgbClr val="111827"/>
@@ -8785,6 +8853,7 @@
           <a:lstStyle xmlns:a="http://schemas.openxmlformats.org/drawingml/2006/main"/>
           <a:p xmlns:a="http://schemas.openxmlformats.org/drawingml/2006/main">
             <a:pPr algn="l">
+              <a:buNone/>
               <a:defRPr sz="975" b="1">
                 <a:solidFill>
                   <a:srgbClr val="5B6472"/>
@@ -8849,6 +8918,7 @@
           <a:lstStyle xmlns:a="http://schemas.openxmlformats.org/drawingml/2006/main"/>
           <a:p xmlns:a="http://schemas.openxmlformats.org/drawingml/2006/main">
             <a:pPr algn="l">
+              <a:buNone/>
               <a:defRPr sz="1725" b="1">
                 <a:solidFill>
                   <a:srgbClr val="111827"/>
@@ -8946,6 +9016,7 @@
           <a:lstStyle xmlns:a="http://schemas.openxmlformats.org/drawingml/2006/main"/>
           <a:p xmlns:a="http://schemas.openxmlformats.org/drawingml/2006/main">
             <a:pPr algn="l">
+              <a:buNone/>
               <a:defRPr sz="1350" b="0">
                 <a:solidFill>
                   <a:srgbClr val="111827"/>
@@ -9043,6 +9114,7 @@
           <a:lstStyle xmlns:a="http://schemas.openxmlformats.org/drawingml/2006/main"/>
           <a:p xmlns:a="http://schemas.openxmlformats.org/drawingml/2006/main">
             <a:pPr algn="l">
+              <a:buNone/>
               <a:defRPr sz="1350" b="0">
                 <a:solidFill>
                   <a:srgbClr val="111827"/>
@@ -9140,6 +9212,7 @@
           <a:lstStyle xmlns:a="http://schemas.openxmlformats.org/drawingml/2006/main"/>
           <a:p xmlns:a="http://schemas.openxmlformats.org/drawingml/2006/main">
             <a:pPr algn="l">
+              <a:buNone/>
               <a:defRPr sz="1350" b="0">
                 <a:solidFill>
                   <a:srgbClr val="111827"/>
@@ -9237,6 +9310,7 @@
           <a:lstStyle xmlns:a="http://schemas.openxmlformats.org/drawingml/2006/main"/>
           <a:p xmlns:a="http://schemas.openxmlformats.org/drawingml/2006/main">
             <a:pPr algn="l">
+              <a:buNone/>
               <a:defRPr sz="1350" b="0">
                 <a:solidFill>
                   <a:srgbClr val="111827"/>
@@ -9301,6 +9375,7 @@
           <a:lstStyle xmlns:a="http://schemas.openxmlformats.org/drawingml/2006/main"/>
           <a:p xmlns:a="http://schemas.openxmlformats.org/drawingml/2006/main">
             <a:pPr algn="l">
+              <a:buNone/>
               <a:defRPr sz="825" b="0">
                 <a:solidFill>
                   <a:srgbClr val="64748B"/>
@@ -9365,6 +9440,7 @@
           <a:lstStyle xmlns:a="http://schemas.openxmlformats.org/drawingml/2006/main"/>
           <a:p xmlns:a="http://schemas.openxmlformats.org/drawingml/2006/main">
             <a:pPr algn="r">
+              <a:buNone/>
               <a:defRPr sz="825" b="0">
                 <a:solidFill>
                   <a:srgbClr val="64748B"/>
@@ -9521,6 +9597,7 @@
           <a:lstStyle xmlns:a="http://schemas.openxmlformats.org/drawingml/2006/main"/>
           <a:p xmlns:a="http://schemas.openxmlformats.org/drawingml/2006/main">
             <a:pPr algn="l">
+              <a:buNone/>
               <a:defRPr sz="2025" b="1">
                 <a:solidFill>
                   <a:srgbClr val="FFFFFF"/>
@@ -9585,6 +9662,7 @@
           <a:lstStyle xmlns:a="http://schemas.openxmlformats.org/drawingml/2006/main"/>
           <a:p xmlns:a="http://schemas.openxmlformats.org/drawingml/2006/main">
             <a:pPr algn="r">
+              <a:buNone/>
               <a:defRPr sz="675" b="0">
                 <a:solidFill>
                   <a:srgbClr val="CBD5E1"/>
@@ -9617,7 +9695,7 @@
           <p:nvPr/>
         </p:nvPicPr>
         <p:blipFill>
-          <a:blip xmlns:r="http://schemas.openxmlformats.org/officeDocument/2006/relationships" xmlns:a="http://schemas.openxmlformats.org/drawingml/2006/main" r:embed="R0e11069add624b86"/>
+          <a:blip xmlns:r="http://schemas.openxmlformats.org/officeDocument/2006/relationships" xmlns:a="http://schemas.openxmlformats.org/drawingml/2006/main" r:embed="R5426c2cfff944f0e"/>
           <a:stretch xmlns:a="http://schemas.openxmlformats.org/drawingml/2006/main"/>
         </p:blipFill>
         <p:spPr>
@@ -9671,6 +9749,7 @@
           <a:lstStyle xmlns:a="http://schemas.openxmlformats.org/drawingml/2006/main"/>
           <a:p xmlns:a="http://schemas.openxmlformats.org/drawingml/2006/main">
             <a:pPr algn="ctr">
+              <a:buNone/>
               <a:defRPr sz="1575" b="1">
                 <a:solidFill>
                   <a:srgbClr val="2563EB"/>
@@ -9735,6 +9814,7 @@
           <a:lstStyle xmlns:a="http://schemas.openxmlformats.org/drawingml/2006/main"/>
           <a:p xmlns:a="http://schemas.openxmlformats.org/drawingml/2006/main">
             <a:pPr algn="l">
+              <a:buNone/>
               <a:defRPr sz="825" b="0">
                 <a:solidFill>
                   <a:srgbClr val="64748B"/>
@@ -9799,6 +9879,7 @@
           <a:lstStyle xmlns:a="http://schemas.openxmlformats.org/drawingml/2006/main"/>
           <a:p xmlns:a="http://schemas.openxmlformats.org/drawingml/2006/main">
             <a:pPr algn="r">
+              <a:buNone/>
               <a:defRPr sz="825" b="0">
                 <a:solidFill>
                   <a:srgbClr val="64748B"/>
@@ -9955,6 +10036,7 @@
           <a:lstStyle xmlns:a="http://schemas.openxmlformats.org/drawingml/2006/main"/>
           <a:p xmlns:a="http://schemas.openxmlformats.org/drawingml/2006/main">
             <a:pPr algn="l">
+              <a:buNone/>
               <a:defRPr sz="2025" b="1">
                 <a:solidFill>
                   <a:srgbClr val="FFFFFF"/>
@@ -10019,6 +10101,7 @@
           <a:lstStyle xmlns:a="http://schemas.openxmlformats.org/drawingml/2006/main"/>
           <a:p xmlns:a="http://schemas.openxmlformats.org/drawingml/2006/main">
             <a:pPr algn="r">
+              <a:buNone/>
               <a:defRPr sz="675" b="0">
                 <a:solidFill>
                   <a:srgbClr val="CBD5E1"/>
@@ -10051,7 +10134,7 @@
           <p:nvPr/>
         </p:nvPicPr>
         <p:blipFill>
-          <a:blip xmlns:r="http://schemas.openxmlformats.org/officeDocument/2006/relationships" xmlns:a="http://schemas.openxmlformats.org/drawingml/2006/main" r:embed="R4d5d699519f44b49"/>
+          <a:blip xmlns:r="http://schemas.openxmlformats.org/officeDocument/2006/relationships" xmlns:a="http://schemas.openxmlformats.org/drawingml/2006/main" r:embed="Rec34830780094acd"/>
           <a:stretch xmlns:a="http://schemas.openxmlformats.org/drawingml/2006/main"/>
         </p:blipFill>
         <p:spPr>
@@ -10105,6 +10188,7 @@
           <a:lstStyle xmlns:a="http://schemas.openxmlformats.org/drawingml/2006/main"/>
           <a:p xmlns:a="http://schemas.openxmlformats.org/drawingml/2006/main">
             <a:pPr algn="ctr">
+              <a:buNone/>
               <a:defRPr sz="1650" b="1">
                 <a:solidFill>
                   <a:srgbClr val="334155"/>
@@ -10169,6 +10253,7 @@
           <a:lstStyle xmlns:a="http://schemas.openxmlformats.org/drawingml/2006/main"/>
           <a:p xmlns:a="http://schemas.openxmlformats.org/drawingml/2006/main">
             <a:pPr algn="l">
+              <a:buNone/>
               <a:defRPr sz="825" b="0">
                 <a:solidFill>
                   <a:srgbClr val="64748B"/>
@@ -10233,6 +10318,7 @@
           <a:lstStyle xmlns:a="http://schemas.openxmlformats.org/drawingml/2006/main"/>
           <a:p xmlns:a="http://schemas.openxmlformats.org/drawingml/2006/main">
             <a:pPr algn="r">
+              <a:buNone/>
               <a:defRPr sz="825" b="0">
                 <a:solidFill>
                   <a:srgbClr val="64748B"/>
@@ -10389,6 +10475,7 @@
           <a:lstStyle xmlns:a="http://schemas.openxmlformats.org/drawingml/2006/main"/>
           <a:p xmlns:a="http://schemas.openxmlformats.org/drawingml/2006/main">
             <a:pPr algn="l">
+              <a:buNone/>
               <a:defRPr sz="2025" b="1">
                 <a:solidFill>
                   <a:srgbClr val="FFFFFF"/>
@@ -10453,6 +10540,7 @@
           <a:lstStyle xmlns:a="http://schemas.openxmlformats.org/drawingml/2006/main"/>
           <a:p xmlns:a="http://schemas.openxmlformats.org/drawingml/2006/main">
             <a:pPr algn="r">
+              <a:buNone/>
               <a:defRPr sz="675" b="0">
                 <a:solidFill>
                   <a:srgbClr val="CBD5E1"/>
@@ -10550,6 +10638,7 @@
           <a:lstStyle xmlns:a="http://schemas.openxmlformats.org/drawingml/2006/main"/>
           <a:p xmlns:a="http://schemas.openxmlformats.org/drawingml/2006/main">
             <a:pPr algn="l">
+              <a:buNone/>
               <a:defRPr sz="975" b="1">
                 <a:solidFill>
                   <a:srgbClr val="334155"/>
@@ -10647,6 +10736,7 @@
           <a:lstStyle xmlns:a="http://schemas.openxmlformats.org/drawingml/2006/main"/>
           <a:p xmlns:a="http://schemas.openxmlformats.org/drawingml/2006/main">
             <a:pPr algn="l">
+              <a:buNone/>
               <a:defRPr sz="975" b="1">
                 <a:solidFill>
                   <a:srgbClr val="334155"/>
@@ -10744,6 +10834,7 @@
           <a:lstStyle xmlns:a="http://schemas.openxmlformats.org/drawingml/2006/main"/>
           <a:p xmlns:a="http://schemas.openxmlformats.org/drawingml/2006/main">
             <a:pPr algn="l">
+              <a:buNone/>
               <a:defRPr sz="975" b="0">
                 <a:solidFill>
                   <a:srgbClr val="111827"/>
@@ -10841,6 +10932,7 @@
           <a:lstStyle xmlns:a="http://schemas.openxmlformats.org/drawingml/2006/main"/>
           <a:p xmlns:a="http://schemas.openxmlformats.org/drawingml/2006/main">
             <a:pPr algn="r">
+              <a:buNone/>
               <a:defRPr sz="975" b="0">
                 <a:solidFill>
                   <a:srgbClr val="111827"/>
@@ -10938,6 +11030,7 @@
           <a:lstStyle xmlns:a="http://schemas.openxmlformats.org/drawingml/2006/main"/>
           <a:p xmlns:a="http://schemas.openxmlformats.org/drawingml/2006/main">
             <a:pPr algn="l">
+              <a:buNone/>
               <a:defRPr sz="975" b="0">
                 <a:solidFill>
                   <a:srgbClr val="111827"/>
@@ -11035,6 +11128,7 @@
           <a:lstStyle xmlns:a="http://schemas.openxmlformats.org/drawingml/2006/main"/>
           <a:p xmlns:a="http://schemas.openxmlformats.org/drawingml/2006/main">
             <a:pPr algn="r">
+              <a:buNone/>
               <a:defRPr sz="975" b="0">
                 <a:solidFill>
                   <a:srgbClr val="111827"/>
@@ -11132,6 +11226,7 @@
           <a:lstStyle xmlns:a="http://schemas.openxmlformats.org/drawingml/2006/main"/>
           <a:p xmlns:a="http://schemas.openxmlformats.org/drawingml/2006/main">
             <a:pPr algn="l">
+              <a:buNone/>
               <a:defRPr sz="975" b="0">
                 <a:solidFill>
                   <a:srgbClr val="111827"/>
@@ -11229,6 +11324,7 @@
           <a:lstStyle xmlns:a="http://schemas.openxmlformats.org/drawingml/2006/main"/>
           <a:p xmlns:a="http://schemas.openxmlformats.org/drawingml/2006/main">
             <a:pPr algn="r">
+              <a:buNone/>
               <a:defRPr sz="975" b="0">
                 <a:solidFill>
                   <a:srgbClr val="111827"/>
@@ -11326,6 +11422,7 @@
           <a:lstStyle xmlns:a="http://schemas.openxmlformats.org/drawingml/2006/main"/>
           <a:p xmlns:a="http://schemas.openxmlformats.org/drawingml/2006/main">
             <a:pPr algn="l">
+              <a:buNone/>
               <a:defRPr sz="975" b="0">
                 <a:solidFill>
                   <a:srgbClr val="111827"/>
@@ -11423,6 +11520,7 @@
           <a:lstStyle xmlns:a="http://schemas.openxmlformats.org/drawingml/2006/main"/>
           <a:p xmlns:a="http://schemas.openxmlformats.org/drawingml/2006/main">
             <a:pPr algn="r">
+              <a:buNone/>
               <a:defRPr sz="975" b="0">
                 <a:solidFill>
                   <a:srgbClr val="111827"/>
@@ -11520,6 +11618,7 @@
           <a:lstStyle xmlns:a="http://schemas.openxmlformats.org/drawingml/2006/main"/>
           <a:p xmlns:a="http://schemas.openxmlformats.org/drawingml/2006/main">
             <a:pPr algn="l">
+              <a:buNone/>
               <a:defRPr sz="975" b="0">
                 <a:solidFill>
                   <a:srgbClr val="111827"/>
@@ -11617,6 +11716,7 @@
           <a:lstStyle xmlns:a="http://schemas.openxmlformats.org/drawingml/2006/main"/>
           <a:p xmlns:a="http://schemas.openxmlformats.org/drawingml/2006/main">
             <a:pPr algn="r">
+              <a:buNone/>
               <a:defRPr sz="975" b="0">
                 <a:solidFill>
                   <a:srgbClr val="111827"/>
@@ -11714,6 +11814,7 @@
           <a:lstStyle xmlns:a="http://schemas.openxmlformats.org/drawingml/2006/main"/>
           <a:p xmlns:a="http://schemas.openxmlformats.org/drawingml/2006/main">
             <a:pPr algn="l">
+              <a:buNone/>
               <a:defRPr sz="975" b="0">
                 <a:solidFill>
                   <a:srgbClr val="111827"/>
@@ -11811,6 +11912,7 @@
           <a:lstStyle xmlns:a="http://schemas.openxmlformats.org/drawingml/2006/main"/>
           <a:p xmlns:a="http://schemas.openxmlformats.org/drawingml/2006/main">
             <a:pPr algn="r">
+              <a:buNone/>
               <a:defRPr sz="975" b="0">
                 <a:solidFill>
                   <a:srgbClr val="111827"/>
@@ -11875,6 +11977,7 @@
           <a:lstStyle xmlns:a="http://schemas.openxmlformats.org/drawingml/2006/main"/>
           <a:p xmlns:a="http://schemas.openxmlformats.org/drawingml/2006/main">
             <a:pPr algn="l">
+              <a:buNone/>
               <a:defRPr sz="1350" b="1">
                 <a:solidFill>
                   <a:srgbClr val="DC2626"/>
@@ -11939,6 +12042,7 @@
           <a:lstStyle xmlns:a="http://schemas.openxmlformats.org/drawingml/2006/main"/>
           <a:p xmlns:a="http://schemas.openxmlformats.org/drawingml/2006/main">
             <a:pPr algn="l">
+              <a:buNone/>
               <a:defRPr sz="825" b="0">
                 <a:solidFill>
                   <a:srgbClr val="64748B"/>
@@ -12003,6 +12107,7 @@
           <a:lstStyle xmlns:a="http://schemas.openxmlformats.org/drawingml/2006/main"/>
           <a:p xmlns:a="http://schemas.openxmlformats.org/drawingml/2006/main">
             <a:pPr algn="r">
+              <a:buNone/>
               <a:defRPr sz="825" b="0">
                 <a:solidFill>
                   <a:srgbClr val="64748B"/>
@@ -12159,6 +12264,7 @@
           <a:lstStyle xmlns:a="http://schemas.openxmlformats.org/drawingml/2006/main"/>
           <a:p xmlns:a="http://schemas.openxmlformats.org/drawingml/2006/main">
             <a:pPr algn="l">
+              <a:buNone/>
               <a:defRPr sz="2025" b="1">
                 <a:solidFill>
                   <a:srgbClr val="FFFFFF"/>
@@ -12223,6 +12329,7 @@
           <a:lstStyle xmlns:a="http://schemas.openxmlformats.org/drawingml/2006/main"/>
           <a:p xmlns:a="http://schemas.openxmlformats.org/drawingml/2006/main">
             <a:pPr algn="r">
+              <a:buNone/>
               <a:defRPr sz="675" b="0">
                 <a:solidFill>
                   <a:srgbClr val="CBD5E1"/>
@@ -12287,6 +12394,7 @@
           <a:lstStyle xmlns:a="http://schemas.openxmlformats.org/drawingml/2006/main"/>
           <a:p xmlns:a="http://schemas.openxmlformats.org/drawingml/2006/main">
             <a:pPr algn="l">
+              <a:buNone/>
               <a:defRPr sz="1125" b="1">
                 <a:solidFill>
                   <a:srgbClr val="111827"/>
@@ -12417,6 +12525,7 @@
           <a:lstStyle xmlns:a="http://schemas.openxmlformats.org/drawingml/2006/main"/>
           <a:p xmlns:a="http://schemas.openxmlformats.org/drawingml/2006/main">
             <a:pPr algn="r">
+              <a:buNone/>
               <a:defRPr sz="1125" b="1">
                 <a:solidFill>
                   <a:srgbClr val="111827"/>
@@ -12481,6 +12590,7 @@
           <a:lstStyle xmlns:a="http://schemas.openxmlformats.org/drawingml/2006/main"/>
           <a:p xmlns:a="http://schemas.openxmlformats.org/drawingml/2006/main">
             <a:pPr algn="l">
+              <a:buNone/>
               <a:defRPr sz="1125" b="1">
                 <a:solidFill>
                   <a:srgbClr val="111827"/>
@@ -12611,6 +12721,7 @@
           <a:lstStyle xmlns:a="http://schemas.openxmlformats.org/drawingml/2006/main"/>
           <a:p xmlns:a="http://schemas.openxmlformats.org/drawingml/2006/main">
             <a:pPr algn="r">
+              <a:buNone/>
               <a:defRPr sz="1125" b="1">
                 <a:solidFill>
                   <a:srgbClr val="111827"/>
@@ -12675,6 +12786,7 @@
           <a:lstStyle xmlns:a="http://schemas.openxmlformats.org/drawingml/2006/main"/>
           <a:p xmlns:a="http://schemas.openxmlformats.org/drawingml/2006/main">
             <a:pPr algn="l">
+              <a:buNone/>
               <a:defRPr sz="1125" b="1">
                 <a:solidFill>
                   <a:srgbClr val="111827"/>
@@ -12805,6 +12917,7 @@
           <a:lstStyle xmlns:a="http://schemas.openxmlformats.org/drawingml/2006/main"/>
           <a:p xmlns:a="http://schemas.openxmlformats.org/drawingml/2006/main">
             <a:pPr algn="r">
+              <a:buNone/>
               <a:defRPr sz="1125" b="1">
                 <a:solidFill>
                   <a:srgbClr val="111827"/>
@@ -12869,6 +12982,7 @@
           <a:lstStyle xmlns:a="http://schemas.openxmlformats.org/drawingml/2006/main"/>
           <a:p xmlns:a="http://schemas.openxmlformats.org/drawingml/2006/main">
             <a:pPr algn="l">
+              <a:buNone/>
               <a:defRPr sz="1125" b="1">
                 <a:solidFill>
                   <a:srgbClr val="111827"/>
@@ -12999,6 +13113,7 @@
           <a:lstStyle xmlns:a="http://schemas.openxmlformats.org/drawingml/2006/main"/>
           <a:p xmlns:a="http://schemas.openxmlformats.org/drawingml/2006/main">
             <a:pPr algn="r">
+              <a:buNone/>
               <a:defRPr sz="1125" b="1">
                 <a:solidFill>
                   <a:srgbClr val="111827"/>
@@ -13063,6 +13178,7 @@
           <a:lstStyle xmlns:a="http://schemas.openxmlformats.org/drawingml/2006/main"/>
           <a:p xmlns:a="http://schemas.openxmlformats.org/drawingml/2006/main">
             <a:pPr algn="l">
+              <a:buNone/>
               <a:defRPr sz="1125" b="1">
                 <a:solidFill>
                   <a:srgbClr val="111827"/>
@@ -13193,6 +13309,7 @@
           <a:lstStyle xmlns:a="http://schemas.openxmlformats.org/drawingml/2006/main"/>
           <a:p xmlns:a="http://schemas.openxmlformats.org/drawingml/2006/main">
             <a:pPr algn="r">
+              <a:buNone/>
               <a:defRPr sz="1125" b="1">
                 <a:solidFill>
                   <a:srgbClr val="111827"/>
@@ -13257,6 +13374,7 @@
           <a:lstStyle xmlns:a="http://schemas.openxmlformats.org/drawingml/2006/main"/>
           <a:p xmlns:a="http://schemas.openxmlformats.org/drawingml/2006/main">
             <a:pPr algn="l">
+              <a:buNone/>
               <a:defRPr sz="1125" b="1">
                 <a:solidFill>
                   <a:srgbClr val="111827"/>
@@ -13387,6 +13505,7 @@
           <a:lstStyle xmlns:a="http://schemas.openxmlformats.org/drawingml/2006/main"/>
           <a:p xmlns:a="http://schemas.openxmlformats.org/drawingml/2006/main">
             <a:pPr algn="r">
+              <a:buNone/>
               <a:defRPr sz="1125" b="1">
                 <a:solidFill>
                   <a:srgbClr val="111827"/>
@@ -13451,6 +13570,7 @@
           <a:lstStyle xmlns:a="http://schemas.openxmlformats.org/drawingml/2006/main"/>
           <a:p xmlns:a="http://schemas.openxmlformats.org/drawingml/2006/main">
             <a:pPr algn="l">
+              <a:buNone/>
               <a:defRPr sz="1125" b="1">
                 <a:solidFill>
                   <a:srgbClr val="111827"/>
@@ -13581,6 +13701,7 @@
           <a:lstStyle xmlns:a="http://schemas.openxmlformats.org/drawingml/2006/main"/>
           <a:p xmlns:a="http://schemas.openxmlformats.org/drawingml/2006/main">
             <a:pPr algn="r">
+              <a:buNone/>
               <a:defRPr sz="1125" b="1">
                 <a:solidFill>
                   <a:srgbClr val="111827"/>
@@ -13645,6 +13766,7 @@
           <a:lstStyle xmlns:a="http://schemas.openxmlformats.org/drawingml/2006/main"/>
           <a:p xmlns:a="http://schemas.openxmlformats.org/drawingml/2006/main">
             <a:pPr algn="l">
+              <a:buNone/>
               <a:defRPr sz="1125" b="1">
                 <a:solidFill>
                   <a:srgbClr val="111827"/>
@@ -13775,6 +13897,7 @@
           <a:lstStyle xmlns:a="http://schemas.openxmlformats.org/drawingml/2006/main"/>
           <a:p xmlns:a="http://schemas.openxmlformats.org/drawingml/2006/main">
             <a:pPr algn="r">
+              <a:buNone/>
               <a:defRPr sz="1125" b="1">
                 <a:solidFill>
                   <a:srgbClr val="111827"/>
@@ -13839,6 +13962,7 @@
           <a:lstStyle xmlns:a="http://schemas.openxmlformats.org/drawingml/2006/main"/>
           <a:p xmlns:a="http://schemas.openxmlformats.org/drawingml/2006/main">
             <a:pPr algn="l">
+              <a:buNone/>
               <a:defRPr sz="1125" b="1">
                 <a:solidFill>
                   <a:srgbClr val="111827"/>
@@ -13969,6 +14093,7 @@
           <a:lstStyle xmlns:a="http://schemas.openxmlformats.org/drawingml/2006/main"/>
           <a:p xmlns:a="http://schemas.openxmlformats.org/drawingml/2006/main">
             <a:pPr algn="r">
+              <a:buNone/>
               <a:defRPr sz="1125" b="1">
                 <a:solidFill>
                   <a:srgbClr val="111827"/>
@@ -14033,6 +14158,7 @@
           <a:lstStyle xmlns:a="http://schemas.openxmlformats.org/drawingml/2006/main"/>
           <a:p xmlns:a="http://schemas.openxmlformats.org/drawingml/2006/main">
             <a:pPr algn="l">
+              <a:buNone/>
               <a:defRPr sz="1650" b="1">
                 <a:solidFill>
                   <a:srgbClr val="111827"/>
@@ -14097,6 +14223,7 @@
           <a:lstStyle xmlns:a="http://schemas.openxmlformats.org/drawingml/2006/main"/>
           <a:p xmlns:a="http://schemas.openxmlformats.org/drawingml/2006/main">
             <a:pPr algn="l">
+              <a:buNone/>
               <a:defRPr sz="825" b="0">
                 <a:solidFill>
                   <a:srgbClr val="64748B"/>
@@ -14161,6 +14288,7 @@
           <a:lstStyle xmlns:a="http://schemas.openxmlformats.org/drawingml/2006/main"/>
           <a:p xmlns:a="http://schemas.openxmlformats.org/drawingml/2006/main">
             <a:pPr algn="r">
+              <a:buNone/>
               <a:defRPr sz="825" b="0">
                 <a:solidFill>
                   <a:srgbClr val="64748B"/>
@@ -14317,6 +14445,7 @@
           <a:lstStyle xmlns:a="http://schemas.openxmlformats.org/drawingml/2006/main"/>
           <a:p xmlns:a="http://schemas.openxmlformats.org/drawingml/2006/main">
             <a:pPr algn="l">
+              <a:buNone/>
               <a:defRPr sz="2025" b="1">
                 <a:solidFill>
                   <a:srgbClr val="FFFFFF"/>
@@ -14381,6 +14510,7 @@
           <a:lstStyle xmlns:a="http://schemas.openxmlformats.org/drawingml/2006/main"/>
           <a:p xmlns:a="http://schemas.openxmlformats.org/drawingml/2006/main">
             <a:pPr algn="r">
+              <a:buNone/>
               <a:defRPr sz="675" b="0">
                 <a:solidFill>
                   <a:srgbClr val="CBD5E1"/>
@@ -14513,6 +14643,7 @@
           <a:lstStyle xmlns:a="http://schemas.openxmlformats.org/drawingml/2006/main"/>
           <a:p xmlns:a="http://schemas.openxmlformats.org/drawingml/2006/main">
             <a:pPr algn="l">
+              <a:buNone/>
               <a:defRPr sz="975" b="1">
                 <a:solidFill>
                   <a:srgbClr val="5B6472"/>
@@ -14577,6 +14708,7 @@
           <a:lstStyle xmlns:a="http://schemas.openxmlformats.org/drawingml/2006/main"/>
           <a:p xmlns:a="http://schemas.openxmlformats.org/drawingml/2006/main">
             <a:pPr algn="l">
+              <a:buNone/>
               <a:defRPr sz="1725" b="1">
                 <a:solidFill>
                   <a:srgbClr val="111827"/>
@@ -14709,6 +14841,7 @@
           <a:lstStyle xmlns:a="http://schemas.openxmlformats.org/drawingml/2006/main"/>
           <a:p xmlns:a="http://schemas.openxmlformats.org/drawingml/2006/main">
             <a:pPr algn="l">
+              <a:buNone/>
               <a:defRPr sz="975" b="1">
                 <a:solidFill>
                   <a:srgbClr val="5B6472"/>
@@ -14773,6 +14906,7 @@
           <a:lstStyle xmlns:a="http://schemas.openxmlformats.org/drawingml/2006/main"/>
           <a:p xmlns:a="http://schemas.openxmlformats.org/drawingml/2006/main">
             <a:pPr algn="l">
+              <a:buNone/>
               <a:defRPr sz="1725" b="1">
                 <a:solidFill>
                   <a:srgbClr val="111827"/>
@@ -14905,6 +15039,7 @@
           <a:lstStyle xmlns:a="http://schemas.openxmlformats.org/drawingml/2006/main"/>
           <a:p xmlns:a="http://schemas.openxmlformats.org/drawingml/2006/main">
             <a:pPr algn="l">
+              <a:buNone/>
               <a:defRPr sz="975" b="1">
                 <a:solidFill>
                   <a:srgbClr val="5B6472"/>
@@ -14969,6 +15104,7 @@
           <a:lstStyle xmlns:a="http://schemas.openxmlformats.org/drawingml/2006/main"/>
           <a:p xmlns:a="http://schemas.openxmlformats.org/drawingml/2006/main">
             <a:pPr algn="l">
+              <a:buNone/>
               <a:defRPr sz="1725" b="1">
                 <a:solidFill>
                   <a:srgbClr val="111827"/>
@@ -15101,6 +15237,7 @@
           <a:lstStyle xmlns:a="http://schemas.openxmlformats.org/drawingml/2006/main"/>
           <a:p xmlns:a="http://schemas.openxmlformats.org/drawingml/2006/main">
             <a:pPr algn="l">
+              <a:buNone/>
               <a:defRPr sz="975" b="1">
                 <a:solidFill>
                   <a:srgbClr val="5B6472"/>
@@ -15165,6 +15302,7 @@
           <a:lstStyle xmlns:a="http://schemas.openxmlformats.org/drawingml/2006/main"/>
           <a:p xmlns:a="http://schemas.openxmlformats.org/drawingml/2006/main">
             <a:pPr algn="l">
+              <a:buNone/>
               <a:defRPr sz="1725" b="1">
                 <a:solidFill>
                   <a:srgbClr val="111827"/>
@@ -15229,6 +15367,7 @@
           <a:lstStyle xmlns:a="http://schemas.openxmlformats.org/drawingml/2006/main"/>
           <a:p xmlns:a="http://schemas.openxmlformats.org/drawingml/2006/main">
             <a:pPr algn="l">
+              <a:buNone/>
               <a:defRPr sz="1800" b="1">
                 <a:solidFill>
                   <a:srgbClr val="111827"/>
@@ -15326,6 +15465,7 @@
           <a:lstStyle xmlns:a="http://schemas.openxmlformats.org/drawingml/2006/main"/>
           <a:p xmlns:a="http://schemas.openxmlformats.org/drawingml/2006/main">
             <a:pPr algn="l">
+              <a:buNone/>
               <a:defRPr sz="975" b="1">
                 <a:solidFill>
                   <a:srgbClr val="334155"/>
@@ -15423,6 +15563,7 @@
           <a:lstStyle xmlns:a="http://schemas.openxmlformats.org/drawingml/2006/main"/>
           <a:p xmlns:a="http://schemas.openxmlformats.org/drawingml/2006/main">
             <a:pPr algn="l">
+              <a:buNone/>
               <a:defRPr sz="975" b="1">
                 <a:solidFill>
                   <a:srgbClr val="334155"/>
@@ -15520,6 +15661,7 @@
           <a:lstStyle xmlns:a="http://schemas.openxmlformats.org/drawingml/2006/main"/>
           <a:p xmlns:a="http://schemas.openxmlformats.org/drawingml/2006/main">
             <a:pPr algn="l">
+              <a:buNone/>
               <a:defRPr sz="975" b="1">
                 <a:solidFill>
                   <a:srgbClr val="334155"/>
@@ -15617,6 +15759,7 @@
           <a:lstStyle xmlns:a="http://schemas.openxmlformats.org/drawingml/2006/main"/>
           <a:p xmlns:a="http://schemas.openxmlformats.org/drawingml/2006/main">
             <a:pPr algn="l">
+              <a:buNone/>
               <a:defRPr sz="975" b="0">
                 <a:solidFill>
                   <a:srgbClr val="111827"/>
@@ -15714,6 +15857,7 @@
           <a:lstStyle xmlns:a="http://schemas.openxmlformats.org/drawingml/2006/main"/>
           <a:p xmlns:a="http://schemas.openxmlformats.org/drawingml/2006/main">
             <a:pPr algn="r">
+              <a:buNone/>
               <a:defRPr sz="975" b="0">
                 <a:solidFill>
                   <a:srgbClr val="111827"/>
@@ -15811,6 +15955,7 @@
           <a:lstStyle xmlns:a="http://schemas.openxmlformats.org/drawingml/2006/main"/>
           <a:p xmlns:a="http://schemas.openxmlformats.org/drawingml/2006/main">
             <a:pPr algn="r">
+              <a:buNone/>
               <a:defRPr sz="975" b="0">
                 <a:solidFill>
                   <a:srgbClr val="111827"/>
@@ -15908,6 +16053,7 @@
           <a:lstStyle xmlns:a="http://schemas.openxmlformats.org/drawingml/2006/main"/>
           <a:p xmlns:a="http://schemas.openxmlformats.org/drawingml/2006/main">
             <a:pPr algn="l">
+              <a:buNone/>
               <a:defRPr sz="975" b="0">
                 <a:solidFill>
                   <a:srgbClr val="111827"/>
@@ -16005,6 +16151,7 @@
           <a:lstStyle xmlns:a="http://schemas.openxmlformats.org/drawingml/2006/main"/>
           <a:p xmlns:a="http://schemas.openxmlformats.org/drawingml/2006/main">
             <a:pPr algn="r">
+              <a:buNone/>
               <a:defRPr sz="975" b="0">
                 <a:solidFill>
                   <a:srgbClr val="111827"/>
@@ -16102,6 +16249,7 @@
           <a:lstStyle xmlns:a="http://schemas.openxmlformats.org/drawingml/2006/main"/>
           <a:p xmlns:a="http://schemas.openxmlformats.org/drawingml/2006/main">
             <a:pPr algn="r">
+              <a:buNone/>
               <a:defRPr sz="975" b="0">
                 <a:solidFill>
                   <a:srgbClr val="111827"/>
@@ -16166,6 +16314,7 @@
           <a:lstStyle xmlns:a="http://schemas.openxmlformats.org/drawingml/2006/main"/>
           <a:p xmlns:a="http://schemas.openxmlformats.org/drawingml/2006/main">
             <a:pPr algn="l">
+              <a:buNone/>
               <a:defRPr sz="1875" b="1">
                 <a:solidFill>
                   <a:srgbClr val="334155"/>
@@ -16230,6 +16379,7 @@
           <a:lstStyle xmlns:a="http://schemas.openxmlformats.org/drawingml/2006/main"/>
           <a:p xmlns:a="http://schemas.openxmlformats.org/drawingml/2006/main">
             <a:pPr algn="l">
+              <a:buNone/>
               <a:defRPr sz="825" b="0">
                 <a:solidFill>
                   <a:srgbClr val="64748B"/>
@@ -16294,6 +16444,7 @@
           <a:lstStyle xmlns:a="http://schemas.openxmlformats.org/drawingml/2006/main"/>
           <a:p xmlns:a="http://schemas.openxmlformats.org/drawingml/2006/main">
             <a:pPr algn="r">
+              <a:buNone/>
               <a:defRPr sz="825" b="0">
                 <a:solidFill>
                   <a:srgbClr val="64748B"/>
@@ -16450,6 +16601,7 @@
           <a:lstStyle xmlns:a="http://schemas.openxmlformats.org/drawingml/2006/main"/>
           <a:p xmlns:a="http://schemas.openxmlformats.org/drawingml/2006/main">
             <a:pPr algn="l">
+              <a:buNone/>
               <a:defRPr sz="2025" b="1">
                 <a:solidFill>
                   <a:srgbClr val="FFFFFF"/>
@@ -16514,6 +16666,7 @@
           <a:lstStyle xmlns:a="http://schemas.openxmlformats.org/drawingml/2006/main"/>
           <a:p xmlns:a="http://schemas.openxmlformats.org/drawingml/2006/main">
             <a:pPr algn="r">
+              <a:buNone/>
               <a:defRPr sz="675" b="0">
                 <a:solidFill>
                   <a:srgbClr val="CBD5E1"/>
@@ -16611,6 +16764,7 @@
           <a:lstStyle xmlns:a="http://schemas.openxmlformats.org/drawingml/2006/main"/>
           <a:p xmlns:a="http://schemas.openxmlformats.org/drawingml/2006/main">
             <a:pPr algn="l">
+              <a:buNone/>
               <a:defRPr sz="975" b="1">
                 <a:solidFill>
                   <a:srgbClr val="334155"/>
@@ -16708,6 +16862,7 @@
           <a:lstStyle xmlns:a="http://schemas.openxmlformats.org/drawingml/2006/main"/>
           <a:p xmlns:a="http://schemas.openxmlformats.org/drawingml/2006/main">
             <a:pPr algn="l">
+              <a:buNone/>
               <a:defRPr sz="975" b="1">
                 <a:solidFill>
                   <a:srgbClr val="334155"/>
@@ -16805,6 +16960,7 @@
           <a:lstStyle xmlns:a="http://schemas.openxmlformats.org/drawingml/2006/main"/>
           <a:p xmlns:a="http://schemas.openxmlformats.org/drawingml/2006/main">
             <a:pPr algn="l">
+              <a:buNone/>
               <a:defRPr sz="975" b="1">
                 <a:solidFill>
                   <a:srgbClr val="334155"/>
@@ -16902,6 +17058,7 @@
           <a:lstStyle xmlns:a="http://schemas.openxmlformats.org/drawingml/2006/main"/>
           <a:p xmlns:a="http://schemas.openxmlformats.org/drawingml/2006/main">
             <a:pPr algn="l">
+              <a:buNone/>
               <a:defRPr sz="975" b="1">
                 <a:solidFill>
                   <a:srgbClr val="334155"/>
@@ -16999,6 +17156,7 @@
           <a:lstStyle xmlns:a="http://schemas.openxmlformats.org/drawingml/2006/main"/>
           <a:p xmlns:a="http://schemas.openxmlformats.org/drawingml/2006/main">
             <a:pPr algn="l">
+              <a:buNone/>
               <a:defRPr sz="975" b="0">
                 <a:solidFill>
                   <a:srgbClr val="111827"/>
@@ -17096,6 +17254,7 @@
           <a:lstStyle xmlns:a="http://schemas.openxmlformats.org/drawingml/2006/main"/>
           <a:p xmlns:a="http://schemas.openxmlformats.org/drawingml/2006/main">
             <a:pPr algn="r">
+              <a:buNone/>
               <a:defRPr sz="975" b="0">
                 <a:solidFill>
                   <a:srgbClr val="111827"/>
@@ -17193,6 +17352,7 @@
           <a:lstStyle xmlns:a="http://schemas.openxmlformats.org/drawingml/2006/main"/>
           <a:p xmlns:a="http://schemas.openxmlformats.org/drawingml/2006/main">
             <a:pPr algn="r">
+              <a:buNone/>
               <a:defRPr sz="975" b="0">
                 <a:solidFill>
                   <a:srgbClr val="111827"/>
@@ -17290,6 +17450,7 @@
           <a:lstStyle xmlns:a="http://schemas.openxmlformats.org/drawingml/2006/main"/>
           <a:p xmlns:a="http://schemas.openxmlformats.org/drawingml/2006/main">
             <a:pPr algn="r">
+              <a:buNone/>
               <a:defRPr sz="975" b="0">
                 <a:solidFill>
                   <a:srgbClr val="111827"/>
@@ -17387,6 +17548,7 @@
           <a:lstStyle xmlns:a="http://schemas.openxmlformats.org/drawingml/2006/main"/>
           <a:p xmlns:a="http://schemas.openxmlformats.org/drawingml/2006/main">
             <a:pPr algn="l">
+              <a:buNone/>
               <a:defRPr sz="975" b="0">
                 <a:solidFill>
                   <a:srgbClr val="111827"/>
@@ -17484,6 +17646,7 @@
           <a:lstStyle xmlns:a="http://schemas.openxmlformats.org/drawingml/2006/main"/>
           <a:p xmlns:a="http://schemas.openxmlformats.org/drawingml/2006/main">
             <a:pPr algn="r">
+              <a:buNone/>
               <a:defRPr sz="975" b="0">
                 <a:solidFill>
                   <a:srgbClr val="111827"/>
@@ -17581,6 +17744,7 @@
           <a:lstStyle xmlns:a="http://schemas.openxmlformats.org/drawingml/2006/main"/>
           <a:p xmlns:a="http://schemas.openxmlformats.org/drawingml/2006/main">
             <a:pPr algn="r">
+              <a:buNone/>
               <a:defRPr sz="975" b="0">
                 <a:solidFill>
                   <a:srgbClr val="111827"/>
@@ -17678,6 +17842,7 @@
           <a:lstStyle xmlns:a="http://schemas.openxmlformats.org/drawingml/2006/main"/>
           <a:p xmlns:a="http://schemas.openxmlformats.org/drawingml/2006/main">
             <a:pPr algn="r">
+              <a:buNone/>
               <a:defRPr sz="975" b="0">
                 <a:solidFill>
                   <a:srgbClr val="111827"/>
@@ -17775,6 +17940,7 @@
           <a:lstStyle xmlns:a="http://schemas.openxmlformats.org/drawingml/2006/main"/>
           <a:p xmlns:a="http://schemas.openxmlformats.org/drawingml/2006/main">
             <a:pPr algn="l">
+              <a:buNone/>
               <a:defRPr sz="975" b="0">
                 <a:solidFill>
                   <a:srgbClr val="111827"/>
@@ -17872,6 +18038,7 @@
           <a:lstStyle xmlns:a="http://schemas.openxmlformats.org/drawingml/2006/main"/>
           <a:p xmlns:a="http://schemas.openxmlformats.org/drawingml/2006/main">
             <a:pPr algn="r">
+              <a:buNone/>
               <a:defRPr sz="975" b="0">
                 <a:solidFill>
                   <a:srgbClr val="111827"/>
@@ -17969,6 +18136,7 @@
           <a:lstStyle xmlns:a="http://schemas.openxmlformats.org/drawingml/2006/main"/>
           <a:p xmlns:a="http://schemas.openxmlformats.org/drawingml/2006/main">
             <a:pPr algn="r">
+              <a:buNone/>
               <a:defRPr sz="975" b="0">
                 <a:solidFill>
                   <a:srgbClr val="111827"/>
@@ -18066,6 +18234,7 @@
           <a:lstStyle xmlns:a="http://schemas.openxmlformats.org/drawingml/2006/main"/>
           <a:p xmlns:a="http://schemas.openxmlformats.org/drawingml/2006/main">
             <a:pPr algn="r">
+              <a:buNone/>
               <a:defRPr sz="975" b="0">
                 <a:solidFill>
                   <a:srgbClr val="111827"/>
@@ -18163,6 +18332,7 @@
           <a:lstStyle xmlns:a="http://schemas.openxmlformats.org/drawingml/2006/main"/>
           <a:p xmlns:a="http://schemas.openxmlformats.org/drawingml/2006/main">
             <a:pPr algn="l">
+              <a:buNone/>
               <a:defRPr sz="1350" b="0">
                 <a:solidFill>
                   <a:srgbClr val="111827"/>
@@ -18260,6 +18430,7 @@
           <a:lstStyle xmlns:a="http://schemas.openxmlformats.org/drawingml/2006/main"/>
           <a:p xmlns:a="http://schemas.openxmlformats.org/drawingml/2006/main">
             <a:pPr algn="l">
+              <a:buNone/>
               <a:defRPr sz="1350" b="0">
                 <a:solidFill>
                   <a:srgbClr val="111827"/>
@@ -18357,6 +18528,7 @@
           <a:lstStyle xmlns:a="http://schemas.openxmlformats.org/drawingml/2006/main"/>
           <a:p xmlns:a="http://schemas.openxmlformats.org/drawingml/2006/main">
             <a:pPr algn="l">
+              <a:buNone/>
               <a:defRPr sz="1350" b="0">
                 <a:solidFill>
                   <a:srgbClr val="111827"/>
@@ -18421,6 +18593,7 @@
           <a:lstStyle xmlns:a="http://schemas.openxmlformats.org/drawingml/2006/main"/>
           <a:p xmlns:a="http://schemas.openxmlformats.org/drawingml/2006/main">
             <a:pPr algn="l">
+              <a:buNone/>
               <a:defRPr sz="1650" b="1">
                 <a:solidFill>
                   <a:srgbClr val="DC2626"/>
@@ -18485,6 +18658,7 @@
           <a:lstStyle xmlns:a="http://schemas.openxmlformats.org/drawingml/2006/main"/>
           <a:p xmlns:a="http://schemas.openxmlformats.org/drawingml/2006/main">
             <a:pPr algn="l">
+              <a:buNone/>
               <a:defRPr sz="825" b="0">
                 <a:solidFill>
                   <a:srgbClr val="64748B"/>
@@ -18549,6 +18723,7 @@
           <a:lstStyle xmlns:a="http://schemas.openxmlformats.org/drawingml/2006/main"/>
           <a:p xmlns:a="http://schemas.openxmlformats.org/drawingml/2006/main">
             <a:pPr algn="r">
+              <a:buNone/>
               <a:defRPr sz="825" b="0">
                 <a:solidFill>
                   <a:srgbClr val="64748B"/>

</xml_diff>